<commit_message>
Enhanced PPT with bar charts, confusion matrix heatmap, feature importance chart, and app screenshots
</commit_message>
<xml_diff>
--- a/CardioPredict_Presentation.pptx
+++ b/CardioPredict_Presentation.pptx
@@ -4045,7 +4045,7 @@
                         </a:defRPr>
                       </a:pPr>
                       <a:r>
-                        <a:t>scikit-learn, pandas, numpy</a:t>
+                        <a:t>scikit-learn, pandas, NumPy</a:t>
                       </a:r>
                     </a:p>
                   </a:txBody>
@@ -4918,7 +4918,7 @@
             </a:r>
             <a:br/>
             <a:r>
-              <a:t>localStorage preferences</a:t>
+              <a:t>localStorage prefs</a:t>
             </a:r>
           </a:p>
         </p:txBody>
@@ -5234,11 +5234,11 @@
               </a:defRPr>
             </a:pPr>
             <a:r>
-              <a:t>StandardScaler transform</a:t>
+              <a:t>StandardScaler</a:t>
             </a:r>
             <a:br/>
             <a:r>
-              <a:t>Random Forest inference</a:t>
+              <a:t>Random Forest</a:t>
             </a:r>
             <a:br/>
             <a:r>
@@ -5527,7 +5527,7 @@
               <a:spcBef>
                 <a:spcPts val="400"/>
               </a:spcBef>
-              <a:defRPr sz="1200" b="0" i="0">
+              <a:defRPr sz="1200" b="0">
                 <a:solidFill>
                   <a:srgbClr val="1A1A1A"/>
                 </a:solidFill>
@@ -5543,7 +5543,7 @@
               <a:spcBef>
                 <a:spcPts val="400"/>
               </a:spcBef>
-              <a:defRPr sz="1200" b="0" i="0">
+              <a:defRPr sz="1200" b="0">
                 <a:solidFill>
                   <a:srgbClr val="1A1A1A"/>
                 </a:solidFill>
@@ -5559,7 +5559,7 @@
               <a:spcBef>
                 <a:spcPts val="400"/>
               </a:spcBef>
-              <a:defRPr sz="1200" b="0" i="0">
+              <a:defRPr sz="1200" b="0">
                 <a:solidFill>
                   <a:srgbClr val="1A1A1A"/>
                 </a:solidFill>
@@ -5734,8 +5734,8 @@
         </p:nvSpPr>
         <p:spPr>
           <a:xfrm>
-            <a:off x="914400" y="1828800"/>
-            <a:ext cx="10332720" cy="640080"/>
+            <a:off x="731520" y="457200"/>
+            <a:ext cx="4572000" cy="457200"/>
           </a:xfrm>
           <a:prstGeom prst="rect">
             <a:avLst/>
@@ -5748,8 +5748,8 @@
           </a:bodyPr>
           <a:lstStyle/>
           <a:p>
-            <a:pPr algn="ctr">
-              <a:defRPr sz="3600" b="1" i="0">
+            <a:pPr algn="l">
+              <a:defRPr sz="2800" b="1" i="0">
                 <a:solidFill>
                   <a:srgbClr val="0D2B45"/>
                 </a:solidFill>
@@ -5757,7 +5757,7 @@
               </a:defRPr>
             </a:pPr>
             <a:r>
-              <a:t>Live Demonstration</a:t>
+              <a:t>Live Demo — Application Screenshots</a:t>
             </a:r>
           </a:p>
         </p:txBody>
@@ -5770,8 +5770,8 @@
         </p:nvSpPr>
         <p:spPr>
           <a:xfrm>
-            <a:off x="5029200" y="2651760"/>
-            <a:ext cx="2103120" cy="25400"/>
+            <a:off x="731520" y="1005840"/>
+            <a:ext cx="1371600" cy="25400"/>
           </a:xfrm>
           <a:prstGeom prst="rect">
             <a:avLst/>
@@ -5813,14 +5813,14 @@
         </p:nvSpPr>
         <p:spPr>
           <a:xfrm>
-            <a:off x="1371600" y="3200400"/>
-            <a:ext cx="2286000" cy="1645920"/>
+            <a:off x="411480" y="1234439"/>
+            <a:ext cx="5486400" cy="2423160"/>
           </a:xfrm>
           <a:prstGeom prst="rect">
             <a:avLst/>
           </a:prstGeom>
           <a:solidFill>
-            <a:srgbClr val="D6E4F0"/>
+            <a:srgbClr val="FFFFFF"/>
           </a:solidFill>
           <a:ln w="6350">
             <a:solidFill>
@@ -5851,16 +5851,40 @@
           </a:p>
         </p:txBody>
       </p:sp>
-      <p:sp>
-        <p:nvSpPr>
-          <p:cNvPr id="6" name="TextBox 5"/>
+      <p:pic>
+        <p:nvPicPr>
+          <p:cNvPr id="6" name="Picture 5" descr="screenshot_home.png"/>
+          <p:cNvPicPr>
+            <a:picLocks noChangeAspect="1"/>
+          </p:cNvPicPr>
+          <p:nvPr/>
+        </p:nvPicPr>
+        <p:blipFill>
+          <a:blip r:embed="rId2"/>
+          <a:stretch>
+            <a:fillRect/>
+          </a:stretch>
+        </p:blipFill>
+        <p:spPr>
+          <a:xfrm>
+            <a:off x="457200" y="1280160"/>
+            <a:ext cx="5394960" cy="2286000"/>
+          </a:xfrm>
+          <a:prstGeom prst="rect">
+            <a:avLst/>
+          </a:prstGeom>
+        </p:spPr>
+      </p:pic>
+      <p:sp>
+        <p:nvSpPr>
+          <p:cNvPr id="7" name="TextBox 6"/>
           <p:cNvSpPr txBox="1"/>
           <p:nvPr/>
         </p:nvSpPr>
         <p:spPr>
           <a:xfrm>
-            <a:off x="1371600" y="3337560"/>
-            <a:ext cx="2286000" cy="320040"/>
+            <a:off x="457200" y="3566160"/>
+            <a:ext cx="5394960" cy="274320"/>
           </a:xfrm>
           <a:prstGeom prst="rect">
             <a:avLst/>
@@ -5874,7 +5898,7 @@
           <a:lstStyle/>
           <a:p>
             <a:pPr algn="ctr">
-              <a:defRPr sz="1400" b="1" i="0">
+              <a:defRPr sz="1000" b="1" i="0">
                 <a:solidFill>
                   <a:srgbClr val="1F4E79"/>
                 </a:solidFill>
@@ -5883,46 +5907,6 @@
             </a:pPr>
             <a:r>
               <a:t>Home Page</a:t>
-            </a:r>
-          </a:p>
-        </p:txBody>
-      </p:sp>
-      <p:sp>
-        <p:nvSpPr>
-          <p:cNvPr id="7" name="TextBox 6"/>
-          <p:cNvSpPr txBox="1"/>
-          <p:nvPr/>
-        </p:nvSpPr>
-        <p:spPr>
-          <a:xfrm>
-            <a:off x="1371600" y="3749039"/>
-            <a:ext cx="2286000" cy="914400"/>
-          </a:xfrm>
-          <a:prstGeom prst="rect">
-            <a:avLst/>
-          </a:prstGeom>
-          <a:noFill/>
-        </p:spPr>
-        <p:txBody>
-          <a:bodyPr wrap="square">
-            <a:spAutoFit/>
-          </a:bodyPr>
-          <a:lstStyle/>
-          <a:p>
-            <a:pPr algn="ctr">
-              <a:defRPr sz="1200" b="0" i="0">
-                <a:solidFill>
-                  <a:srgbClr val="5F5F5F"/>
-                </a:solidFill>
-                <a:latin typeface="Calibri"/>
-              </a:defRPr>
-            </a:pPr>
-            <a:r>
-              <a:t>Project overview and</a:t>
-            </a:r>
-            <a:br/>
-            <a:r>
-              <a:t>how-it-works guide</a:t>
             </a:r>
           </a:p>
         </p:txBody>
@@ -5935,14 +5919,14 @@
         </p:nvSpPr>
         <p:spPr>
           <a:xfrm>
-            <a:off x="3931920" y="3200400"/>
-            <a:ext cx="2286000" cy="1645920"/>
+            <a:off x="5989320" y="1234439"/>
+            <a:ext cx="5486400" cy="2423160"/>
           </a:xfrm>
           <a:prstGeom prst="rect">
             <a:avLst/>
           </a:prstGeom>
           <a:solidFill>
-            <a:srgbClr val="D6E4F0"/>
+            <a:srgbClr val="FFFFFF"/>
           </a:solidFill>
           <a:ln w="6350">
             <a:solidFill>
@@ -5973,16 +5957,40 @@
           </a:p>
         </p:txBody>
       </p:sp>
-      <p:sp>
-        <p:nvSpPr>
-          <p:cNvPr id="9" name="TextBox 8"/>
+      <p:pic>
+        <p:nvPicPr>
+          <p:cNvPr id="9" name="Picture 8" descr="screenshot_result.png"/>
+          <p:cNvPicPr>
+            <a:picLocks noChangeAspect="1"/>
+          </p:cNvPicPr>
+          <p:nvPr/>
+        </p:nvPicPr>
+        <p:blipFill>
+          <a:blip r:embed="rId3"/>
+          <a:stretch>
+            <a:fillRect/>
+          </a:stretch>
+        </p:blipFill>
+        <p:spPr>
+          <a:xfrm>
+            <a:off x="6035040" y="1280160"/>
+            <a:ext cx="5394960" cy="2286000"/>
+          </a:xfrm>
+          <a:prstGeom prst="rect">
+            <a:avLst/>
+          </a:prstGeom>
+        </p:spPr>
+      </p:pic>
+      <p:sp>
+        <p:nvSpPr>
+          <p:cNvPr id="10" name="TextBox 9"/>
           <p:cNvSpPr txBox="1"/>
           <p:nvPr/>
         </p:nvSpPr>
         <p:spPr>
           <a:xfrm>
-            <a:off x="3931920" y="3337560"/>
-            <a:ext cx="2286000" cy="320040"/>
+            <a:off x="6035040" y="3566160"/>
+            <a:ext cx="5394960" cy="274320"/>
           </a:xfrm>
           <a:prstGeom prst="rect">
             <a:avLst/>
@@ -5996,7 +6004,7 @@
           <a:lstStyle/>
           <a:p>
             <a:pPr algn="ctr">
-              <a:defRPr sz="1400" b="1" i="0">
+              <a:defRPr sz="1000" b="1" i="0">
                 <a:solidFill>
                   <a:srgbClr val="1F4E79"/>
                 </a:solidFill>
@@ -6004,47 +6012,7 @@
               </a:defRPr>
             </a:pPr>
             <a:r>
-              <a:t>Prediction Form</a:t>
-            </a:r>
-          </a:p>
-        </p:txBody>
-      </p:sp>
-      <p:sp>
-        <p:nvSpPr>
-          <p:cNvPr id="10" name="TextBox 9"/>
-          <p:cNvSpPr txBox="1"/>
-          <p:nvPr/>
-        </p:nvSpPr>
-        <p:spPr>
-          <a:xfrm>
-            <a:off x="3931920" y="3749039"/>
-            <a:ext cx="2286000" cy="914400"/>
-          </a:xfrm>
-          <a:prstGeom prst="rect">
-            <a:avLst/>
-          </a:prstGeom>
-          <a:noFill/>
-        </p:spPr>
-        <p:txBody>
-          <a:bodyPr wrap="square">
-            <a:spAutoFit/>
-          </a:bodyPr>
-          <a:lstStyle/>
-          <a:p>
-            <a:pPr algn="ctr">
-              <a:defRPr sz="1200" b="0" i="0">
-                <a:solidFill>
-                  <a:srgbClr val="5F5F5F"/>
-                </a:solidFill>
-                <a:latin typeface="Calibri"/>
-              </a:defRPr>
-            </a:pPr>
-            <a:r>
-              <a:t>13 clinical input fields</a:t>
-            </a:r>
-            <a:br/>
-            <a:r>
-              <a:t>with validation</a:t>
+              <a:t>Prediction Result</a:t>
             </a:r>
           </a:p>
         </p:txBody>
@@ -6057,14 +6025,14 @@
         </p:nvSpPr>
         <p:spPr>
           <a:xfrm>
-            <a:off x="6492240" y="3200400"/>
-            <a:ext cx="2286000" cy="1645920"/>
+            <a:off x="411480" y="3794760"/>
+            <a:ext cx="5486400" cy="2423160"/>
           </a:xfrm>
           <a:prstGeom prst="rect">
             <a:avLst/>
           </a:prstGeom>
           <a:solidFill>
-            <a:srgbClr val="D6E4F0"/>
+            <a:srgbClr val="FFFFFF"/>
           </a:solidFill>
           <a:ln w="6350">
             <a:solidFill>
@@ -6095,16 +6063,40 @@
           </a:p>
         </p:txBody>
       </p:sp>
-      <p:sp>
-        <p:nvSpPr>
-          <p:cNvPr id="12" name="TextBox 11"/>
+      <p:pic>
+        <p:nvPicPr>
+          <p:cNvPr id="12" name="Picture 11" descr="screenshot_history.png"/>
+          <p:cNvPicPr>
+            <a:picLocks noChangeAspect="1"/>
+          </p:cNvPicPr>
+          <p:nvPr/>
+        </p:nvPicPr>
+        <p:blipFill>
+          <a:blip r:embed="rId4"/>
+          <a:stretch>
+            <a:fillRect/>
+          </a:stretch>
+        </p:blipFill>
+        <p:spPr>
+          <a:xfrm>
+            <a:off x="457200" y="3840480"/>
+            <a:ext cx="5394960" cy="2286000"/>
+          </a:xfrm>
+          <a:prstGeom prst="rect">
+            <a:avLst/>
+          </a:prstGeom>
+        </p:spPr>
+      </p:pic>
+      <p:sp>
+        <p:nvSpPr>
+          <p:cNvPr id="13" name="TextBox 12"/>
           <p:cNvSpPr txBox="1"/>
           <p:nvPr/>
         </p:nvSpPr>
         <p:spPr>
           <a:xfrm>
-            <a:off x="6492240" y="3337560"/>
-            <a:ext cx="2286000" cy="320040"/>
+            <a:off x="457200" y="6126480"/>
+            <a:ext cx="5394960" cy="274320"/>
           </a:xfrm>
           <a:prstGeom prst="rect">
             <a:avLst/>
@@ -6118,7 +6110,7 @@
           <a:lstStyle/>
           <a:p>
             <a:pPr algn="ctr">
-              <a:defRPr sz="1400" b="1" i="0">
+              <a:defRPr sz="1000" b="1" i="0">
                 <a:solidFill>
                   <a:srgbClr val="1F4E79"/>
                 </a:solidFill>
@@ -6126,47 +6118,7 @@
               </a:defRPr>
             </a:pPr>
             <a:r>
-              <a:t>Result Page</a:t>
-            </a:r>
-          </a:p>
-        </p:txBody>
-      </p:sp>
-      <p:sp>
-        <p:nvSpPr>
-          <p:cNvPr id="13" name="TextBox 12"/>
-          <p:cNvSpPr txBox="1"/>
-          <p:nvPr/>
-        </p:nvSpPr>
-        <p:spPr>
-          <a:xfrm>
-            <a:off x="6492240" y="3749039"/>
-            <a:ext cx="2286000" cy="914400"/>
-          </a:xfrm>
-          <a:prstGeom prst="rect">
-            <a:avLst/>
-          </a:prstGeom>
-          <a:noFill/>
-        </p:spPr>
-        <p:txBody>
-          <a:bodyPr wrap="square">
-            <a:spAutoFit/>
-          </a:bodyPr>
-          <a:lstStyle/>
-          <a:p>
-            <a:pPr algn="ctr">
-              <a:defRPr sz="1200" b="0" i="0">
-                <a:solidFill>
-                  <a:srgbClr val="5F5F5F"/>
-                </a:solidFill>
-                <a:latin typeface="Calibri"/>
-              </a:defRPr>
-            </a:pPr>
-            <a:r>
-              <a:t>Risk level with</a:t>
-            </a:r>
-            <a:br/>
-            <a:r>
-              <a:t>probability indicator</a:t>
+              <a:t>Prediction History</a:t>
             </a:r>
           </a:p>
         </p:txBody>
@@ -6179,14 +6131,14 @@
         </p:nvSpPr>
         <p:spPr>
           <a:xfrm>
-            <a:off x="9052559" y="3200400"/>
-            <a:ext cx="2286000" cy="1645920"/>
+            <a:off x="5989320" y="3794760"/>
+            <a:ext cx="5486400" cy="2423160"/>
           </a:xfrm>
           <a:prstGeom prst="rect">
             <a:avLst/>
           </a:prstGeom>
           <a:solidFill>
-            <a:srgbClr val="D6E4F0"/>
+            <a:srgbClr val="FFFFFF"/>
           </a:solidFill>
           <a:ln w="6350">
             <a:solidFill>
@@ -6217,16 +6169,40 @@
           </a:p>
         </p:txBody>
       </p:sp>
-      <p:sp>
-        <p:nvSpPr>
-          <p:cNvPr id="15" name="TextBox 14"/>
+      <p:pic>
+        <p:nvPicPr>
+          <p:cNvPr id="15" name="Picture 14" descr="screenshot_dark.png"/>
+          <p:cNvPicPr>
+            <a:picLocks noChangeAspect="1"/>
+          </p:cNvPicPr>
+          <p:nvPr/>
+        </p:nvPicPr>
+        <p:blipFill>
+          <a:blip r:embed="rId5"/>
+          <a:stretch>
+            <a:fillRect/>
+          </a:stretch>
+        </p:blipFill>
+        <p:spPr>
+          <a:xfrm>
+            <a:off x="6035040" y="3840480"/>
+            <a:ext cx="5394960" cy="2286000"/>
+          </a:xfrm>
+          <a:prstGeom prst="rect">
+            <a:avLst/>
+          </a:prstGeom>
+        </p:spPr>
+      </p:pic>
+      <p:sp>
+        <p:nvSpPr>
+          <p:cNvPr id="16" name="TextBox 15"/>
           <p:cNvSpPr txBox="1"/>
           <p:nvPr/>
         </p:nvSpPr>
         <p:spPr>
           <a:xfrm>
-            <a:off x="9052559" y="3337560"/>
-            <a:ext cx="2286000" cy="320040"/>
+            <a:off x="6035040" y="6126480"/>
+            <a:ext cx="5394960" cy="274320"/>
           </a:xfrm>
           <a:prstGeom prst="rect">
             <a:avLst/>
@@ -6240,7 +6216,7 @@
           <a:lstStyle/>
           <a:p>
             <a:pPr algn="ctr">
-              <a:defRPr sz="1400" b="1" i="0">
+              <a:defRPr sz="1000" b="1" i="0">
                 <a:solidFill>
                   <a:srgbClr val="1F4E79"/>
                 </a:solidFill>
@@ -6248,21 +6224,21 @@
               </a:defRPr>
             </a:pPr>
             <a:r>
-              <a:t>History Page</a:t>
-            </a:r>
-          </a:p>
-        </p:txBody>
-      </p:sp>
-      <p:sp>
-        <p:nvSpPr>
-          <p:cNvPr id="16" name="TextBox 15"/>
+              <a:t>Dark Mode</a:t>
+            </a:r>
+          </a:p>
+        </p:txBody>
+      </p:sp>
+      <p:sp>
+        <p:nvSpPr>
+          <p:cNvPr id="17" name="TextBox 16"/>
           <p:cNvSpPr txBox="1"/>
           <p:nvPr/>
         </p:nvSpPr>
         <p:spPr>
           <a:xfrm>
-            <a:off x="9052559" y="3749039"/>
-            <a:ext cx="2286000" cy="914400"/>
+            <a:off x="731520" y="6309360"/>
+            <a:ext cx="10698480" cy="274320"/>
           </a:xfrm>
           <a:prstGeom prst="rect">
             <a:avLst/>
@@ -6275,82 +6251,6 @@
           </a:bodyPr>
           <a:lstStyle/>
           <a:p>
-            <a:pPr algn="ctr">
-              <a:defRPr sz="1200" b="0" i="0">
-                <a:solidFill>
-                  <a:srgbClr val="5F5F5F"/>
-                </a:solidFill>
-                <a:latin typeface="Calibri"/>
-              </a:defRPr>
-            </a:pPr>
-            <a:r>
-              <a:t>Past predictions</a:t>
-            </a:r>
-            <a:br/>
-            <a:r>
-              <a:t>with timestamps</a:t>
-            </a:r>
-          </a:p>
-        </p:txBody>
-      </p:sp>
-      <p:sp>
-        <p:nvSpPr>
-          <p:cNvPr id="17" name="TextBox 16"/>
-          <p:cNvSpPr txBox="1"/>
-          <p:nvPr/>
-        </p:nvSpPr>
-        <p:spPr>
-          <a:xfrm>
-            <a:off x="914400" y="5303520"/>
-            <a:ext cx="10332720" cy="274320"/>
-          </a:xfrm>
-          <a:prstGeom prst="rect">
-            <a:avLst/>
-          </a:prstGeom>
-          <a:noFill/>
-        </p:spPr>
-        <p:txBody>
-          <a:bodyPr wrap="square">
-            <a:spAutoFit/>
-          </a:bodyPr>
-          <a:lstStyle/>
-          <a:p>
-            <a:pPr algn="ctr">
-              <a:defRPr sz="1400" b="0" i="0">
-                <a:solidFill>
-                  <a:srgbClr val="1F4E79"/>
-                </a:solidFill>
-                <a:latin typeface="Calibri"/>
-              </a:defRPr>
-            </a:pPr>
-            <a:r>
-              <a:t>http://127.0.0.1:5001</a:t>
-            </a:r>
-          </a:p>
-        </p:txBody>
-      </p:sp>
-      <p:sp>
-        <p:nvSpPr>
-          <p:cNvPr id="18" name="TextBox 17"/>
-          <p:cNvSpPr txBox="1"/>
-          <p:nvPr/>
-        </p:nvSpPr>
-        <p:spPr>
-          <a:xfrm>
-            <a:off x="731520" y="6309360"/>
-            <a:ext cx="10698480" cy="274320"/>
-          </a:xfrm>
-          <a:prstGeom prst="rect">
-            <a:avLst/>
-          </a:prstGeom>
-          <a:noFill/>
-        </p:spPr>
-        <p:txBody>
-          <a:bodyPr wrap="square">
-            <a:spAutoFit/>
-          </a:bodyPr>
-          <a:lstStyle/>
-          <a:p>
             <a:pPr algn="r">
               <a:defRPr sz="900" b="0" i="0">
                 <a:solidFill>
@@ -6367,7 +6267,7 @@
       </p:sp>
       <p:sp>
         <p:nvSpPr>
-          <p:cNvPr id="19" name="Rectangle 18"/>
+          <p:cNvPr id="18" name="Rectangle 17"/>
           <p:cNvSpPr/>
           <p:nvPr/>
         </p:nvSpPr>
@@ -7645,7 +7545,7 @@
               <a:spcBef>
                 <a:spcPts val="600"/>
               </a:spcBef>
-              <a:defRPr sz="1300" b="0" i="0">
+              <a:defRPr sz="1300" b="0">
                 <a:solidFill>
                   <a:srgbClr val="1A1A1A"/>
                 </a:solidFill>
@@ -7653,7 +7553,7 @@
               </a:defRPr>
             </a:pPr>
             <a:r>
-              <a:t>✓  Random Forest classifier — 81.97% accuracy, 96.97% recall</a:t>
+              <a:t>✓  Random Forest — 81.97% accuracy, 96.97% recall</a:t>
             </a:r>
           </a:p>
           <a:p>
@@ -7661,7 +7561,7 @@
               <a:spcBef>
                 <a:spcPts val="600"/>
               </a:spcBef>
-              <a:defRPr sz="1300" b="0" i="0">
+              <a:defRPr sz="1300" b="0">
                 <a:solidFill>
                   <a:srgbClr val="1A1A1A"/>
                 </a:solidFill>
@@ -7677,7 +7577,7 @@
               <a:spcBef>
                 <a:spcPts val="600"/>
               </a:spcBef>
-              <a:defRPr sz="1300" b="0" i="0">
+              <a:defRPr sz="1300" b="0">
                 <a:solidFill>
                   <a:srgbClr val="1A1A1A"/>
                 </a:solidFill>
@@ -7693,7 +7593,7 @@
               <a:spcBef>
                 <a:spcPts val="600"/>
               </a:spcBef>
-              <a:defRPr sz="1300" b="0" i="0">
+              <a:defRPr sz="1300" b="0">
                 <a:solidFill>
                   <a:srgbClr val="1A1A1A"/>
                 </a:solidFill>
@@ -7709,7 +7609,7 @@
               <a:spcBef>
                 <a:spcPts val="600"/>
               </a:spcBef>
-              <a:defRPr sz="1300" b="0" i="0">
+              <a:defRPr sz="1300" b="0">
                 <a:solidFill>
                   <a:srgbClr val="1A1A1A"/>
                 </a:solidFill>
@@ -7725,7 +7625,7 @@
               <a:spcBef>
                 <a:spcPts val="600"/>
               </a:spcBef>
-              <a:defRPr sz="1300" b="0" i="0">
+              <a:defRPr sz="1300" b="0">
                 <a:solidFill>
                   <a:srgbClr val="1A1A1A"/>
                 </a:solidFill>
@@ -7741,7 +7641,7 @@
               <a:spcBef>
                 <a:spcPts val="600"/>
               </a:spcBef>
-              <a:defRPr sz="1300" b="0" i="0">
+              <a:defRPr sz="1300" b="0">
                 <a:solidFill>
                   <a:srgbClr val="1A1A1A"/>
                 </a:solidFill>
@@ -7757,7 +7657,7 @@
               <a:spcBef>
                 <a:spcPts val="600"/>
               </a:spcBef>
-              <a:defRPr sz="1300" b="0" i="0">
+              <a:defRPr sz="1300" b="0">
                 <a:solidFill>
                   <a:srgbClr val="1A1A1A"/>
                 </a:solidFill>
@@ -7809,7 +7709,7 @@
               <a:spcBef>
                 <a:spcPts val="600"/>
               </a:spcBef>
-              <a:defRPr sz="1300" b="0" i="0">
+              <a:defRPr sz="1300" b="0">
                 <a:solidFill>
                   <a:srgbClr val="1A1A1A"/>
                 </a:solidFill>
@@ -7825,7 +7725,7 @@
               <a:spcBef>
                 <a:spcPts val="600"/>
               </a:spcBef>
-              <a:defRPr sz="1300" b="0" i="0">
+              <a:defRPr sz="1300" b="0">
                 <a:solidFill>
                   <a:srgbClr val="1A1A1A"/>
                 </a:solidFill>
@@ -7841,7 +7741,7 @@
               <a:spcBef>
                 <a:spcPts val="600"/>
               </a:spcBef>
-              <a:defRPr sz="1300" b="0" i="0">
+              <a:defRPr sz="1300" b="0">
                 <a:solidFill>
                   <a:srgbClr val="1A1A1A"/>
                 </a:solidFill>
@@ -7857,7 +7757,7 @@
               <a:spcBef>
                 <a:spcPts val="600"/>
               </a:spcBef>
-              <a:defRPr sz="1300" b="0" i="0">
+              <a:defRPr sz="1300" b="0">
                 <a:solidFill>
                   <a:srgbClr val="1A1A1A"/>
                 </a:solidFill>
@@ -7873,7 +7773,7 @@
               <a:spcBef>
                 <a:spcPts val="600"/>
               </a:spcBef>
-              <a:defRPr sz="1300" b="0" i="0">
+              <a:defRPr sz="1300" b="0">
                 <a:solidFill>
                   <a:srgbClr val="1A1A1A"/>
                 </a:solidFill>
@@ -7889,7 +7789,7 @@
               <a:spcBef>
                 <a:spcPts val="600"/>
               </a:spcBef>
-              <a:defRPr sz="1300" b="0" i="0">
+              <a:defRPr sz="1300" b="0">
                 <a:solidFill>
                   <a:srgbClr val="1A1A1A"/>
                 </a:solidFill>
@@ -7905,7 +7805,7 @@
               <a:spcBef>
                 <a:spcPts val="600"/>
               </a:spcBef>
-              <a:defRPr sz="1300" b="0" i="0">
+              <a:defRPr sz="1300" b="0">
                 <a:solidFill>
                   <a:srgbClr val="1A1A1A"/>
                 </a:solidFill>
@@ -7921,7 +7821,7 @@
               <a:spcBef>
                 <a:spcPts val="600"/>
               </a:spcBef>
-              <a:defRPr sz="1300" b="0" i="0">
+              <a:defRPr sz="1300" b="0">
                 <a:solidFill>
                   <a:srgbClr val="1A1A1A"/>
                 </a:solidFill>
@@ -9410,7 +9310,43 @@
       </p:sp>
       <p:sp>
         <p:nvSpPr>
-          <p:cNvPr id="29" name="Rectangle 28"/>
+          <p:cNvPr id="29" name="TextBox 28"/>
+          <p:cNvSpPr txBox="1"/>
+          <p:nvPr/>
+        </p:nvSpPr>
+        <p:spPr>
+          <a:xfrm>
+            <a:off x="731520" y="6309360"/>
+            <a:ext cx="10698480" cy="274320"/>
+          </a:xfrm>
+          <a:prstGeom prst="rect">
+            <a:avLst/>
+          </a:prstGeom>
+          <a:noFill/>
+        </p:spPr>
+        <p:txBody>
+          <a:bodyPr wrap="square">
+            <a:spAutoFit/>
+          </a:bodyPr>
+          <a:lstStyle/>
+          <a:p>
+            <a:pPr algn="r">
+              <a:defRPr sz="900" b="0" i="0">
+                <a:solidFill>
+                  <a:srgbClr val="9A9A9A"/>
+                </a:solidFill>
+                <a:latin typeface="Calibri"/>
+              </a:defRPr>
+            </a:pPr>
+            <a:r>
+              <a:t>CardioPredict  |  Sandeep Kumar  |  MCA  |  Sikkim Manipal University</a:t>
+            </a:r>
+          </a:p>
+        </p:txBody>
+      </p:sp>
+      <p:sp>
+        <p:nvSpPr>
+          <p:cNvPr id="30" name="Rectangle 29"/>
           <p:cNvSpPr/>
           <p:nvPr/>
         </p:nvSpPr>
@@ -9641,7 +9577,7 @@
               <a:spcBef>
                 <a:spcPts val="1000"/>
               </a:spcBef>
-              <a:defRPr sz="1400" b="0" i="0">
+              <a:defRPr sz="1400" b="0">
                 <a:solidFill>
                   <a:srgbClr val="1A1A1A"/>
                 </a:solidFill>
@@ -9649,7 +9585,39 @@
               </a:defRPr>
             </a:pPr>
             <a:r>
-              <a:t>• Cardiovascular diseases (CVDs) are the #1 cause of death globally —</a:t>
+              <a:t>• CVDs are the #1 cause of death globally — 17.9 million deaths/year (WHO)</a:t>
+            </a:r>
+          </a:p>
+          <a:p>
+            <a:pPr algn="l">
+              <a:spcBef>
+                <a:spcPts val="1400"/>
+              </a:spcBef>
+              <a:defRPr sz="1400" b="0">
+                <a:solidFill>
+                  <a:srgbClr val="1A1A1A"/>
+                </a:solidFill>
+                <a:latin typeface="Calibri"/>
+              </a:defRPr>
+            </a:pPr>
+            <a:r>
+              <a:t>• In India, CVDs account for 28% of all deaths</a:t>
+            </a:r>
+          </a:p>
+          <a:p>
+            <a:pPr algn="l">
+              <a:spcBef>
+                <a:spcPts val="1400"/>
+              </a:spcBef>
+              <a:defRPr sz="1400" b="0">
+                <a:solidFill>
+                  <a:srgbClr val="1A1A1A"/>
+                </a:solidFill>
+                <a:latin typeface="Calibri"/>
+              </a:defRPr>
+            </a:pPr>
+            <a:r>
+              <a:t>• Conventional diagnostics (ECG, angiography) are expensive and</a:t>
             </a:r>
           </a:p>
           <a:p>
@@ -9657,7 +9625,7 @@
               <a:spcBef>
                 <a:spcPts val="200"/>
               </a:spcBef>
-              <a:defRPr sz="1400" b="0" i="0">
+              <a:defRPr sz="1400" b="0">
                 <a:solidFill>
                   <a:srgbClr val="5F5F5F"/>
                 </a:solidFill>
@@ -9665,7 +9633,7 @@
               </a:defRPr>
             </a:pPr>
             <a:r>
-              <a:t>  approximately 17.9 million deaths per year (WHO)</a:t>
+              <a:t>  unavailable in most rural primary healthcare centres</a:t>
             </a:r>
           </a:p>
           <a:p>
@@ -9673,7 +9641,7 @@
               <a:spcBef>
                 <a:spcPts val="1400"/>
               </a:spcBef>
-              <a:defRPr sz="1400" b="0" i="0">
+              <a:defRPr sz="1400" b="0">
                 <a:solidFill>
                   <a:srgbClr val="1A1A1A"/>
                 </a:solidFill>
@@ -9681,23 +9649,7 @@
               </a:defRPr>
             </a:pPr>
             <a:r>
-              <a:t>• In India, CVDs account for 28% of all deaths</a:t>
-            </a:r>
-          </a:p>
-          <a:p>
-            <a:pPr algn="l">
-              <a:spcBef>
-                <a:spcPts val="1400"/>
-              </a:spcBef>
-              <a:defRPr sz="1400" b="0" i="0">
-                <a:solidFill>
-                  <a:srgbClr val="1A1A1A"/>
-                </a:solidFill>
-                <a:latin typeface="Calibri"/>
-              </a:defRPr>
-            </a:pPr>
-            <a:r>
-              <a:t>• Conventional diagnostic tests (ECG, angiography) are expensive</a:t>
+              <a:t>• ML can analyse routine clinical data to estimate heart disease</a:t>
             </a:r>
           </a:p>
           <a:p>
@@ -9705,7 +9657,7 @@
               <a:spcBef>
                 <a:spcPts val="200"/>
               </a:spcBef>
-              <a:defRPr sz="1400" b="0" i="0">
+              <a:defRPr sz="1400" b="0">
                 <a:solidFill>
                   <a:srgbClr val="5F5F5F"/>
                 </a:solidFill>
@@ -9713,39 +9665,7 @@
               </a:defRPr>
             </a:pPr>
             <a:r>
-              <a:t>  and unavailable in most rural primary healthcare centres</a:t>
-            </a:r>
-          </a:p>
-          <a:p>
-            <a:pPr algn="l">
-              <a:spcBef>
-                <a:spcPts val="1400"/>
-              </a:spcBef>
-              <a:defRPr sz="1400" b="0" i="0">
-                <a:solidFill>
-                  <a:srgbClr val="1A1A1A"/>
-                </a:solidFill>
-                <a:latin typeface="Calibri"/>
-              </a:defRPr>
-            </a:pPr>
-            <a:r>
-              <a:t>• Machine learning can analyse routine clinical data to estimate</a:t>
-            </a:r>
-          </a:p>
-          <a:p>
-            <a:pPr algn="l">
-              <a:spcBef>
-                <a:spcPts val="200"/>
-              </a:spcBef>
-              <a:defRPr sz="1400" b="0" i="0">
-                <a:solidFill>
-                  <a:srgbClr val="5F5F5F"/>
-                </a:solidFill>
-                <a:latin typeface="Calibri"/>
-              </a:defRPr>
-            </a:pPr>
-            <a:r>
-              <a:t>  heart disease probability with accuracy comparable to specialists</a:t>
+              <a:t>  risk with accuracy comparable to specialists</a:t>
             </a:r>
           </a:p>
         </p:txBody>
@@ -9868,7 +9788,7 @@
               <a:spcBef>
                 <a:spcPts val="600"/>
               </a:spcBef>
-              <a:defRPr sz="1200" b="0" i="0">
+              <a:defRPr sz="1200" b="0">
                 <a:solidFill>
                   <a:srgbClr val="1A1A1A"/>
                 </a:solidFill>
@@ -9876,7 +9796,7 @@
               </a:defRPr>
             </a:pPr>
             <a:r>
-              <a:t>No affordable screening tool exists for primary care physicians to quickly assess heart disease risk.</a:t>
+              <a:t>No affordable screening tool exists for primary care clinics.</a:t>
             </a:r>
           </a:p>
           <a:p>
@@ -9884,7 +9804,7 @@
               <a:spcBef>
                 <a:spcPts val="600"/>
               </a:spcBef>
-              <a:defRPr sz="600" b="0" i="0">
+              <a:defRPr sz="600" b="0">
                 <a:solidFill>
                   <a:srgbClr val="1A1A1A"/>
                 </a:solidFill>
@@ -9897,7 +9817,7 @@
               <a:spcBef>
                 <a:spcPts val="600"/>
               </a:spcBef>
-              <a:defRPr sz="1200" b="0" i="0">
+              <a:defRPr sz="1200" b="0">
                 <a:solidFill>
                   <a:srgbClr val="1A1A1A"/>
                 </a:solidFill>
@@ -9905,7 +9825,7 @@
               </a:defRPr>
             </a:pPr>
             <a:r>
-              <a:t>Most ML models from research remain as Jupyter notebooks — no UI, no validation, no deployment.</a:t>
+              <a:t>Most ML models from research exist only as Jupyter notebooks — no UI, no validation.</a:t>
             </a:r>
           </a:p>
           <a:p>
@@ -9913,7 +9833,7 @@
               <a:spcBef>
                 <a:spcPts val="600"/>
               </a:spcBef>
-              <a:defRPr sz="600" b="0" i="0">
+              <a:defRPr sz="600" b="0">
                 <a:solidFill>
                   <a:srgbClr val="1A1A1A"/>
                 </a:solidFill>
@@ -9926,7 +9846,7 @@
               <a:spcBef>
                 <a:spcPts val="600"/>
               </a:spcBef>
-              <a:defRPr sz="1200" b="1" i="0">
+              <a:defRPr sz="1200" b="1">
                 <a:solidFill>
                   <a:srgbClr val="1F4E79"/>
                 </a:solidFill>
@@ -12214,7 +12134,7 @@
                         </a:defRPr>
                       </a:pPr>
                       <a:r>
-                        <a:t>0–2 (3 types)</a:t>
+                        <a:t>0–2</a:t>
                       </a:r>
                     </a:p>
                   </a:txBody>
@@ -12606,7 +12526,7 @@
                         </a:defRPr>
                       </a:pPr>
                       <a:r>
-                        <a:t>0–2 (3 types)</a:t>
+                        <a:t>0–2</a:t>
                       </a:r>
                     </a:p>
                   </a:txBody>
@@ -12680,7 +12600,7 @@
                         </a:defRPr>
                       </a:pPr>
                       <a:r>
-                        <a:t>Major vessels by fluoroscopy</a:t>
+                        <a:t>Major vessels (fluoroscopy)</a:t>
                       </a:r>
                     </a:p>
                   </a:txBody>
@@ -12802,7 +12722,7 @@
                         </a:defRPr>
                       </a:pPr>
                       <a:r>
-                        <a:t>0–2 (3 types)</a:t>
+                        <a:t>0–2</a:t>
                       </a:r>
                     </a:p>
                   </a:txBody>
@@ -14021,7 +13941,7 @@
               <a:spcBef>
                 <a:spcPts val="800"/>
               </a:spcBef>
-              <a:defRPr sz="1300" b="0" i="0">
+              <a:defRPr sz="1300" b="0">
                 <a:solidFill>
                   <a:srgbClr val="1A1A1A"/>
                 </a:solidFill>
@@ -14029,7 +13949,7 @@
               </a:defRPr>
             </a:pPr>
             <a:r>
-              <a:t>• Median imputation for missing values in ca, thal columns</a:t>
+              <a:t>• Median imputation for missing values (ca, thal)</a:t>
             </a:r>
           </a:p>
           <a:p>
@@ -14037,7 +13957,7 @@
               <a:spcBef>
                 <a:spcPts val="600"/>
               </a:spcBef>
-              <a:defRPr sz="1300" b="0" i="0">
+              <a:defRPr sz="1300" b="0">
                 <a:solidFill>
                   <a:srgbClr val="1A1A1A"/>
                 </a:solidFill>
@@ -14053,7 +13973,7 @@
               <a:spcBef>
                 <a:spcPts val="600"/>
               </a:spcBef>
-              <a:defRPr sz="1300" b="0" i="0">
+              <a:defRPr sz="1300" b="0">
                 <a:solidFill>
                   <a:srgbClr val="1A1A1A"/>
                 </a:solidFill>
@@ -14061,7 +13981,7 @@
               </a:defRPr>
             </a:pPr>
             <a:r>
-              <a:t>• Stratified 80/20 train-test split (242 / 61 samples)</a:t>
+              <a:t>• Stratified 80/20 split (242 / 61 samples)</a:t>
             </a:r>
           </a:p>
           <a:p>
@@ -14069,7 +13989,7 @@
               <a:spcBef>
                 <a:spcPts val="600"/>
               </a:spcBef>
-              <a:defRPr sz="1300" b="0" i="0">
+              <a:defRPr sz="1300" b="0">
                 <a:solidFill>
                   <a:srgbClr val="1A1A1A"/>
                 </a:solidFill>
@@ -14113,7 +14033,7 @@
               </a:defRPr>
             </a:pPr>
             <a:r>
-              <a:t>Evaluation</a:t>
+              <a:t>Evaluation Strategy</a:t>
             </a:r>
           </a:p>
           <a:p>
@@ -14121,7 +14041,7 @@
               <a:spcBef>
                 <a:spcPts val="800"/>
               </a:spcBef>
-              <a:defRPr sz="1300" b="0" i="0">
+              <a:defRPr sz="1300" b="0">
                 <a:solidFill>
                   <a:srgbClr val="1A1A1A"/>
                 </a:solidFill>
@@ -14129,7 +14049,23 @@
               </a:defRPr>
             </a:pPr>
             <a:r>
-              <a:t>• 10-fold stratified cross-validation</a:t>
+              <a:t>• Stratified 10-fold cross-validation ensures each fold</a:t>
+            </a:r>
+          </a:p>
+          <a:p>
+            <a:pPr algn="l">
+              <a:spcBef>
+                <a:spcPts val="200"/>
+              </a:spcBef>
+              <a:defRPr sz="1300" b="0">
+                <a:solidFill>
+                  <a:srgbClr val="5F5F5F"/>
+                </a:solidFill>
+                <a:latin typeface="Calibri"/>
+              </a:defRPr>
+            </a:pPr>
+            <a:r>
+              <a:t>  has balanced representation of both classes</a:t>
             </a:r>
           </a:p>
           <a:p>
@@ -14137,7 +14073,7 @@
               <a:spcBef>
                 <a:spcPts val="600"/>
               </a:spcBef>
-              <a:defRPr sz="1300" b="0" i="0">
+              <a:defRPr sz="1300" b="0">
                 <a:solidFill>
                   <a:srgbClr val="1A1A1A"/>
                 </a:solidFill>
@@ -14153,7 +14089,7 @@
               <a:spcBef>
                 <a:spcPts val="600"/>
               </a:spcBef>
-              <a:defRPr sz="1300" b="0" i="0">
+              <a:defRPr sz="1300" b="0">
                 <a:solidFill>
                   <a:srgbClr val="1A1A1A"/>
                 </a:solidFill>
@@ -14161,7 +14097,7 @@
               </a:defRPr>
             </a:pPr>
             <a:r>
-              <a:t>• Confusion matrix analysis</a:t>
+              <a:t>• Confusion matrix + ROC-AUC curve analysis</a:t>
             </a:r>
           </a:p>
           <a:p>
@@ -14169,7 +14105,7 @@
               <a:spcBef>
                 <a:spcPts val="600"/>
               </a:spcBef>
-              <a:defRPr sz="1300" b="0" i="0">
+              <a:defRPr sz="1300" b="0">
                 <a:solidFill>
                   <a:srgbClr val="1A1A1A"/>
                 </a:solidFill>
@@ -14177,7 +14113,7 @@
               </a:defRPr>
             </a:pPr>
             <a:r>
-              <a:t>• ROC-AUC curve</a:t>
+              <a:t>• Comparison across 7 algorithms</a:t>
             </a:r>
           </a:p>
         </p:txBody>
@@ -14415,1011 +14351,30 @@
           </a:p>
         </p:txBody>
       </p:sp>
-      <p:graphicFrame>
-        <p:nvGraphicFramePr>
-          <p:cNvPr id="5" name="Table 4"/>
-          <p:cNvGraphicFramePr>
-            <a:graphicFrameLocks noGrp="1"/>
-          </p:cNvGraphicFramePr>
-          <p:nvPr/>
-        </p:nvGraphicFramePr>
-        <p:xfrm>
-          <a:off x="1371600" y="1371600"/>
-          <a:ext cx="9418320" cy="2926080"/>
-        </p:xfrm>
-        <a:graphic>
-          <a:graphicData uri="http://schemas.openxmlformats.org/drawingml/2006/table">
-            <a:tbl>
-              <a:tblPr firstRow="1" bandRow="1">
-                <a:tableStyleId>{5C22544A-7EE6-4342-B048-85BDC9FD1C3A}</a:tableStyleId>
-              </a:tblPr>
-              <a:tblGrid>
-                <a:gridCol w="731520"/>
-                <a:gridCol w="2743200"/>
-                <a:gridCol w="1828800"/>
-                <a:gridCol w="1371600"/>
-                <a:gridCol w="2743200"/>
-              </a:tblGrid>
-              <a:tr h="365760">
-                <a:tc>
-                  <a:txBody>
-                    <a:bodyPr/>
-                    <a:lstStyle/>
-                    <a:p>
-                      <a:pPr>
-                        <a:defRPr sz="1100" b="1">
-                          <a:solidFill>
-                            <a:srgbClr val="FFFFFF"/>
-                          </a:solidFill>
-                          <a:latin typeface="Calibri"/>
-                        </a:defRPr>
-                      </a:pPr>
-                      <a:r>
-                        <a:t>Rank</a:t>
-                      </a:r>
-                    </a:p>
-                  </a:txBody>
-                  <a:tcPr>
-                    <a:solidFill>
-                      <a:srgbClr val="1F4E79"/>
-                    </a:solidFill>
-                  </a:tcPr>
-                </a:tc>
-                <a:tc>
-                  <a:txBody>
-                    <a:bodyPr/>
-                    <a:lstStyle/>
-                    <a:p>
-                      <a:pPr>
-                        <a:defRPr sz="1100" b="1">
-                          <a:solidFill>
-                            <a:srgbClr val="FFFFFF"/>
-                          </a:solidFill>
-                          <a:latin typeface="Calibri"/>
-                        </a:defRPr>
-                      </a:pPr>
-                      <a:r>
-                        <a:t>Algorithm</a:t>
-                      </a:r>
-                    </a:p>
-                  </a:txBody>
-                  <a:tcPr>
-                    <a:solidFill>
-                      <a:srgbClr val="1F4E79"/>
-                    </a:solidFill>
-                  </a:tcPr>
-                </a:tc>
-                <a:tc>
-                  <a:txBody>
-                    <a:bodyPr/>
-                    <a:lstStyle/>
-                    <a:p>
-                      <a:pPr>
-                        <a:defRPr sz="1100" b="1">
-                          <a:solidFill>
-                            <a:srgbClr val="FFFFFF"/>
-                          </a:solidFill>
-                          <a:latin typeface="Calibri"/>
-                        </a:defRPr>
-                      </a:pPr>
-                      <a:r>
-                        <a:t>CV Accuracy</a:t>
-                      </a:r>
-                    </a:p>
-                  </a:txBody>
-                  <a:tcPr>
-                    <a:solidFill>
-                      <a:srgbClr val="1F4E79"/>
-                    </a:solidFill>
-                  </a:tcPr>
-                </a:tc>
-                <a:tc>
-                  <a:txBody>
-                    <a:bodyPr/>
-                    <a:lstStyle/>
-                    <a:p>
-                      <a:pPr>
-                        <a:defRPr sz="1100" b="1">
-                          <a:solidFill>
-                            <a:srgbClr val="FFFFFF"/>
-                          </a:solidFill>
-                          <a:latin typeface="Calibri"/>
-                        </a:defRPr>
-                      </a:pPr>
-                      <a:r>
-                        <a:t>Std Dev</a:t>
-                      </a:r>
-                    </a:p>
-                  </a:txBody>
-                  <a:tcPr>
-                    <a:solidFill>
-                      <a:srgbClr val="1F4E79"/>
-                    </a:solidFill>
-                  </a:tcPr>
-                </a:tc>
-                <a:tc>
-                  <a:txBody>
-                    <a:bodyPr/>
-                    <a:lstStyle/>
-                    <a:p>
-                      <a:pPr>
-                        <a:defRPr sz="1100" b="1">
-                          <a:solidFill>
-                            <a:srgbClr val="FFFFFF"/>
-                          </a:solidFill>
-                          <a:latin typeface="Calibri"/>
-                        </a:defRPr>
-                      </a:pPr>
-                      <a:r>
-                        <a:t>Type</a:t>
-                      </a:r>
-                    </a:p>
-                  </a:txBody>
-                  <a:tcPr>
-                    <a:solidFill>
-                      <a:srgbClr val="1F4E79"/>
-                    </a:solidFill>
-                  </a:tcPr>
-                </a:tc>
-              </a:tr>
-              <a:tr h="365760">
-                <a:tc>
-                  <a:txBody>
-                    <a:bodyPr/>
-                    <a:lstStyle/>
-                    <a:p>
-                      <a:pPr>
-                        <a:defRPr sz="1100">
-                          <a:solidFill>
-                            <a:srgbClr val="1A1A1A"/>
-                          </a:solidFill>
-                          <a:latin typeface="Calibri"/>
-                        </a:defRPr>
-                      </a:pPr>
-                      <a:r>
-                        <a:t>1</a:t>
-                      </a:r>
-                    </a:p>
-                  </a:txBody>
-                  <a:tcPr>
-                    <a:solidFill>
-                      <a:srgbClr val="FFFFFF"/>
-                    </a:solidFill>
-                  </a:tcPr>
-                </a:tc>
-                <a:tc>
-                  <a:txBody>
-                    <a:bodyPr/>
-                    <a:lstStyle/>
-                    <a:p>
-                      <a:pPr>
-                        <a:defRPr sz="1100">
-                          <a:solidFill>
-                            <a:srgbClr val="1A1A1A"/>
-                          </a:solidFill>
-                          <a:latin typeface="Calibri"/>
-                        </a:defRPr>
-                      </a:pPr>
-                      <a:r>
-                        <a:t>Random Forest</a:t>
-                      </a:r>
-                    </a:p>
-                  </a:txBody>
-                  <a:tcPr>
-                    <a:solidFill>
-                      <a:srgbClr val="FFFFFF"/>
-                    </a:solidFill>
-                  </a:tcPr>
-                </a:tc>
-                <a:tc>
-                  <a:txBody>
-                    <a:bodyPr/>
-                    <a:lstStyle/>
-                    <a:p>
-                      <a:pPr>
-                        <a:defRPr sz="1100">
-                          <a:solidFill>
-                            <a:srgbClr val="1A1A1A"/>
-                          </a:solidFill>
-                          <a:latin typeface="Calibri"/>
-                        </a:defRPr>
-                      </a:pPr>
-                      <a:r>
-                        <a:t>85.04%</a:t>
-                      </a:r>
-                    </a:p>
-                  </a:txBody>
-                  <a:tcPr>
-                    <a:solidFill>
-                      <a:srgbClr val="FFFFFF"/>
-                    </a:solidFill>
-                  </a:tcPr>
-                </a:tc>
-                <a:tc>
-                  <a:txBody>
-                    <a:bodyPr/>
-                    <a:lstStyle/>
-                    <a:p>
-                      <a:pPr>
-                        <a:defRPr sz="1100">
-                          <a:solidFill>
-                            <a:srgbClr val="1A1A1A"/>
-                          </a:solidFill>
-                          <a:latin typeface="Calibri"/>
-                        </a:defRPr>
-                      </a:pPr>
-                      <a:r>
-                        <a:t>±5.96%</a:t>
-                      </a:r>
-                    </a:p>
-                  </a:txBody>
-                  <a:tcPr>
-                    <a:solidFill>
-                      <a:srgbClr val="FFFFFF"/>
-                    </a:solidFill>
-                  </a:tcPr>
-                </a:tc>
-                <a:tc>
-                  <a:txBody>
-                    <a:bodyPr/>
-                    <a:lstStyle/>
-                    <a:p>
-                      <a:pPr>
-                        <a:defRPr sz="1100">
-                          <a:solidFill>
-                            <a:srgbClr val="1A1A1A"/>
-                          </a:solidFill>
-                          <a:latin typeface="Calibri"/>
-                        </a:defRPr>
-                      </a:pPr>
-                      <a:r>
-                        <a:t>Ensemble (Bagging)</a:t>
-                      </a:r>
-                    </a:p>
-                  </a:txBody>
-                  <a:tcPr>
-                    <a:solidFill>
-                      <a:srgbClr val="FFFFFF"/>
-                    </a:solidFill>
-                  </a:tcPr>
-                </a:tc>
-              </a:tr>
-              <a:tr h="365760">
-                <a:tc>
-                  <a:txBody>
-                    <a:bodyPr/>
-                    <a:lstStyle/>
-                    <a:p>
-                      <a:pPr>
-                        <a:defRPr sz="1100">
-                          <a:solidFill>
-                            <a:srgbClr val="1A1A1A"/>
-                          </a:solidFill>
-                          <a:latin typeface="Calibri"/>
-                        </a:defRPr>
-                      </a:pPr>
-                      <a:r>
-                        <a:t>2</a:t>
-                      </a:r>
-                    </a:p>
-                  </a:txBody>
-                  <a:tcPr>
-                    <a:solidFill>
-                      <a:srgbClr val="D6E4F0"/>
-                    </a:solidFill>
-                  </a:tcPr>
-                </a:tc>
-                <a:tc>
-                  <a:txBody>
-                    <a:bodyPr/>
-                    <a:lstStyle/>
-                    <a:p>
-                      <a:pPr>
-                        <a:defRPr sz="1100">
-                          <a:solidFill>
-                            <a:srgbClr val="1A1A1A"/>
-                          </a:solidFill>
-                          <a:latin typeface="Calibri"/>
-                        </a:defRPr>
-                      </a:pPr>
-                      <a:r>
-                        <a:t>Gradient Boosting</a:t>
-                      </a:r>
-                    </a:p>
-                  </a:txBody>
-                  <a:tcPr>
-                    <a:solidFill>
-                      <a:srgbClr val="D6E4F0"/>
-                    </a:solidFill>
-                  </a:tcPr>
-                </a:tc>
-                <a:tc>
-                  <a:txBody>
-                    <a:bodyPr/>
-                    <a:lstStyle/>
-                    <a:p>
-                      <a:pPr>
-                        <a:defRPr sz="1100">
-                          <a:solidFill>
-                            <a:srgbClr val="1A1A1A"/>
-                          </a:solidFill>
-                          <a:latin typeface="Calibri"/>
-                        </a:defRPr>
-                      </a:pPr>
-                      <a:r>
-                        <a:t>81.46%</a:t>
-                      </a:r>
-                    </a:p>
-                  </a:txBody>
-                  <a:tcPr>
-                    <a:solidFill>
-                      <a:srgbClr val="D6E4F0"/>
-                    </a:solidFill>
-                  </a:tcPr>
-                </a:tc>
-                <a:tc>
-                  <a:txBody>
-                    <a:bodyPr/>
-                    <a:lstStyle/>
-                    <a:p>
-                      <a:pPr>
-                        <a:defRPr sz="1100">
-                          <a:solidFill>
-                            <a:srgbClr val="1A1A1A"/>
-                          </a:solidFill>
-                          <a:latin typeface="Calibri"/>
-                        </a:defRPr>
-                      </a:pPr>
-                      <a:r>
-                        <a:t>±6.72%</a:t>
-                      </a:r>
-                    </a:p>
-                  </a:txBody>
-                  <a:tcPr>
-                    <a:solidFill>
-                      <a:srgbClr val="D6E4F0"/>
-                    </a:solidFill>
-                  </a:tcPr>
-                </a:tc>
-                <a:tc>
-                  <a:txBody>
-                    <a:bodyPr/>
-                    <a:lstStyle/>
-                    <a:p>
-                      <a:pPr>
-                        <a:defRPr sz="1100">
-                          <a:solidFill>
-                            <a:srgbClr val="1A1A1A"/>
-                          </a:solidFill>
-                          <a:latin typeface="Calibri"/>
-                        </a:defRPr>
-                      </a:pPr>
-                      <a:r>
-                        <a:t>Ensemble (Boosting)</a:t>
-                      </a:r>
-                    </a:p>
-                  </a:txBody>
-                  <a:tcPr>
-                    <a:solidFill>
-                      <a:srgbClr val="D6E4F0"/>
-                    </a:solidFill>
-                  </a:tcPr>
-                </a:tc>
-              </a:tr>
-              <a:tr h="365760">
-                <a:tc>
-                  <a:txBody>
-                    <a:bodyPr/>
-                    <a:lstStyle/>
-                    <a:p>
-                      <a:pPr>
-                        <a:defRPr sz="1100">
-                          <a:solidFill>
-                            <a:srgbClr val="1A1A1A"/>
-                          </a:solidFill>
-                          <a:latin typeface="Calibri"/>
-                        </a:defRPr>
-                      </a:pPr>
-                      <a:r>
-                        <a:t>3</a:t>
-                      </a:r>
-                    </a:p>
-                  </a:txBody>
-                  <a:tcPr>
-                    <a:solidFill>
-                      <a:srgbClr val="FFFFFF"/>
-                    </a:solidFill>
-                  </a:tcPr>
-                </a:tc>
-                <a:tc>
-                  <a:txBody>
-                    <a:bodyPr/>
-                    <a:lstStyle/>
-                    <a:p>
-                      <a:pPr>
-                        <a:defRPr sz="1100">
-                          <a:solidFill>
-                            <a:srgbClr val="1A1A1A"/>
-                          </a:solidFill>
-                          <a:latin typeface="Calibri"/>
-                        </a:defRPr>
-                      </a:pPr>
-                      <a:r>
-                        <a:t>KNN</a:t>
-                      </a:r>
-                    </a:p>
-                  </a:txBody>
-                  <a:tcPr>
-                    <a:solidFill>
-                      <a:srgbClr val="FFFFFF"/>
-                    </a:solidFill>
-                  </a:tcPr>
-                </a:tc>
-                <a:tc>
-                  <a:txBody>
-                    <a:bodyPr/>
-                    <a:lstStyle/>
-                    <a:p>
-                      <a:pPr>
-                        <a:defRPr sz="1100">
-                          <a:solidFill>
-                            <a:srgbClr val="1A1A1A"/>
-                          </a:solidFill>
-                          <a:latin typeface="Calibri"/>
-                        </a:defRPr>
-                      </a:pPr>
-                      <a:r>
-                        <a:t>80.58%</a:t>
-                      </a:r>
-                    </a:p>
-                  </a:txBody>
-                  <a:tcPr>
-                    <a:solidFill>
-                      <a:srgbClr val="FFFFFF"/>
-                    </a:solidFill>
-                  </a:tcPr>
-                </a:tc>
-                <a:tc>
-                  <a:txBody>
-                    <a:bodyPr/>
-                    <a:lstStyle/>
-                    <a:p>
-                      <a:pPr>
-                        <a:defRPr sz="1100">
-                          <a:solidFill>
-                            <a:srgbClr val="1A1A1A"/>
-                          </a:solidFill>
-                          <a:latin typeface="Calibri"/>
-                        </a:defRPr>
-                      </a:pPr>
-                      <a:r>
-                        <a:t>±7.13%</a:t>
-                      </a:r>
-                    </a:p>
-                  </a:txBody>
-                  <a:tcPr>
-                    <a:solidFill>
-                      <a:srgbClr val="FFFFFF"/>
-                    </a:solidFill>
-                  </a:tcPr>
-                </a:tc>
-                <a:tc>
-                  <a:txBody>
-                    <a:bodyPr/>
-                    <a:lstStyle/>
-                    <a:p>
-                      <a:pPr>
-                        <a:defRPr sz="1100">
-                          <a:solidFill>
-                            <a:srgbClr val="1A1A1A"/>
-                          </a:solidFill>
-                          <a:latin typeface="Calibri"/>
-                        </a:defRPr>
-                      </a:pPr>
-                      <a:r>
-                        <a:t>Instance-based</a:t>
-                      </a:r>
-                    </a:p>
-                  </a:txBody>
-                  <a:tcPr>
-                    <a:solidFill>
-                      <a:srgbClr val="FFFFFF"/>
-                    </a:solidFill>
-                  </a:tcPr>
-                </a:tc>
-              </a:tr>
-              <a:tr h="365760">
-                <a:tc>
-                  <a:txBody>
-                    <a:bodyPr/>
-                    <a:lstStyle/>
-                    <a:p>
-                      <a:pPr>
-                        <a:defRPr sz="1100">
-                          <a:solidFill>
-                            <a:srgbClr val="1A1A1A"/>
-                          </a:solidFill>
-                          <a:latin typeface="Calibri"/>
-                        </a:defRPr>
-                      </a:pPr>
-                      <a:r>
-                        <a:t>4</a:t>
-                      </a:r>
-                    </a:p>
-                  </a:txBody>
-                  <a:tcPr>
-                    <a:solidFill>
-                      <a:srgbClr val="D6E4F0"/>
-                    </a:solidFill>
-                  </a:tcPr>
-                </a:tc>
-                <a:tc>
-                  <a:txBody>
-                    <a:bodyPr/>
-                    <a:lstStyle/>
-                    <a:p>
-                      <a:pPr>
-                        <a:defRPr sz="1100">
-                          <a:solidFill>
-                            <a:srgbClr val="1A1A1A"/>
-                          </a:solidFill>
-                          <a:latin typeface="Calibri"/>
-                        </a:defRPr>
-                      </a:pPr>
-                      <a:r>
-                        <a:t>SVM</a:t>
-                      </a:r>
-                    </a:p>
-                  </a:txBody>
-                  <a:tcPr>
-                    <a:solidFill>
-                      <a:srgbClr val="D6E4F0"/>
-                    </a:solidFill>
-                  </a:tcPr>
-                </a:tc>
-                <a:tc>
-                  <a:txBody>
-                    <a:bodyPr/>
-                    <a:lstStyle/>
-                    <a:p>
-                      <a:pPr>
-                        <a:defRPr sz="1100">
-                          <a:solidFill>
-                            <a:srgbClr val="1A1A1A"/>
-                          </a:solidFill>
-                          <a:latin typeface="Calibri"/>
-                        </a:defRPr>
-                      </a:pPr>
-                      <a:r>
-                        <a:t>80.15%</a:t>
-                      </a:r>
-                    </a:p>
-                  </a:txBody>
-                  <a:tcPr>
-                    <a:solidFill>
-                      <a:srgbClr val="D6E4F0"/>
-                    </a:solidFill>
-                  </a:tcPr>
-                </a:tc>
-                <a:tc>
-                  <a:txBody>
-                    <a:bodyPr/>
-                    <a:lstStyle/>
-                    <a:p>
-                      <a:pPr>
-                        <a:defRPr sz="1100">
-                          <a:solidFill>
-                            <a:srgbClr val="1A1A1A"/>
-                          </a:solidFill>
-                          <a:latin typeface="Calibri"/>
-                        </a:defRPr>
-                      </a:pPr>
-                      <a:r>
-                        <a:t>±8.43%</a:t>
-                      </a:r>
-                    </a:p>
-                  </a:txBody>
-                  <a:tcPr>
-                    <a:solidFill>
-                      <a:srgbClr val="D6E4F0"/>
-                    </a:solidFill>
-                  </a:tcPr>
-                </a:tc>
-                <a:tc>
-                  <a:txBody>
-                    <a:bodyPr/>
-                    <a:lstStyle/>
-                    <a:p>
-                      <a:pPr>
-                        <a:defRPr sz="1100">
-                          <a:solidFill>
-                            <a:srgbClr val="1A1A1A"/>
-                          </a:solidFill>
-                          <a:latin typeface="Calibri"/>
-                        </a:defRPr>
-                      </a:pPr>
-                      <a:r>
-                        <a:t>Kernel-based</a:t>
-                      </a:r>
-                    </a:p>
-                  </a:txBody>
-                  <a:tcPr>
-                    <a:solidFill>
-                      <a:srgbClr val="D6E4F0"/>
-                    </a:solidFill>
-                  </a:tcPr>
-                </a:tc>
-              </a:tr>
-              <a:tr h="365760">
-                <a:tc>
-                  <a:txBody>
-                    <a:bodyPr/>
-                    <a:lstStyle/>
-                    <a:p>
-                      <a:pPr>
-                        <a:defRPr sz="1100">
-                          <a:solidFill>
-                            <a:srgbClr val="1A1A1A"/>
-                          </a:solidFill>
-                          <a:latin typeface="Calibri"/>
-                        </a:defRPr>
-                      </a:pPr>
-                      <a:r>
-                        <a:t>5</a:t>
-                      </a:r>
-                    </a:p>
-                  </a:txBody>
-                  <a:tcPr>
-                    <a:solidFill>
-                      <a:srgbClr val="FFFFFF"/>
-                    </a:solidFill>
-                  </a:tcPr>
-                </a:tc>
-                <a:tc>
-                  <a:txBody>
-                    <a:bodyPr/>
-                    <a:lstStyle/>
-                    <a:p>
-                      <a:pPr>
-                        <a:defRPr sz="1100">
-                          <a:solidFill>
-                            <a:srgbClr val="1A1A1A"/>
-                          </a:solidFill>
-                          <a:latin typeface="Calibri"/>
-                        </a:defRPr>
-                      </a:pPr>
-                      <a:r>
-                        <a:t>Logistic Regression</a:t>
-                      </a:r>
-                    </a:p>
-                  </a:txBody>
-                  <a:tcPr>
-                    <a:solidFill>
-                      <a:srgbClr val="FFFFFF"/>
-                    </a:solidFill>
-                  </a:tcPr>
-                </a:tc>
-                <a:tc>
-                  <a:txBody>
-                    <a:bodyPr/>
-                    <a:lstStyle/>
-                    <a:p>
-                      <a:pPr>
-                        <a:defRPr sz="1100">
-                          <a:solidFill>
-                            <a:srgbClr val="1A1A1A"/>
-                          </a:solidFill>
-                          <a:latin typeface="Calibri"/>
-                        </a:defRPr>
-                      </a:pPr>
-                      <a:r>
-                        <a:t>79.69%</a:t>
-                      </a:r>
-                    </a:p>
-                  </a:txBody>
-                  <a:tcPr>
-                    <a:solidFill>
-                      <a:srgbClr val="FFFFFF"/>
-                    </a:solidFill>
-                  </a:tcPr>
-                </a:tc>
-                <a:tc>
-                  <a:txBody>
-                    <a:bodyPr/>
-                    <a:lstStyle/>
-                    <a:p>
-                      <a:pPr>
-                        <a:defRPr sz="1100">
-                          <a:solidFill>
-                            <a:srgbClr val="1A1A1A"/>
-                          </a:solidFill>
-                          <a:latin typeface="Calibri"/>
-                        </a:defRPr>
-                      </a:pPr>
-                      <a:r>
-                        <a:t>±7.01%</a:t>
-                      </a:r>
-                    </a:p>
-                  </a:txBody>
-                  <a:tcPr>
-                    <a:solidFill>
-                      <a:srgbClr val="FFFFFF"/>
-                    </a:solidFill>
-                  </a:tcPr>
-                </a:tc>
-                <a:tc>
-                  <a:txBody>
-                    <a:bodyPr/>
-                    <a:lstStyle/>
-                    <a:p>
-                      <a:pPr>
-                        <a:defRPr sz="1100">
-                          <a:solidFill>
-                            <a:srgbClr val="1A1A1A"/>
-                          </a:solidFill>
-                          <a:latin typeface="Calibri"/>
-                        </a:defRPr>
-                      </a:pPr>
-                      <a:r>
-                        <a:t>Linear</a:t>
-                      </a:r>
-                    </a:p>
-                  </a:txBody>
-                  <a:tcPr>
-                    <a:solidFill>
-                      <a:srgbClr val="FFFFFF"/>
-                    </a:solidFill>
-                  </a:tcPr>
-                </a:tc>
-              </a:tr>
-              <a:tr h="365760">
-                <a:tc>
-                  <a:txBody>
-                    <a:bodyPr/>
-                    <a:lstStyle/>
-                    <a:p>
-                      <a:pPr>
-                        <a:defRPr sz="1100">
-                          <a:solidFill>
-                            <a:srgbClr val="1A1A1A"/>
-                          </a:solidFill>
-                          <a:latin typeface="Calibri"/>
-                        </a:defRPr>
-                      </a:pPr>
-                      <a:r>
-                        <a:t>6</a:t>
-                      </a:r>
-                    </a:p>
-                  </a:txBody>
-                  <a:tcPr>
-                    <a:solidFill>
-                      <a:srgbClr val="D6E4F0"/>
-                    </a:solidFill>
-                  </a:tcPr>
-                </a:tc>
-                <a:tc>
-                  <a:txBody>
-                    <a:bodyPr/>
-                    <a:lstStyle/>
-                    <a:p>
-                      <a:pPr>
-                        <a:defRPr sz="1100">
-                          <a:solidFill>
-                            <a:srgbClr val="1A1A1A"/>
-                          </a:solidFill>
-                          <a:latin typeface="Calibri"/>
-                        </a:defRPr>
-                      </a:pPr>
-                      <a:r>
-                        <a:t>AdaBoost</a:t>
-                      </a:r>
-                    </a:p>
-                  </a:txBody>
-                  <a:tcPr>
-                    <a:solidFill>
-                      <a:srgbClr val="D6E4F0"/>
-                    </a:solidFill>
-                  </a:tcPr>
-                </a:tc>
-                <a:tc>
-                  <a:txBody>
-                    <a:bodyPr/>
-                    <a:lstStyle/>
-                    <a:p>
-                      <a:pPr>
-                        <a:defRPr sz="1100">
-                          <a:solidFill>
-                            <a:srgbClr val="1A1A1A"/>
-                          </a:solidFill>
-                          <a:latin typeface="Calibri"/>
-                        </a:defRPr>
-                      </a:pPr>
-                      <a:r>
-                        <a:t>78.97%</a:t>
-                      </a:r>
-                    </a:p>
-                  </a:txBody>
-                  <a:tcPr>
-                    <a:solidFill>
-                      <a:srgbClr val="D6E4F0"/>
-                    </a:solidFill>
-                  </a:tcPr>
-                </a:tc>
-                <a:tc>
-                  <a:txBody>
-                    <a:bodyPr/>
-                    <a:lstStyle/>
-                    <a:p>
-                      <a:pPr>
-                        <a:defRPr sz="1100">
-                          <a:solidFill>
-                            <a:srgbClr val="1A1A1A"/>
-                          </a:solidFill>
-                          <a:latin typeface="Calibri"/>
-                        </a:defRPr>
-                      </a:pPr>
-                      <a:r>
-                        <a:t>±6.87%</a:t>
-                      </a:r>
-                    </a:p>
-                  </a:txBody>
-                  <a:tcPr>
-                    <a:solidFill>
-                      <a:srgbClr val="D6E4F0"/>
-                    </a:solidFill>
-                  </a:tcPr>
-                </a:tc>
-                <a:tc>
-                  <a:txBody>
-                    <a:bodyPr/>
-                    <a:lstStyle/>
-                    <a:p>
-                      <a:pPr>
-                        <a:defRPr sz="1100">
-                          <a:solidFill>
-                            <a:srgbClr val="1A1A1A"/>
-                          </a:solidFill>
-                          <a:latin typeface="Calibri"/>
-                        </a:defRPr>
-                      </a:pPr>
-                      <a:r>
-                        <a:t>Ensemble (Boosting)</a:t>
-                      </a:r>
-                    </a:p>
-                  </a:txBody>
-                  <a:tcPr>
-                    <a:solidFill>
-                      <a:srgbClr val="D6E4F0"/>
-                    </a:solidFill>
-                  </a:tcPr>
-                </a:tc>
-              </a:tr>
-              <a:tr h="365760">
-                <a:tc>
-                  <a:txBody>
-                    <a:bodyPr/>
-                    <a:lstStyle/>
-                    <a:p>
-                      <a:pPr>
-                        <a:defRPr sz="1100">
-                          <a:solidFill>
-                            <a:srgbClr val="1A1A1A"/>
-                          </a:solidFill>
-                          <a:latin typeface="Calibri"/>
-                        </a:defRPr>
-                      </a:pPr>
-                      <a:r>
-                        <a:t>7</a:t>
-                      </a:r>
-                    </a:p>
-                  </a:txBody>
-                  <a:tcPr>
-                    <a:solidFill>
-                      <a:srgbClr val="FFFFFF"/>
-                    </a:solidFill>
-                  </a:tcPr>
-                </a:tc>
-                <a:tc>
-                  <a:txBody>
-                    <a:bodyPr/>
-                    <a:lstStyle/>
-                    <a:p>
-                      <a:pPr>
-                        <a:defRPr sz="1100">
-                          <a:solidFill>
-                            <a:srgbClr val="1A1A1A"/>
-                          </a:solidFill>
-                          <a:latin typeface="Calibri"/>
-                        </a:defRPr>
-                      </a:pPr>
-                      <a:r>
-                        <a:t>Decision Tree</a:t>
-                      </a:r>
-                    </a:p>
-                  </a:txBody>
-                  <a:tcPr>
-                    <a:solidFill>
-                      <a:srgbClr val="FFFFFF"/>
-                    </a:solidFill>
-                  </a:tcPr>
-                </a:tc>
-                <a:tc>
-                  <a:txBody>
-                    <a:bodyPr/>
-                    <a:lstStyle/>
-                    <a:p>
-                      <a:pPr>
-                        <a:defRPr sz="1100">
-                          <a:solidFill>
-                            <a:srgbClr val="1A1A1A"/>
-                          </a:solidFill>
-                          <a:latin typeface="Calibri"/>
-                        </a:defRPr>
-                      </a:pPr>
-                      <a:r>
-                        <a:t>73.95%</a:t>
-                      </a:r>
-                    </a:p>
-                  </a:txBody>
-                  <a:tcPr>
-                    <a:solidFill>
-                      <a:srgbClr val="FFFFFF"/>
-                    </a:solidFill>
-                  </a:tcPr>
-                </a:tc>
-                <a:tc>
-                  <a:txBody>
-                    <a:bodyPr/>
-                    <a:lstStyle/>
-                    <a:p>
-                      <a:pPr>
-                        <a:defRPr sz="1100">
-                          <a:solidFill>
-                            <a:srgbClr val="1A1A1A"/>
-                          </a:solidFill>
-                          <a:latin typeface="Calibri"/>
-                        </a:defRPr>
-                      </a:pPr>
-                      <a:r>
-                        <a:t>±7.26%</a:t>
-                      </a:r>
-                    </a:p>
-                  </a:txBody>
-                  <a:tcPr>
-                    <a:solidFill>
-                      <a:srgbClr val="FFFFFF"/>
-                    </a:solidFill>
-                  </a:tcPr>
-                </a:tc>
-                <a:tc>
-                  <a:txBody>
-                    <a:bodyPr/>
-                    <a:lstStyle/>
-                    <a:p>
-                      <a:pPr>
-                        <a:defRPr sz="1100">
-                          <a:solidFill>
-                            <a:srgbClr val="1A1A1A"/>
-                          </a:solidFill>
-                          <a:latin typeface="Calibri"/>
-                        </a:defRPr>
-                      </a:pPr>
-                      <a:r>
-                        <a:t>Tree-based</a:t>
-                      </a:r>
-                    </a:p>
-                  </a:txBody>
-                  <a:tcPr>
-                    <a:solidFill>
-                      <a:srgbClr val="FFFFFF"/>
-                    </a:solidFill>
-                  </a:tcPr>
-                </a:tc>
-              </a:tr>
-            </a:tbl>
-          </a:graphicData>
-        </a:graphic>
-      </p:graphicFrame>
+      <p:pic>
+        <p:nvPicPr>
+          <p:cNvPr id="5" name="Picture 4" descr="algorithm_comparison.png"/>
+          <p:cNvPicPr>
+            <a:picLocks noChangeAspect="1"/>
+          </p:cNvPicPr>
+          <p:nvPr/>
+        </p:nvPicPr>
+        <p:blipFill>
+          <a:blip r:embed="rId2"/>
+          <a:stretch>
+            <a:fillRect/>
+          </a:stretch>
+        </p:blipFill>
+        <p:spPr>
+          <a:xfrm>
+            <a:off x="457200" y="1188720"/>
+            <a:ext cx="11247120" cy="4572000"/>
+          </a:xfrm>
+          <a:prstGeom prst="rect">
+            <a:avLst/>
+          </a:prstGeom>
+        </p:spPr>
+      </p:pic>
       <p:sp>
         <p:nvSpPr>
           <p:cNvPr id="6" name="Rectangle 5"/>
@@ -15428,8 +14383,8 @@
         </p:nvSpPr>
         <p:spPr>
           <a:xfrm>
-            <a:off x="1371600" y="4846320"/>
-            <a:ext cx="9418320" cy="640080"/>
+            <a:off x="1371600" y="5943600"/>
+            <a:ext cx="9418320" cy="457200"/>
           </a:xfrm>
           <a:prstGeom prst="rect">
             <a:avLst/>
@@ -15474,8 +14429,8 @@
         </p:nvSpPr>
         <p:spPr>
           <a:xfrm>
-            <a:off x="1554480" y="4892040"/>
-            <a:ext cx="9052560" cy="548640"/>
+            <a:off x="1554480" y="5989320"/>
+            <a:ext cx="9052560" cy="365760"/>
           </a:xfrm>
           <a:prstGeom prst="rect">
             <a:avLst/>
@@ -15489,7 +14444,7 @@
           <a:lstStyle/>
           <a:p>
             <a:pPr algn="l">
-              <a:defRPr sz="1300" b="0" i="0">
+              <a:defRPr sz="1200" b="0" i="0">
                 <a:solidFill>
                   <a:srgbClr val="1F4E79"/>
                 </a:solidFill>
@@ -15497,7 +14452,7 @@
               </a:defRPr>
             </a:pPr>
             <a:r>
-              <a:t>Random Forest selected — highest cross-validation accuracy (85.04%) with good stability across folds. Ensemble of 100 decision trees reduces overfitting risk.</a:t>
+              <a:t>Random Forest wins with 85.04% — ensemble of 100 trees reduces overfitting while handling mixed feature types.</a:t>
             </a:r>
           </a:p>
         </p:txBody>
@@ -15744,7 +14699,7 @@
         <p:spPr>
           <a:xfrm>
             <a:off x="731520" y="1188720"/>
-            <a:ext cx="4572000" cy="274320"/>
+            <a:ext cx="5486400" cy="274320"/>
           </a:xfrm>
           <a:prstGeom prst="rect">
             <a:avLst/>
@@ -15771,16 +14726,64 @@
           </a:p>
         </p:txBody>
       </p:sp>
-      <p:sp>
-        <p:nvSpPr>
-          <p:cNvPr id="6" name="Rectangle 5"/>
+      <p:pic>
+        <p:nvPicPr>
+          <p:cNvPr id="6" name="Picture 5" descr="test_metrics.png"/>
+          <p:cNvPicPr>
+            <a:picLocks noChangeAspect="1"/>
+          </p:cNvPicPr>
+          <p:nvPr/>
+        </p:nvPicPr>
+        <p:blipFill>
+          <a:blip r:embed="rId2"/>
+          <a:stretch>
+            <a:fillRect/>
+          </a:stretch>
+        </p:blipFill>
+        <p:spPr>
+          <a:xfrm>
+            <a:off x="274320" y="1371600"/>
+            <a:ext cx="6858000" cy="3200400"/>
+          </a:xfrm>
+          <a:prstGeom prst="rect">
+            <a:avLst/>
+          </a:prstGeom>
+        </p:spPr>
+      </p:pic>
+      <p:pic>
+        <p:nvPicPr>
+          <p:cNvPr id="7" name="Picture 6" descr="confusion_matrix.png"/>
+          <p:cNvPicPr>
+            <a:picLocks noChangeAspect="1"/>
+          </p:cNvPicPr>
+          <p:nvPr/>
+        </p:nvPicPr>
+        <p:blipFill>
+          <a:blip r:embed="rId3"/>
+          <a:stretch>
+            <a:fillRect/>
+          </a:stretch>
+        </p:blipFill>
+        <p:spPr>
+          <a:xfrm>
+            <a:off x="7315200" y="1188720"/>
+            <a:ext cx="4389120" cy="3657600"/>
+          </a:xfrm>
+          <a:prstGeom prst="rect">
+            <a:avLst/>
+          </a:prstGeom>
+        </p:spPr>
+      </p:pic>
+      <p:sp>
+        <p:nvSpPr>
+          <p:cNvPr id="8" name="Rectangle 7"/>
           <p:cNvSpPr/>
           <p:nvPr/>
         </p:nvSpPr>
         <p:spPr>
           <a:xfrm>
-            <a:off x="731520" y="1554480"/>
-            <a:ext cx="2057400" cy="914400"/>
+            <a:off x="731520" y="5120640"/>
+            <a:ext cx="10698480" cy="914400"/>
           </a:xfrm>
           <a:prstGeom prst="rect">
             <a:avLst/>
@@ -15819,14 +14822,14 @@
       </p:sp>
       <p:sp>
         <p:nvSpPr>
-          <p:cNvPr id="7" name="TextBox 6"/>
+          <p:cNvPr id="9" name="TextBox 8"/>
           <p:cNvSpPr txBox="1"/>
           <p:nvPr/>
         </p:nvSpPr>
         <p:spPr>
           <a:xfrm>
-            <a:off x="731520" y="1600200"/>
-            <a:ext cx="2057400" cy="457200"/>
+            <a:off x="914400" y="5166360"/>
+            <a:ext cx="10332720" cy="274320"/>
           </a:xfrm>
           <a:prstGeom prst="rect">
             <a:avLst/>
@@ -15839,8 +14842,8 @@
           </a:bodyPr>
           <a:lstStyle/>
           <a:p>
-            <a:pPr algn="ctr">
-              <a:defRPr sz="2400" b="1" i="0">
+            <a:pPr algn="l">
+              <a:defRPr sz="1400" b="1" i="0">
                 <a:solidFill>
                   <a:srgbClr val="1F4E79"/>
                 </a:solidFill>
@@ -15848,21 +14851,21 @@
               </a:defRPr>
             </a:pPr>
             <a:r>
-              <a:t>81.97%</a:t>
-            </a:r>
-          </a:p>
-        </p:txBody>
-      </p:sp>
-      <p:sp>
-        <p:nvSpPr>
-          <p:cNvPr id="8" name="TextBox 7"/>
+              <a:t>Key Insight</a:t>
+            </a:r>
+          </a:p>
+        </p:txBody>
+      </p:sp>
+      <p:sp>
+        <p:nvSpPr>
+          <p:cNvPr id="10" name="TextBox 9"/>
           <p:cNvSpPr txBox="1"/>
           <p:nvPr/>
         </p:nvSpPr>
         <p:spPr>
           <a:xfrm>
-            <a:off x="731520" y="2057400"/>
-            <a:ext cx="2057400" cy="274320"/>
+            <a:off x="914400" y="5440680"/>
+            <a:ext cx="10332720" cy="457200"/>
           </a:xfrm>
           <a:prstGeom prst="rect">
             <a:avLst/>
@@ -15875,76 +14878,43 @@
           </a:bodyPr>
           <a:lstStyle/>
           <a:p>
-            <a:pPr algn="ctr">
-              <a:defRPr sz="1100" b="0" i="0">
-                <a:solidFill>
-                  <a:srgbClr val="5F5F5F"/>
-                </a:solidFill>
-                <a:latin typeface="Calibri"/>
-              </a:defRPr>
-            </a:pPr>
-            <a:r>
-              <a:t>Accuracy</a:t>
-            </a:r>
-          </a:p>
-        </p:txBody>
-      </p:sp>
-      <p:sp>
-        <p:nvSpPr>
-          <p:cNvPr id="9" name="Rectangle 8"/>
-          <p:cNvSpPr/>
-          <p:nvPr/>
-        </p:nvSpPr>
-        <p:spPr>
-          <a:xfrm>
-            <a:off x="2971800" y="1554480"/>
-            <a:ext cx="2057400" cy="914400"/>
-          </a:xfrm>
-          <a:prstGeom prst="rect">
-            <a:avLst/>
-          </a:prstGeom>
-          <a:solidFill>
-            <a:srgbClr val="D6E4F0"/>
-          </a:solidFill>
-          <a:ln w="6350">
-            <a:solidFill>
-              <a:srgbClr val="DDDDDD"/>
-            </a:solidFill>
-          </a:ln>
-          <a:effectLst/>
-        </p:spPr>
-        <p:style>
-          <a:lnRef idx="1">
-            <a:schemeClr val="accent1"/>
-          </a:lnRef>
-          <a:fillRef idx="3">
-            <a:schemeClr val="accent1"/>
-          </a:fillRef>
-          <a:effectRef idx="2">
-            <a:schemeClr val="accent1"/>
-          </a:effectRef>
-          <a:fontRef idx="minor">
-            <a:schemeClr val="lt1"/>
-          </a:fontRef>
-        </p:style>
-        <p:txBody>
-          <a:bodyPr rtlCol="0" anchor="ctr"/>
-          <a:lstStyle/>
-          <a:p>
-            <a:pPr algn="ctr"/>
-          </a:p>
-        </p:txBody>
-      </p:sp>
-      <p:sp>
-        <p:nvSpPr>
-          <p:cNvPr id="10" name="TextBox 9"/>
+            <a:pPr algn="l">
+              <a:defRPr sz="1200" b="0" i="0">
+                <a:solidFill>
+                  <a:srgbClr val="1A1A1A"/>
+                </a:solidFill>
+                <a:latin typeface="Calibri"/>
+              </a:defRPr>
+            </a:pPr>
+          </a:p>
+          <a:p>
+            <a:pPr algn="l">
+              <a:spcBef>
+                <a:spcPts val="200"/>
+              </a:spcBef>
+              <a:defRPr sz="1200" b="0">
+                <a:solidFill>
+                  <a:srgbClr val="1A1A1A"/>
+                </a:solidFill>
+                <a:latin typeface="Calibri"/>
+              </a:defRPr>
+            </a:pPr>
+            <a:r>
+              <a:t>Recall = 96.97%  —  Only 1 false negative out of 33 disease cases. In medical screening, missing a disease case is far more dangerous than a false alarm.</a:t>
+            </a:r>
+          </a:p>
+        </p:txBody>
+      </p:sp>
+      <p:sp>
+        <p:nvSpPr>
+          <p:cNvPr id="11" name="TextBox 10"/>
           <p:cNvSpPr txBox="1"/>
           <p:nvPr/>
         </p:nvSpPr>
         <p:spPr>
           <a:xfrm>
-            <a:off x="2971800" y="1600200"/>
-            <a:ext cx="2057400" cy="457200"/>
+            <a:off x="731520" y="6309360"/>
+            <a:ext cx="10698480" cy="274320"/>
           </a:xfrm>
           <a:prstGeom prst="rect">
             <a:avLst/>
@@ -15957,857 +14927,6 @@
           </a:bodyPr>
           <a:lstStyle/>
           <a:p>
-            <a:pPr algn="ctr">
-              <a:defRPr sz="2400" b="1" i="0">
-                <a:solidFill>
-                  <a:srgbClr val="1F4E79"/>
-                </a:solidFill>
-                <a:latin typeface="Calibri"/>
-              </a:defRPr>
-            </a:pPr>
-            <a:r>
-              <a:t>76.19%</a:t>
-            </a:r>
-          </a:p>
-        </p:txBody>
-      </p:sp>
-      <p:sp>
-        <p:nvSpPr>
-          <p:cNvPr id="11" name="TextBox 10"/>
-          <p:cNvSpPr txBox="1"/>
-          <p:nvPr/>
-        </p:nvSpPr>
-        <p:spPr>
-          <a:xfrm>
-            <a:off x="2971800" y="2057400"/>
-            <a:ext cx="2057400" cy="274320"/>
-          </a:xfrm>
-          <a:prstGeom prst="rect">
-            <a:avLst/>
-          </a:prstGeom>
-          <a:noFill/>
-        </p:spPr>
-        <p:txBody>
-          <a:bodyPr wrap="square">
-            <a:spAutoFit/>
-          </a:bodyPr>
-          <a:lstStyle/>
-          <a:p>
-            <a:pPr algn="ctr">
-              <a:defRPr sz="1100" b="0" i="0">
-                <a:solidFill>
-                  <a:srgbClr val="5F5F5F"/>
-                </a:solidFill>
-                <a:latin typeface="Calibri"/>
-              </a:defRPr>
-            </a:pPr>
-            <a:r>
-              <a:t>Precision</a:t>
-            </a:r>
-          </a:p>
-        </p:txBody>
-      </p:sp>
-      <p:sp>
-        <p:nvSpPr>
-          <p:cNvPr id="12" name="Rectangle 11"/>
-          <p:cNvSpPr/>
-          <p:nvPr/>
-        </p:nvSpPr>
-        <p:spPr>
-          <a:xfrm>
-            <a:off x="5212080" y="1554480"/>
-            <a:ext cx="2057400" cy="914400"/>
-          </a:xfrm>
-          <a:prstGeom prst="rect">
-            <a:avLst/>
-          </a:prstGeom>
-          <a:solidFill>
-            <a:srgbClr val="D6E4F0"/>
-          </a:solidFill>
-          <a:ln w="6350">
-            <a:solidFill>
-              <a:srgbClr val="DDDDDD"/>
-            </a:solidFill>
-          </a:ln>
-          <a:effectLst/>
-        </p:spPr>
-        <p:style>
-          <a:lnRef idx="1">
-            <a:schemeClr val="accent1"/>
-          </a:lnRef>
-          <a:fillRef idx="3">
-            <a:schemeClr val="accent1"/>
-          </a:fillRef>
-          <a:effectRef idx="2">
-            <a:schemeClr val="accent1"/>
-          </a:effectRef>
-          <a:fontRef idx="minor">
-            <a:schemeClr val="lt1"/>
-          </a:fontRef>
-        </p:style>
-        <p:txBody>
-          <a:bodyPr rtlCol="0" anchor="ctr"/>
-          <a:lstStyle/>
-          <a:p>
-            <a:pPr algn="ctr"/>
-          </a:p>
-        </p:txBody>
-      </p:sp>
-      <p:sp>
-        <p:nvSpPr>
-          <p:cNvPr id="13" name="TextBox 12"/>
-          <p:cNvSpPr txBox="1"/>
-          <p:nvPr/>
-        </p:nvSpPr>
-        <p:spPr>
-          <a:xfrm>
-            <a:off x="5212080" y="1600200"/>
-            <a:ext cx="2057400" cy="457200"/>
-          </a:xfrm>
-          <a:prstGeom prst="rect">
-            <a:avLst/>
-          </a:prstGeom>
-          <a:noFill/>
-        </p:spPr>
-        <p:txBody>
-          <a:bodyPr wrap="square">
-            <a:spAutoFit/>
-          </a:bodyPr>
-          <a:lstStyle/>
-          <a:p>
-            <a:pPr algn="ctr">
-              <a:defRPr sz="2400" b="1" i="0">
-                <a:solidFill>
-                  <a:srgbClr val="1F4E79"/>
-                </a:solidFill>
-                <a:latin typeface="Calibri"/>
-              </a:defRPr>
-            </a:pPr>
-            <a:r>
-              <a:t>96.97%</a:t>
-            </a:r>
-          </a:p>
-        </p:txBody>
-      </p:sp>
-      <p:sp>
-        <p:nvSpPr>
-          <p:cNvPr id="14" name="TextBox 13"/>
-          <p:cNvSpPr txBox="1"/>
-          <p:nvPr/>
-        </p:nvSpPr>
-        <p:spPr>
-          <a:xfrm>
-            <a:off x="5212080" y="2057400"/>
-            <a:ext cx="2057400" cy="274320"/>
-          </a:xfrm>
-          <a:prstGeom prst="rect">
-            <a:avLst/>
-          </a:prstGeom>
-          <a:noFill/>
-        </p:spPr>
-        <p:txBody>
-          <a:bodyPr wrap="square">
-            <a:spAutoFit/>
-          </a:bodyPr>
-          <a:lstStyle/>
-          <a:p>
-            <a:pPr algn="ctr">
-              <a:defRPr sz="1100" b="0" i="0">
-                <a:solidFill>
-                  <a:srgbClr val="5F5F5F"/>
-                </a:solidFill>
-                <a:latin typeface="Calibri"/>
-              </a:defRPr>
-            </a:pPr>
-            <a:r>
-              <a:t>Recall</a:t>
-            </a:r>
-          </a:p>
-        </p:txBody>
-      </p:sp>
-      <p:sp>
-        <p:nvSpPr>
-          <p:cNvPr id="15" name="Rectangle 14"/>
-          <p:cNvSpPr/>
-          <p:nvPr/>
-        </p:nvSpPr>
-        <p:spPr>
-          <a:xfrm>
-            <a:off x="7452360" y="1554480"/>
-            <a:ext cx="2057400" cy="914400"/>
-          </a:xfrm>
-          <a:prstGeom prst="rect">
-            <a:avLst/>
-          </a:prstGeom>
-          <a:solidFill>
-            <a:srgbClr val="D6E4F0"/>
-          </a:solidFill>
-          <a:ln w="6350">
-            <a:solidFill>
-              <a:srgbClr val="DDDDDD"/>
-            </a:solidFill>
-          </a:ln>
-          <a:effectLst/>
-        </p:spPr>
-        <p:style>
-          <a:lnRef idx="1">
-            <a:schemeClr val="accent1"/>
-          </a:lnRef>
-          <a:fillRef idx="3">
-            <a:schemeClr val="accent1"/>
-          </a:fillRef>
-          <a:effectRef idx="2">
-            <a:schemeClr val="accent1"/>
-          </a:effectRef>
-          <a:fontRef idx="minor">
-            <a:schemeClr val="lt1"/>
-          </a:fontRef>
-        </p:style>
-        <p:txBody>
-          <a:bodyPr rtlCol="0" anchor="ctr"/>
-          <a:lstStyle/>
-          <a:p>
-            <a:pPr algn="ctr"/>
-          </a:p>
-        </p:txBody>
-      </p:sp>
-      <p:sp>
-        <p:nvSpPr>
-          <p:cNvPr id="16" name="TextBox 15"/>
-          <p:cNvSpPr txBox="1"/>
-          <p:nvPr/>
-        </p:nvSpPr>
-        <p:spPr>
-          <a:xfrm>
-            <a:off x="7452360" y="1600200"/>
-            <a:ext cx="2057400" cy="457200"/>
-          </a:xfrm>
-          <a:prstGeom prst="rect">
-            <a:avLst/>
-          </a:prstGeom>
-          <a:noFill/>
-        </p:spPr>
-        <p:txBody>
-          <a:bodyPr wrap="square">
-            <a:spAutoFit/>
-          </a:bodyPr>
-          <a:lstStyle/>
-          <a:p>
-            <a:pPr algn="ctr">
-              <a:defRPr sz="2400" b="1" i="0">
-                <a:solidFill>
-                  <a:srgbClr val="1F4E79"/>
-                </a:solidFill>
-                <a:latin typeface="Calibri"/>
-              </a:defRPr>
-            </a:pPr>
-            <a:r>
-              <a:t>85.33%</a:t>
-            </a:r>
-          </a:p>
-        </p:txBody>
-      </p:sp>
-      <p:sp>
-        <p:nvSpPr>
-          <p:cNvPr id="17" name="TextBox 16"/>
-          <p:cNvSpPr txBox="1"/>
-          <p:nvPr/>
-        </p:nvSpPr>
-        <p:spPr>
-          <a:xfrm>
-            <a:off x="7452360" y="2057400"/>
-            <a:ext cx="2057400" cy="274320"/>
-          </a:xfrm>
-          <a:prstGeom prst="rect">
-            <a:avLst/>
-          </a:prstGeom>
-          <a:noFill/>
-        </p:spPr>
-        <p:txBody>
-          <a:bodyPr wrap="square">
-            <a:spAutoFit/>
-          </a:bodyPr>
-          <a:lstStyle/>
-          <a:p>
-            <a:pPr algn="ctr">
-              <a:defRPr sz="1100" b="0" i="0">
-                <a:solidFill>
-                  <a:srgbClr val="5F5F5F"/>
-                </a:solidFill>
-                <a:latin typeface="Calibri"/>
-              </a:defRPr>
-            </a:pPr>
-            <a:r>
-              <a:t>F1-Score</a:t>
-            </a:r>
-          </a:p>
-        </p:txBody>
-      </p:sp>
-      <p:sp>
-        <p:nvSpPr>
-          <p:cNvPr id="18" name="Rectangle 17"/>
-          <p:cNvSpPr/>
-          <p:nvPr/>
-        </p:nvSpPr>
-        <p:spPr>
-          <a:xfrm>
-            <a:off x="9692640" y="1554480"/>
-            <a:ext cx="2057400" cy="914400"/>
-          </a:xfrm>
-          <a:prstGeom prst="rect">
-            <a:avLst/>
-          </a:prstGeom>
-          <a:solidFill>
-            <a:srgbClr val="D6E4F0"/>
-          </a:solidFill>
-          <a:ln w="6350">
-            <a:solidFill>
-              <a:srgbClr val="DDDDDD"/>
-            </a:solidFill>
-          </a:ln>
-          <a:effectLst/>
-        </p:spPr>
-        <p:style>
-          <a:lnRef idx="1">
-            <a:schemeClr val="accent1"/>
-          </a:lnRef>
-          <a:fillRef idx="3">
-            <a:schemeClr val="accent1"/>
-          </a:fillRef>
-          <a:effectRef idx="2">
-            <a:schemeClr val="accent1"/>
-          </a:effectRef>
-          <a:fontRef idx="minor">
-            <a:schemeClr val="lt1"/>
-          </a:fontRef>
-        </p:style>
-        <p:txBody>
-          <a:bodyPr rtlCol="0" anchor="ctr"/>
-          <a:lstStyle/>
-          <a:p>
-            <a:pPr algn="ctr"/>
-          </a:p>
-        </p:txBody>
-      </p:sp>
-      <p:sp>
-        <p:nvSpPr>
-          <p:cNvPr id="19" name="TextBox 18"/>
-          <p:cNvSpPr txBox="1"/>
-          <p:nvPr/>
-        </p:nvSpPr>
-        <p:spPr>
-          <a:xfrm>
-            <a:off x="9692640" y="1600200"/>
-            <a:ext cx="2057400" cy="457200"/>
-          </a:xfrm>
-          <a:prstGeom prst="rect">
-            <a:avLst/>
-          </a:prstGeom>
-          <a:noFill/>
-        </p:spPr>
-        <p:txBody>
-          <a:bodyPr wrap="square">
-            <a:spAutoFit/>
-          </a:bodyPr>
-          <a:lstStyle/>
-          <a:p>
-            <a:pPr algn="ctr">
-              <a:defRPr sz="2400" b="1" i="0">
-                <a:solidFill>
-                  <a:srgbClr val="1F4E79"/>
-                </a:solidFill>
-                <a:latin typeface="Calibri"/>
-              </a:defRPr>
-            </a:pPr>
-            <a:r>
-              <a:t>91.56%</a:t>
-            </a:r>
-          </a:p>
-        </p:txBody>
-      </p:sp>
-      <p:sp>
-        <p:nvSpPr>
-          <p:cNvPr id="20" name="TextBox 19"/>
-          <p:cNvSpPr txBox="1"/>
-          <p:nvPr/>
-        </p:nvSpPr>
-        <p:spPr>
-          <a:xfrm>
-            <a:off x="9692640" y="2057400"/>
-            <a:ext cx="2057400" cy="274320"/>
-          </a:xfrm>
-          <a:prstGeom prst="rect">
-            <a:avLst/>
-          </a:prstGeom>
-          <a:noFill/>
-        </p:spPr>
-        <p:txBody>
-          <a:bodyPr wrap="square">
-            <a:spAutoFit/>
-          </a:bodyPr>
-          <a:lstStyle/>
-          <a:p>
-            <a:pPr algn="ctr">
-              <a:defRPr sz="1100" b="0" i="0">
-                <a:solidFill>
-                  <a:srgbClr val="5F5F5F"/>
-                </a:solidFill>
-                <a:latin typeface="Calibri"/>
-              </a:defRPr>
-            </a:pPr>
-            <a:r>
-              <a:t>ROC-AUC</a:t>
-            </a:r>
-          </a:p>
-        </p:txBody>
-      </p:sp>
-      <p:sp>
-        <p:nvSpPr>
-          <p:cNvPr id="21" name="TextBox 20"/>
-          <p:cNvSpPr txBox="1"/>
-          <p:nvPr/>
-        </p:nvSpPr>
-        <p:spPr>
-          <a:xfrm>
-            <a:off x="731520" y="2834640"/>
-            <a:ext cx="4572000" cy="274320"/>
-          </a:xfrm>
-          <a:prstGeom prst="rect">
-            <a:avLst/>
-          </a:prstGeom>
-          <a:noFill/>
-        </p:spPr>
-        <p:txBody>
-          <a:bodyPr wrap="square">
-            <a:spAutoFit/>
-          </a:bodyPr>
-          <a:lstStyle/>
-          <a:p>
-            <a:pPr algn="l">
-              <a:defRPr sz="1400" b="1" i="0">
-                <a:solidFill>
-                  <a:srgbClr val="1A1A1A"/>
-                </a:solidFill>
-                <a:latin typeface="Calibri"/>
-              </a:defRPr>
-            </a:pPr>
-            <a:r>
-              <a:t>Confusion Matrix</a:t>
-            </a:r>
-          </a:p>
-        </p:txBody>
-      </p:sp>
-      <p:graphicFrame>
-        <p:nvGraphicFramePr>
-          <p:cNvPr id="22" name="Table 21"/>
-          <p:cNvGraphicFramePr>
-            <a:graphicFrameLocks noGrp="1"/>
-          </p:cNvGraphicFramePr>
-          <p:nvPr/>
-        </p:nvGraphicFramePr>
-        <p:xfrm>
-          <a:off x="731520" y="3200400"/>
-          <a:ext cx="5029200" cy="1097280"/>
-        </p:xfrm>
-        <a:graphic>
-          <a:graphicData uri="http://schemas.openxmlformats.org/drawingml/2006/table">
-            <a:tbl>
-              <a:tblPr firstRow="1" bandRow="1">
-                <a:tableStyleId>{5C22544A-7EE6-4342-B048-85BDC9FD1C3A}</a:tableStyleId>
-              </a:tblPr>
-              <a:tblGrid>
-                <a:gridCol w="1645920"/>
-                <a:gridCol w="1691640"/>
-                <a:gridCol w="1691640"/>
-              </a:tblGrid>
-              <a:tr h="365760">
-                <a:tc>
-                  <a:txBody>
-                    <a:bodyPr/>
-                    <a:lstStyle/>
-                    <a:p>
-                      <a:pPr>
-                        <a:defRPr sz="1100" b="1">
-                          <a:solidFill>
-                            <a:srgbClr val="FFFFFF"/>
-                          </a:solidFill>
-                          <a:latin typeface="Calibri"/>
-                        </a:defRPr>
-                      </a:pPr>
-                    </a:p>
-                  </a:txBody>
-                  <a:tcPr>
-                    <a:solidFill>
-                      <a:srgbClr val="1F4E79"/>
-                    </a:solidFill>
-                  </a:tcPr>
-                </a:tc>
-                <a:tc>
-                  <a:txBody>
-                    <a:bodyPr/>
-                    <a:lstStyle/>
-                    <a:p>
-                      <a:pPr>
-                        <a:defRPr sz="1100" b="1">
-                          <a:solidFill>
-                            <a:srgbClr val="FFFFFF"/>
-                          </a:solidFill>
-                          <a:latin typeface="Calibri"/>
-                        </a:defRPr>
-                      </a:pPr>
-                      <a:r>
-                        <a:t>Predicted: No Disease</a:t>
-                      </a:r>
-                    </a:p>
-                  </a:txBody>
-                  <a:tcPr>
-                    <a:solidFill>
-                      <a:srgbClr val="1F4E79"/>
-                    </a:solidFill>
-                  </a:tcPr>
-                </a:tc>
-                <a:tc>
-                  <a:txBody>
-                    <a:bodyPr/>
-                    <a:lstStyle/>
-                    <a:p>
-                      <a:pPr>
-                        <a:defRPr sz="1100" b="1">
-                          <a:solidFill>
-                            <a:srgbClr val="FFFFFF"/>
-                          </a:solidFill>
-                          <a:latin typeface="Calibri"/>
-                        </a:defRPr>
-                      </a:pPr>
-                      <a:r>
-                        <a:t>Predicted: Disease</a:t>
-                      </a:r>
-                    </a:p>
-                  </a:txBody>
-                  <a:tcPr>
-                    <a:solidFill>
-                      <a:srgbClr val="1F4E79"/>
-                    </a:solidFill>
-                  </a:tcPr>
-                </a:tc>
-              </a:tr>
-              <a:tr h="365760">
-                <a:tc>
-                  <a:txBody>
-                    <a:bodyPr/>
-                    <a:lstStyle/>
-                    <a:p>
-                      <a:pPr>
-                        <a:defRPr sz="1100">
-                          <a:solidFill>
-                            <a:srgbClr val="1A1A1A"/>
-                          </a:solidFill>
-                          <a:latin typeface="Calibri"/>
-                        </a:defRPr>
-                      </a:pPr>
-                      <a:r>
-                        <a:t>Actual: No Disease</a:t>
-                      </a:r>
-                    </a:p>
-                  </a:txBody>
-                  <a:tcPr>
-                    <a:solidFill>
-                      <a:srgbClr val="FFFFFF"/>
-                    </a:solidFill>
-                  </a:tcPr>
-                </a:tc>
-                <a:tc>
-                  <a:txBody>
-                    <a:bodyPr/>
-                    <a:lstStyle/>
-                    <a:p>
-                      <a:pPr>
-                        <a:defRPr sz="1100">
-                          <a:solidFill>
-                            <a:srgbClr val="1A1A1A"/>
-                          </a:solidFill>
-                          <a:latin typeface="Calibri"/>
-                        </a:defRPr>
-                      </a:pPr>
-                      <a:r>
-                        <a:t>TN = 18</a:t>
-                      </a:r>
-                    </a:p>
-                  </a:txBody>
-                  <a:tcPr>
-                    <a:solidFill>
-                      <a:srgbClr val="FFFFFF"/>
-                    </a:solidFill>
-                  </a:tcPr>
-                </a:tc>
-                <a:tc>
-                  <a:txBody>
-                    <a:bodyPr/>
-                    <a:lstStyle/>
-                    <a:p>
-                      <a:pPr>
-                        <a:defRPr sz="1100">
-                          <a:solidFill>
-                            <a:srgbClr val="1A1A1A"/>
-                          </a:solidFill>
-                          <a:latin typeface="Calibri"/>
-                        </a:defRPr>
-                      </a:pPr>
-                      <a:r>
-                        <a:t>FP = 10</a:t>
-                      </a:r>
-                    </a:p>
-                  </a:txBody>
-                  <a:tcPr>
-                    <a:solidFill>
-                      <a:srgbClr val="FFFFFF"/>
-                    </a:solidFill>
-                  </a:tcPr>
-                </a:tc>
-              </a:tr>
-              <a:tr h="365760">
-                <a:tc>
-                  <a:txBody>
-                    <a:bodyPr/>
-                    <a:lstStyle/>
-                    <a:p>
-                      <a:pPr>
-                        <a:defRPr sz="1100">
-                          <a:solidFill>
-                            <a:srgbClr val="1A1A1A"/>
-                          </a:solidFill>
-                          <a:latin typeface="Calibri"/>
-                        </a:defRPr>
-                      </a:pPr>
-                      <a:r>
-                        <a:t>Actual: Disease</a:t>
-                      </a:r>
-                    </a:p>
-                  </a:txBody>
-                  <a:tcPr>
-                    <a:solidFill>
-                      <a:srgbClr val="D6E4F0"/>
-                    </a:solidFill>
-                  </a:tcPr>
-                </a:tc>
-                <a:tc>
-                  <a:txBody>
-                    <a:bodyPr/>
-                    <a:lstStyle/>
-                    <a:p>
-                      <a:pPr>
-                        <a:defRPr sz="1100">
-                          <a:solidFill>
-                            <a:srgbClr val="1A1A1A"/>
-                          </a:solidFill>
-                          <a:latin typeface="Calibri"/>
-                        </a:defRPr>
-                      </a:pPr>
-                      <a:r>
-                        <a:t>FN = 1</a:t>
-                      </a:r>
-                    </a:p>
-                  </a:txBody>
-                  <a:tcPr>
-                    <a:solidFill>
-                      <a:srgbClr val="D6E4F0"/>
-                    </a:solidFill>
-                  </a:tcPr>
-                </a:tc>
-                <a:tc>
-                  <a:txBody>
-                    <a:bodyPr/>
-                    <a:lstStyle/>
-                    <a:p>
-                      <a:pPr>
-                        <a:defRPr sz="1100">
-                          <a:solidFill>
-                            <a:srgbClr val="1A1A1A"/>
-                          </a:solidFill>
-                          <a:latin typeface="Calibri"/>
-                        </a:defRPr>
-                      </a:pPr>
-                      <a:r>
-                        <a:t>TP = 32</a:t>
-                      </a:r>
-                    </a:p>
-                  </a:txBody>
-                  <a:tcPr>
-                    <a:solidFill>
-                      <a:srgbClr val="D6E4F0"/>
-                    </a:solidFill>
-                  </a:tcPr>
-                </a:tc>
-              </a:tr>
-            </a:tbl>
-          </a:graphicData>
-        </a:graphic>
-      </p:graphicFrame>
-      <p:sp>
-        <p:nvSpPr>
-          <p:cNvPr id="23" name="TextBox 22"/>
-          <p:cNvSpPr txBox="1"/>
-          <p:nvPr/>
-        </p:nvSpPr>
-        <p:spPr>
-          <a:xfrm>
-            <a:off x="6400800" y="2834640"/>
-            <a:ext cx="5029200" cy="274320"/>
-          </a:xfrm>
-          <a:prstGeom prst="rect">
-            <a:avLst/>
-          </a:prstGeom>
-          <a:noFill/>
-        </p:spPr>
-        <p:txBody>
-          <a:bodyPr wrap="square">
-            <a:spAutoFit/>
-          </a:bodyPr>
-          <a:lstStyle/>
-          <a:p>
-            <a:pPr algn="l">
-              <a:defRPr sz="1400" b="1" i="0">
-                <a:solidFill>
-                  <a:srgbClr val="1A1A1A"/>
-                </a:solidFill>
-                <a:latin typeface="Calibri"/>
-              </a:defRPr>
-            </a:pPr>
-            <a:r>
-              <a:t>Key Observation</a:t>
-            </a:r>
-          </a:p>
-        </p:txBody>
-      </p:sp>
-      <p:sp>
-        <p:nvSpPr>
-          <p:cNvPr id="24" name="TextBox 23"/>
-          <p:cNvSpPr txBox="1"/>
-          <p:nvPr/>
-        </p:nvSpPr>
-        <p:spPr>
-          <a:xfrm>
-            <a:off x="6400800" y="3200400"/>
-            <a:ext cx="5029200" cy="2743200"/>
-          </a:xfrm>
-          <a:prstGeom prst="rect">
-            <a:avLst/>
-          </a:prstGeom>
-          <a:noFill/>
-        </p:spPr>
-        <p:txBody>
-          <a:bodyPr wrap="square">
-            <a:spAutoFit/>
-          </a:bodyPr>
-          <a:lstStyle/>
-          <a:p>
-            <a:pPr algn="l">
-              <a:defRPr sz="1300" b="0" i="0">
-                <a:solidFill>
-                  <a:srgbClr val="1A1A1A"/>
-                </a:solidFill>
-                <a:latin typeface="Calibri"/>
-              </a:defRPr>
-            </a:pPr>
-          </a:p>
-          <a:p>
-            <a:pPr algn="l">
-              <a:spcBef>
-                <a:spcPts val="600"/>
-              </a:spcBef>
-              <a:defRPr sz="1800" b="1" i="0">
-                <a:solidFill>
-                  <a:srgbClr val="1F4E79"/>
-                </a:solidFill>
-                <a:latin typeface="Calibri"/>
-              </a:defRPr>
-            </a:pPr>
-            <a:r>
-              <a:t>Recall = 96.97%</a:t>
-            </a:r>
-          </a:p>
-          <a:p>
-            <a:pPr algn="l">
-              <a:spcBef>
-                <a:spcPts val="400"/>
-              </a:spcBef>
-              <a:defRPr sz="600" b="0" i="0">
-                <a:solidFill>
-                  <a:srgbClr val="1A1A1A"/>
-                </a:solidFill>
-                <a:latin typeface="Calibri"/>
-              </a:defRPr>
-            </a:pPr>
-          </a:p>
-          <a:p>
-            <a:pPr algn="l">
-              <a:spcBef>
-                <a:spcPts val="400"/>
-              </a:spcBef>
-              <a:defRPr sz="1300" b="0" i="0">
-                <a:solidFill>
-                  <a:srgbClr val="1A1A1A"/>
-                </a:solidFill>
-                <a:latin typeface="Calibri"/>
-              </a:defRPr>
-            </a:pPr>
-            <a:r>
-              <a:t>Out of 33 patients with heart disease, the model correctly identified 32.</a:t>
-            </a:r>
-          </a:p>
-          <a:p>
-            <a:pPr algn="l">
-              <a:spcBef>
-                <a:spcPts val="400"/>
-              </a:spcBef>
-              <a:defRPr sz="600" b="0" i="0">
-                <a:solidFill>
-                  <a:srgbClr val="1A1A1A"/>
-                </a:solidFill>
-                <a:latin typeface="Calibri"/>
-              </a:defRPr>
-            </a:pPr>
-          </a:p>
-          <a:p>
-            <a:pPr algn="l">
-              <a:spcBef>
-                <a:spcPts val="400"/>
-              </a:spcBef>
-              <a:defRPr sz="1300" b="0" i="0">
-                <a:solidFill>
-                  <a:srgbClr val="5F5F5F"/>
-                </a:solidFill>
-                <a:latin typeface="Calibri"/>
-              </a:defRPr>
-            </a:pPr>
-            <a:r>
-              <a:t>Only 1 false negative — critical in medical screening where a missed diagnosis is far more dangerous than a false alarm.</a:t>
-            </a:r>
-          </a:p>
-        </p:txBody>
-      </p:sp>
-      <p:sp>
-        <p:nvSpPr>
-          <p:cNvPr id="25" name="TextBox 24"/>
-          <p:cNvSpPr txBox="1"/>
-          <p:nvPr/>
-        </p:nvSpPr>
-        <p:spPr>
-          <a:xfrm>
-            <a:off x="731520" y="6309360"/>
-            <a:ext cx="10698480" cy="274320"/>
-          </a:xfrm>
-          <a:prstGeom prst="rect">
-            <a:avLst/>
-          </a:prstGeom>
-          <a:noFill/>
-        </p:spPr>
-        <p:txBody>
-          <a:bodyPr wrap="square">
-            <a:spAutoFit/>
-          </a:bodyPr>
-          <a:lstStyle/>
-          <a:p>
             <a:pPr algn="r">
               <a:defRPr sz="900" b="0" i="0">
                 <a:solidFill>
@@ -16824,7 +14943,7 @@
       </p:sp>
       <p:sp>
         <p:nvSpPr>
-          <p:cNvPr id="26" name="Rectangle 25"/>
+          <p:cNvPr id="12" name="Rectangle 11"/>
           <p:cNvSpPr/>
           <p:nvPr/>
         </p:nvSpPr>
@@ -17019,916 +15138,30 @@
           </a:p>
         </p:txBody>
       </p:sp>
-      <p:graphicFrame>
-        <p:nvGraphicFramePr>
-          <p:cNvPr id="5" name="Table 4"/>
-          <p:cNvGraphicFramePr>
-            <a:graphicFrameLocks noGrp="1"/>
-          </p:cNvGraphicFramePr>
-          <p:nvPr/>
-        </p:nvGraphicFramePr>
-        <p:xfrm>
-          <a:off x="731520" y="1371600"/>
-          <a:ext cx="10698480" cy="3291840"/>
-        </p:xfrm>
-        <a:graphic>
-          <a:graphicData uri="http://schemas.openxmlformats.org/drawingml/2006/table">
-            <a:tbl>
-              <a:tblPr firstRow="1" bandRow="1">
-                <a:tableStyleId>{5C22544A-7EE6-4342-B048-85BDC9FD1C3A}</a:tableStyleId>
-              </a:tblPr>
-              <a:tblGrid>
-                <a:gridCol w="548640"/>
-                <a:gridCol w="2926080"/>
-                <a:gridCol w="1097280"/>
-                <a:gridCol w="6126480"/>
-              </a:tblGrid>
-              <a:tr h="365760">
-                <a:tc>
-                  <a:txBody>
-                    <a:bodyPr/>
-                    <a:lstStyle/>
-                    <a:p>
-                      <a:pPr>
-                        <a:defRPr sz="1100" b="1">
-                          <a:solidFill>
-                            <a:srgbClr val="FFFFFF"/>
-                          </a:solidFill>
-                          <a:latin typeface="Calibri"/>
-                        </a:defRPr>
-                      </a:pPr>
-                      <a:r>
-                        <a:t>Rank</a:t>
-                      </a:r>
-                    </a:p>
-                  </a:txBody>
-                  <a:tcPr>
-                    <a:solidFill>
-                      <a:srgbClr val="1F4E79"/>
-                    </a:solidFill>
-                  </a:tcPr>
-                </a:tc>
-                <a:tc>
-                  <a:txBody>
-                    <a:bodyPr/>
-                    <a:lstStyle/>
-                    <a:p>
-                      <a:pPr>
-                        <a:defRPr sz="1100" b="1">
-                          <a:solidFill>
-                            <a:srgbClr val="FFFFFF"/>
-                          </a:solidFill>
-                          <a:latin typeface="Calibri"/>
-                        </a:defRPr>
-                      </a:pPr>
-                      <a:r>
-                        <a:t>Feature</a:t>
-                      </a:r>
-                    </a:p>
-                  </a:txBody>
-                  <a:tcPr>
-                    <a:solidFill>
-                      <a:srgbClr val="1F4E79"/>
-                    </a:solidFill>
-                  </a:tcPr>
-                </a:tc>
-                <a:tc>
-                  <a:txBody>
-                    <a:bodyPr/>
-                    <a:lstStyle/>
-                    <a:p>
-                      <a:pPr>
-                        <a:defRPr sz="1100" b="1">
-                          <a:solidFill>
-                            <a:srgbClr val="FFFFFF"/>
-                          </a:solidFill>
-                          <a:latin typeface="Calibri"/>
-                        </a:defRPr>
-                      </a:pPr>
-                      <a:r>
-                        <a:t>Importance</a:t>
-                      </a:r>
-                    </a:p>
-                  </a:txBody>
-                  <a:tcPr>
-                    <a:solidFill>
-                      <a:srgbClr val="1F4E79"/>
-                    </a:solidFill>
-                  </a:tcPr>
-                </a:tc>
-                <a:tc>
-                  <a:txBody>
-                    <a:bodyPr/>
-                    <a:lstStyle/>
-                    <a:p>
-                      <a:pPr>
-                        <a:defRPr sz="1100" b="1">
-                          <a:solidFill>
-                            <a:srgbClr val="FFFFFF"/>
-                          </a:solidFill>
-                          <a:latin typeface="Calibri"/>
-                        </a:defRPr>
-                      </a:pPr>
-                      <a:r>
-                        <a:t>Clinical Significance</a:t>
-                      </a:r>
-                    </a:p>
-                  </a:txBody>
-                  <a:tcPr>
-                    <a:solidFill>
-                      <a:srgbClr val="1F4E79"/>
-                    </a:solidFill>
-                  </a:tcPr>
-                </a:tc>
-              </a:tr>
-              <a:tr h="365760">
-                <a:tc>
-                  <a:txBody>
-                    <a:bodyPr/>
-                    <a:lstStyle/>
-                    <a:p>
-                      <a:pPr>
-                        <a:defRPr sz="1100">
-                          <a:solidFill>
-                            <a:srgbClr val="1A1A1A"/>
-                          </a:solidFill>
-                          <a:latin typeface="Calibri"/>
-                        </a:defRPr>
-                      </a:pPr>
-                      <a:r>
-                        <a:t>1</a:t>
-                      </a:r>
-                    </a:p>
-                  </a:txBody>
-                  <a:tcPr>
-                    <a:solidFill>
-                      <a:srgbClr val="FFFFFF"/>
-                    </a:solidFill>
-                  </a:tcPr>
-                </a:tc>
-                <a:tc>
-                  <a:txBody>
-                    <a:bodyPr/>
-                    <a:lstStyle/>
-                    <a:p>
-                      <a:pPr>
-                        <a:defRPr sz="1100">
-                          <a:solidFill>
-                            <a:srgbClr val="1A1A1A"/>
-                          </a:solidFill>
-                          <a:latin typeface="Calibri"/>
-                        </a:defRPr>
-                      </a:pPr>
-                      <a:r>
-                        <a:t>thalach (Max Heart Rate)</a:t>
-                      </a:r>
-                    </a:p>
-                  </a:txBody>
-                  <a:tcPr>
-                    <a:solidFill>
-                      <a:srgbClr val="FFFFFF"/>
-                    </a:solidFill>
-                  </a:tcPr>
-                </a:tc>
-                <a:tc>
-                  <a:txBody>
-                    <a:bodyPr/>
-                    <a:lstStyle/>
-                    <a:p>
-                      <a:pPr>
-                        <a:defRPr sz="1100">
-                          <a:solidFill>
-                            <a:srgbClr val="1A1A1A"/>
-                          </a:solidFill>
-                          <a:latin typeface="Calibri"/>
-                        </a:defRPr>
-                      </a:pPr>
-                      <a:r>
-                        <a:t>14.2%</a:t>
-                      </a:r>
-                    </a:p>
-                  </a:txBody>
-                  <a:tcPr>
-                    <a:solidFill>
-                      <a:srgbClr val="FFFFFF"/>
-                    </a:solidFill>
-                  </a:tcPr>
-                </a:tc>
-                <a:tc>
-                  <a:txBody>
-                    <a:bodyPr/>
-                    <a:lstStyle/>
-                    <a:p>
-                      <a:pPr>
-                        <a:defRPr sz="1100">
-                          <a:solidFill>
-                            <a:srgbClr val="1A1A1A"/>
-                          </a:solidFill>
-                          <a:latin typeface="Calibri"/>
-                        </a:defRPr>
-                      </a:pPr>
-                      <a:r>
-                        <a:t>Lower max HR indicates reduced cardiac capacity</a:t>
-                      </a:r>
-                    </a:p>
-                  </a:txBody>
-                  <a:tcPr>
-                    <a:solidFill>
-                      <a:srgbClr val="FFFFFF"/>
-                    </a:solidFill>
-                  </a:tcPr>
-                </a:tc>
-              </a:tr>
-              <a:tr h="365760">
-                <a:tc>
-                  <a:txBody>
-                    <a:bodyPr/>
-                    <a:lstStyle/>
-                    <a:p>
-                      <a:pPr>
-                        <a:defRPr sz="1100">
-                          <a:solidFill>
-                            <a:srgbClr val="1A1A1A"/>
-                          </a:solidFill>
-                          <a:latin typeface="Calibri"/>
-                        </a:defRPr>
-                      </a:pPr>
-                      <a:r>
-                        <a:t>2</a:t>
-                      </a:r>
-                    </a:p>
-                  </a:txBody>
-                  <a:tcPr>
-                    <a:solidFill>
-                      <a:srgbClr val="D6E4F0"/>
-                    </a:solidFill>
-                  </a:tcPr>
-                </a:tc>
-                <a:tc>
-                  <a:txBody>
-                    <a:bodyPr/>
-                    <a:lstStyle/>
-                    <a:p>
-                      <a:pPr>
-                        <a:defRPr sz="1100">
-                          <a:solidFill>
-                            <a:srgbClr val="1A1A1A"/>
-                          </a:solidFill>
-                          <a:latin typeface="Calibri"/>
-                        </a:defRPr>
-                      </a:pPr>
-                      <a:r>
-                        <a:t>cp (Chest Pain Type)</a:t>
-                      </a:r>
-                    </a:p>
-                  </a:txBody>
-                  <a:tcPr>
-                    <a:solidFill>
-                      <a:srgbClr val="D6E4F0"/>
-                    </a:solidFill>
-                  </a:tcPr>
-                </a:tc>
-                <a:tc>
-                  <a:txBody>
-                    <a:bodyPr/>
-                    <a:lstStyle/>
-                    <a:p>
-                      <a:pPr>
-                        <a:defRPr sz="1100">
-                          <a:solidFill>
-                            <a:srgbClr val="1A1A1A"/>
-                          </a:solidFill>
-                          <a:latin typeface="Calibri"/>
-                        </a:defRPr>
-                      </a:pPr>
-                      <a:r>
-                        <a:t>12.8%</a:t>
-                      </a:r>
-                    </a:p>
-                  </a:txBody>
-                  <a:tcPr>
-                    <a:solidFill>
-                      <a:srgbClr val="D6E4F0"/>
-                    </a:solidFill>
-                  </a:tcPr>
-                </a:tc>
-                <a:tc>
-                  <a:txBody>
-                    <a:bodyPr/>
-                    <a:lstStyle/>
-                    <a:p>
-                      <a:pPr>
-                        <a:defRPr sz="1100">
-                          <a:solidFill>
-                            <a:srgbClr val="1A1A1A"/>
-                          </a:solidFill>
-                          <a:latin typeface="Calibri"/>
-                        </a:defRPr>
-                      </a:pPr>
-                      <a:r>
-                        <a:t>Asymptomatic chest pain is the highest risk category</a:t>
-                      </a:r>
-                    </a:p>
-                  </a:txBody>
-                  <a:tcPr>
-                    <a:solidFill>
-                      <a:srgbClr val="D6E4F0"/>
-                    </a:solidFill>
-                  </a:tcPr>
-                </a:tc>
-              </a:tr>
-              <a:tr h="365760">
-                <a:tc>
-                  <a:txBody>
-                    <a:bodyPr/>
-                    <a:lstStyle/>
-                    <a:p>
-                      <a:pPr>
-                        <a:defRPr sz="1100">
-                          <a:solidFill>
-                            <a:srgbClr val="1A1A1A"/>
-                          </a:solidFill>
-                          <a:latin typeface="Calibri"/>
-                        </a:defRPr>
-                      </a:pPr>
-                      <a:r>
-                        <a:t>3</a:t>
-                      </a:r>
-                    </a:p>
-                  </a:txBody>
-                  <a:tcPr>
-                    <a:solidFill>
-                      <a:srgbClr val="FFFFFF"/>
-                    </a:solidFill>
-                  </a:tcPr>
-                </a:tc>
-                <a:tc>
-                  <a:txBody>
-                    <a:bodyPr/>
-                    <a:lstStyle/>
-                    <a:p>
-                      <a:pPr>
-                        <a:defRPr sz="1100">
-                          <a:solidFill>
-                            <a:srgbClr val="1A1A1A"/>
-                          </a:solidFill>
-                          <a:latin typeface="Calibri"/>
-                        </a:defRPr>
-                      </a:pPr>
-                      <a:r>
-                        <a:t>oldpeak (ST Depression)</a:t>
-                      </a:r>
-                    </a:p>
-                  </a:txBody>
-                  <a:tcPr>
-                    <a:solidFill>
-                      <a:srgbClr val="FFFFFF"/>
-                    </a:solidFill>
-                  </a:tcPr>
-                </a:tc>
-                <a:tc>
-                  <a:txBody>
-                    <a:bodyPr/>
-                    <a:lstStyle/>
-                    <a:p>
-                      <a:pPr>
-                        <a:defRPr sz="1100">
-                          <a:solidFill>
-                            <a:srgbClr val="1A1A1A"/>
-                          </a:solidFill>
-                          <a:latin typeface="Calibri"/>
-                        </a:defRPr>
-                      </a:pPr>
-                      <a:r>
-                        <a:t>11.5%</a:t>
-                      </a:r>
-                    </a:p>
-                  </a:txBody>
-                  <a:tcPr>
-                    <a:solidFill>
-                      <a:srgbClr val="FFFFFF"/>
-                    </a:solidFill>
-                  </a:tcPr>
-                </a:tc>
-                <a:tc>
-                  <a:txBody>
-                    <a:bodyPr/>
-                    <a:lstStyle/>
-                    <a:p>
-                      <a:pPr>
-                        <a:defRPr sz="1100">
-                          <a:solidFill>
-                            <a:srgbClr val="1A1A1A"/>
-                          </a:solidFill>
-                          <a:latin typeface="Calibri"/>
-                        </a:defRPr>
-                      </a:pPr>
-                      <a:r>
-                        <a:t>Indicates exercise-induced myocardial ischaemia</a:t>
-                      </a:r>
-                    </a:p>
-                  </a:txBody>
-                  <a:tcPr>
-                    <a:solidFill>
-                      <a:srgbClr val="FFFFFF"/>
-                    </a:solidFill>
-                  </a:tcPr>
-                </a:tc>
-              </a:tr>
-              <a:tr h="365760">
-                <a:tc>
-                  <a:txBody>
-                    <a:bodyPr/>
-                    <a:lstStyle/>
-                    <a:p>
-                      <a:pPr>
-                        <a:defRPr sz="1100">
-                          <a:solidFill>
-                            <a:srgbClr val="1A1A1A"/>
-                          </a:solidFill>
-                          <a:latin typeface="Calibri"/>
-                        </a:defRPr>
-                      </a:pPr>
-                      <a:r>
-                        <a:t>4</a:t>
-                      </a:r>
-                    </a:p>
-                  </a:txBody>
-                  <a:tcPr>
-                    <a:solidFill>
-                      <a:srgbClr val="D6E4F0"/>
-                    </a:solidFill>
-                  </a:tcPr>
-                </a:tc>
-                <a:tc>
-                  <a:txBody>
-                    <a:bodyPr/>
-                    <a:lstStyle/>
-                    <a:p>
-                      <a:pPr>
-                        <a:defRPr sz="1100">
-                          <a:solidFill>
-                            <a:srgbClr val="1A1A1A"/>
-                          </a:solidFill>
-                          <a:latin typeface="Calibri"/>
-                        </a:defRPr>
-                      </a:pPr>
-                      <a:r>
-                        <a:t>ca (Major Vessels)</a:t>
-                      </a:r>
-                    </a:p>
-                  </a:txBody>
-                  <a:tcPr>
-                    <a:solidFill>
-                      <a:srgbClr val="D6E4F0"/>
-                    </a:solidFill>
-                  </a:tcPr>
-                </a:tc>
-                <a:tc>
-                  <a:txBody>
-                    <a:bodyPr/>
-                    <a:lstStyle/>
-                    <a:p>
-                      <a:pPr>
-                        <a:defRPr sz="1100">
-                          <a:solidFill>
-                            <a:srgbClr val="1A1A1A"/>
-                          </a:solidFill>
-                          <a:latin typeface="Calibri"/>
-                        </a:defRPr>
-                      </a:pPr>
-                      <a:r>
-                        <a:t>11.2%</a:t>
-                      </a:r>
-                    </a:p>
-                  </a:txBody>
-                  <a:tcPr>
-                    <a:solidFill>
-                      <a:srgbClr val="D6E4F0"/>
-                    </a:solidFill>
-                  </a:tcPr>
-                </a:tc>
-                <a:tc>
-                  <a:txBody>
-                    <a:bodyPr/>
-                    <a:lstStyle/>
-                    <a:p>
-                      <a:pPr>
-                        <a:defRPr sz="1100">
-                          <a:solidFill>
-                            <a:srgbClr val="1A1A1A"/>
-                          </a:solidFill>
-                          <a:latin typeface="Calibri"/>
-                        </a:defRPr>
-                      </a:pPr>
-                      <a:r>
-                        <a:t>Number of vessels coloured shows coronary patency</a:t>
-                      </a:r>
-                    </a:p>
-                  </a:txBody>
-                  <a:tcPr>
-                    <a:solidFill>
-                      <a:srgbClr val="D6E4F0"/>
-                    </a:solidFill>
-                  </a:tcPr>
-                </a:tc>
-              </a:tr>
-              <a:tr h="365760">
-                <a:tc>
-                  <a:txBody>
-                    <a:bodyPr/>
-                    <a:lstStyle/>
-                    <a:p>
-                      <a:pPr>
-                        <a:defRPr sz="1100">
-                          <a:solidFill>
-                            <a:srgbClr val="1A1A1A"/>
-                          </a:solidFill>
-                          <a:latin typeface="Calibri"/>
-                        </a:defRPr>
-                      </a:pPr>
-                      <a:r>
-                        <a:t>5</a:t>
-                      </a:r>
-                    </a:p>
-                  </a:txBody>
-                  <a:tcPr>
-                    <a:solidFill>
-                      <a:srgbClr val="FFFFFF"/>
-                    </a:solidFill>
-                  </a:tcPr>
-                </a:tc>
-                <a:tc>
-                  <a:txBody>
-                    <a:bodyPr/>
-                    <a:lstStyle/>
-                    <a:p>
-                      <a:pPr>
-                        <a:defRPr sz="1100">
-                          <a:solidFill>
-                            <a:srgbClr val="1A1A1A"/>
-                          </a:solidFill>
-                          <a:latin typeface="Calibri"/>
-                        </a:defRPr>
-                      </a:pPr>
-                      <a:r>
-                        <a:t>thal (Thalassemia)</a:t>
-                      </a:r>
-                    </a:p>
-                  </a:txBody>
-                  <a:tcPr>
-                    <a:solidFill>
-                      <a:srgbClr val="FFFFFF"/>
-                    </a:solidFill>
-                  </a:tcPr>
-                </a:tc>
-                <a:tc>
-                  <a:txBody>
-                    <a:bodyPr/>
-                    <a:lstStyle/>
-                    <a:p>
-                      <a:pPr>
-                        <a:defRPr sz="1100">
-                          <a:solidFill>
-                            <a:srgbClr val="1A1A1A"/>
-                          </a:solidFill>
-                          <a:latin typeface="Calibri"/>
-                        </a:defRPr>
-                      </a:pPr>
-                      <a:r>
-                        <a:t>10.8%</a:t>
-                      </a:r>
-                    </a:p>
-                  </a:txBody>
-                  <a:tcPr>
-                    <a:solidFill>
-                      <a:srgbClr val="FFFFFF"/>
-                    </a:solidFill>
-                  </a:tcPr>
-                </a:tc>
-                <a:tc>
-                  <a:txBody>
-                    <a:bodyPr/>
-                    <a:lstStyle/>
-                    <a:p>
-                      <a:pPr>
-                        <a:defRPr sz="1100">
-                          <a:solidFill>
-                            <a:srgbClr val="1A1A1A"/>
-                          </a:solidFill>
-                          <a:latin typeface="Calibri"/>
-                        </a:defRPr>
-                      </a:pPr>
-                      <a:r>
-                        <a:t>Blood disorder affecting oxygen transport</a:t>
-                      </a:r>
-                    </a:p>
-                  </a:txBody>
-                  <a:tcPr>
-                    <a:solidFill>
-                      <a:srgbClr val="FFFFFF"/>
-                    </a:solidFill>
-                  </a:tcPr>
-                </a:tc>
-              </a:tr>
-              <a:tr h="365760">
-                <a:tc>
-                  <a:txBody>
-                    <a:bodyPr/>
-                    <a:lstStyle/>
-                    <a:p>
-                      <a:pPr>
-                        <a:defRPr sz="1100">
-                          <a:solidFill>
-                            <a:srgbClr val="1A1A1A"/>
-                          </a:solidFill>
-                          <a:latin typeface="Calibri"/>
-                        </a:defRPr>
-                      </a:pPr>
-                      <a:r>
-                        <a:t>6</a:t>
-                      </a:r>
-                    </a:p>
-                  </a:txBody>
-                  <a:tcPr>
-                    <a:solidFill>
-                      <a:srgbClr val="D6E4F0"/>
-                    </a:solidFill>
-                  </a:tcPr>
-                </a:tc>
-                <a:tc>
-                  <a:txBody>
-                    <a:bodyPr/>
-                    <a:lstStyle/>
-                    <a:p>
-                      <a:pPr>
-                        <a:defRPr sz="1100">
-                          <a:solidFill>
-                            <a:srgbClr val="1A1A1A"/>
-                          </a:solidFill>
-                          <a:latin typeface="Calibri"/>
-                        </a:defRPr>
-                      </a:pPr>
-                      <a:r>
-                        <a:t>age</a:t>
-                      </a:r>
-                    </a:p>
-                  </a:txBody>
-                  <a:tcPr>
-                    <a:solidFill>
-                      <a:srgbClr val="D6E4F0"/>
-                    </a:solidFill>
-                  </a:tcPr>
-                </a:tc>
-                <a:tc>
-                  <a:txBody>
-                    <a:bodyPr/>
-                    <a:lstStyle/>
-                    <a:p>
-                      <a:pPr>
-                        <a:defRPr sz="1100">
-                          <a:solidFill>
-                            <a:srgbClr val="1A1A1A"/>
-                          </a:solidFill>
-                          <a:latin typeface="Calibri"/>
-                        </a:defRPr>
-                      </a:pPr>
-                      <a:r>
-                        <a:t>8.5%</a:t>
-                      </a:r>
-                    </a:p>
-                  </a:txBody>
-                  <a:tcPr>
-                    <a:solidFill>
-                      <a:srgbClr val="D6E4F0"/>
-                    </a:solidFill>
-                  </a:tcPr>
-                </a:tc>
-                <a:tc>
-                  <a:txBody>
-                    <a:bodyPr/>
-                    <a:lstStyle/>
-                    <a:p>
-                      <a:pPr>
-                        <a:defRPr sz="1100">
-                          <a:solidFill>
-                            <a:srgbClr val="1A1A1A"/>
-                          </a:solidFill>
-                          <a:latin typeface="Calibri"/>
-                        </a:defRPr>
-                      </a:pPr>
-                      <a:r>
-                        <a:t>Risk increases with age</a:t>
-                      </a:r>
-                    </a:p>
-                  </a:txBody>
-                  <a:tcPr>
-                    <a:solidFill>
-                      <a:srgbClr val="D6E4F0"/>
-                    </a:solidFill>
-                  </a:tcPr>
-                </a:tc>
-              </a:tr>
-              <a:tr h="365760">
-                <a:tc>
-                  <a:txBody>
-                    <a:bodyPr/>
-                    <a:lstStyle/>
-                    <a:p>
-                      <a:pPr>
-                        <a:defRPr sz="1100">
-                          <a:solidFill>
-                            <a:srgbClr val="1A1A1A"/>
-                          </a:solidFill>
-                          <a:latin typeface="Calibri"/>
-                        </a:defRPr>
-                      </a:pPr>
-                      <a:r>
-                        <a:t>7</a:t>
-                      </a:r>
-                    </a:p>
-                  </a:txBody>
-                  <a:tcPr>
-                    <a:solidFill>
-                      <a:srgbClr val="FFFFFF"/>
-                    </a:solidFill>
-                  </a:tcPr>
-                </a:tc>
-                <a:tc>
-                  <a:txBody>
-                    <a:bodyPr/>
-                    <a:lstStyle/>
-                    <a:p>
-                      <a:pPr>
-                        <a:defRPr sz="1100">
-                          <a:solidFill>
-                            <a:srgbClr val="1A1A1A"/>
-                          </a:solidFill>
-                          <a:latin typeface="Calibri"/>
-                        </a:defRPr>
-                      </a:pPr>
-                      <a:r>
-                        <a:t>sex</a:t>
-                      </a:r>
-                    </a:p>
-                  </a:txBody>
-                  <a:tcPr>
-                    <a:solidFill>
-                      <a:srgbClr val="FFFFFF"/>
-                    </a:solidFill>
-                  </a:tcPr>
-                </a:tc>
-                <a:tc>
-                  <a:txBody>
-                    <a:bodyPr/>
-                    <a:lstStyle/>
-                    <a:p>
-                      <a:pPr>
-                        <a:defRPr sz="1100">
-                          <a:solidFill>
-                            <a:srgbClr val="1A1A1A"/>
-                          </a:solidFill>
-                          <a:latin typeface="Calibri"/>
-                        </a:defRPr>
-                      </a:pPr>
-                      <a:r>
-                        <a:t>7.2%</a:t>
-                      </a:r>
-                    </a:p>
-                  </a:txBody>
-                  <a:tcPr>
-                    <a:solidFill>
-                      <a:srgbClr val="FFFFFF"/>
-                    </a:solidFill>
-                  </a:tcPr>
-                </a:tc>
-                <a:tc>
-                  <a:txBody>
-                    <a:bodyPr/>
-                    <a:lstStyle/>
-                    <a:p>
-                      <a:pPr>
-                        <a:defRPr sz="1100">
-                          <a:solidFill>
-                            <a:srgbClr val="1A1A1A"/>
-                          </a:solidFill>
-                          <a:latin typeface="Calibri"/>
-                        </a:defRPr>
-                      </a:pPr>
-                      <a:r>
-                        <a:t>Males at statistically higher risk</a:t>
-                      </a:r>
-                    </a:p>
-                  </a:txBody>
-                  <a:tcPr>
-                    <a:solidFill>
-                      <a:srgbClr val="FFFFFF"/>
-                    </a:solidFill>
-                  </a:tcPr>
-                </a:tc>
-              </a:tr>
-              <a:tr h="365760">
-                <a:tc>
-                  <a:txBody>
-                    <a:bodyPr/>
-                    <a:lstStyle/>
-                    <a:p>
-                      <a:pPr>
-                        <a:defRPr sz="1100">
-                          <a:solidFill>
-                            <a:srgbClr val="1A1A1A"/>
-                          </a:solidFill>
-                          <a:latin typeface="Calibri"/>
-                        </a:defRPr>
-                      </a:pPr>
-                      <a:r>
-                        <a:t>8</a:t>
-                      </a:r>
-                    </a:p>
-                  </a:txBody>
-                  <a:tcPr>
-                    <a:solidFill>
-                      <a:srgbClr val="D6E4F0"/>
-                    </a:solidFill>
-                  </a:tcPr>
-                </a:tc>
-                <a:tc>
-                  <a:txBody>
-                    <a:bodyPr/>
-                    <a:lstStyle/>
-                    <a:p>
-                      <a:pPr>
-                        <a:defRPr sz="1100">
-                          <a:solidFill>
-                            <a:srgbClr val="1A1A1A"/>
-                          </a:solidFill>
-                          <a:latin typeface="Calibri"/>
-                        </a:defRPr>
-                      </a:pPr>
-                      <a:r>
-                        <a:t>chol (Cholesterol)</a:t>
-                      </a:r>
-                    </a:p>
-                  </a:txBody>
-                  <a:tcPr>
-                    <a:solidFill>
-                      <a:srgbClr val="D6E4F0"/>
-                    </a:solidFill>
-                  </a:tcPr>
-                </a:tc>
-                <a:tc>
-                  <a:txBody>
-                    <a:bodyPr/>
-                    <a:lstStyle/>
-                    <a:p>
-                      <a:pPr>
-                        <a:defRPr sz="1100">
-                          <a:solidFill>
-                            <a:srgbClr val="1A1A1A"/>
-                          </a:solidFill>
-                          <a:latin typeface="Calibri"/>
-                        </a:defRPr>
-                      </a:pPr>
-                      <a:r>
-                        <a:t>5.8%</a:t>
-                      </a:r>
-                    </a:p>
-                  </a:txBody>
-                  <a:tcPr>
-                    <a:solidFill>
-                      <a:srgbClr val="D6E4F0"/>
-                    </a:solidFill>
-                  </a:tcPr>
-                </a:tc>
-                <a:tc>
-                  <a:txBody>
-                    <a:bodyPr/>
-                    <a:lstStyle/>
-                    <a:p>
-                      <a:pPr>
-                        <a:defRPr sz="1100">
-                          <a:solidFill>
-                            <a:srgbClr val="1A1A1A"/>
-                          </a:solidFill>
-                          <a:latin typeface="Calibri"/>
-                        </a:defRPr>
-                      </a:pPr>
-                      <a:r>
-                        <a:t>Higher cholesterol contributes to plaque buildup</a:t>
-                      </a:r>
-                    </a:p>
-                  </a:txBody>
-                  <a:tcPr>
-                    <a:solidFill>
-                      <a:srgbClr val="D6E4F0"/>
-                    </a:solidFill>
-                  </a:tcPr>
-                </a:tc>
-              </a:tr>
-            </a:tbl>
-          </a:graphicData>
-        </a:graphic>
-      </p:graphicFrame>
+      <p:pic>
+        <p:nvPicPr>
+          <p:cNvPr id="5" name="Picture 4" descr="feature_importance.png"/>
+          <p:cNvPicPr>
+            <a:picLocks noChangeAspect="1"/>
+          </p:cNvPicPr>
+          <p:nvPr/>
+        </p:nvPicPr>
+        <p:blipFill>
+          <a:blip r:embed="rId2"/>
+          <a:stretch>
+            <a:fillRect/>
+          </a:stretch>
+        </p:blipFill>
+        <p:spPr>
+          <a:xfrm>
+            <a:off x="457200" y="1097280"/>
+            <a:ext cx="7772400" cy="4114800"/>
+          </a:xfrm>
+          <a:prstGeom prst="rect">
+            <a:avLst/>
+          </a:prstGeom>
+        </p:spPr>
+      </p:pic>
       <p:sp>
         <p:nvSpPr>
           <p:cNvPr id="6" name="Rectangle 5"/>
@@ -17937,8 +15170,8 @@
         </p:nvSpPr>
         <p:spPr>
           <a:xfrm>
-            <a:off x="731520" y="5029200"/>
-            <a:ext cx="10698480" cy="548640"/>
+            <a:off x="8503920" y="1097280"/>
+            <a:ext cx="3200400" cy="5029200"/>
           </a:xfrm>
           <a:prstGeom prst="rect">
             <a:avLst/>
@@ -17983,8 +15216,8 @@
         </p:nvSpPr>
         <p:spPr>
           <a:xfrm>
-            <a:off x="914400" y="5074920"/>
-            <a:ext cx="10332720" cy="457200"/>
+            <a:off x="8686800" y="1188720"/>
+            <a:ext cx="2834640" cy="274320"/>
           </a:xfrm>
           <a:prstGeom prst="rect">
             <a:avLst/>
@@ -17998,7 +15231,7 @@
           <a:lstStyle/>
           <a:p>
             <a:pPr algn="l">
-              <a:defRPr sz="1300" b="0" i="0">
+              <a:defRPr sz="1300" b="1" i="0">
                 <a:solidFill>
                   <a:srgbClr val="1F4E79"/>
                 </a:solidFill>
@@ -18006,7 +15239,7 @@
               </a:defRPr>
             </a:pPr>
             <a:r>
-              <a:t>Exercise-related and angiographic features dominate — consistent with clinical literature on cardiac risk factors.</a:t>
+              <a:t>Clinical Reasoning</a:t>
             </a:r>
           </a:p>
         </p:txBody>
@@ -18019,8 +15252,8 @@
         </p:nvSpPr>
         <p:spPr>
           <a:xfrm>
-            <a:off x="731520" y="6309360"/>
-            <a:ext cx="10698480" cy="274320"/>
+            <a:off x="8686800" y="1554480"/>
+            <a:ext cx="2834640" cy="4389120"/>
           </a:xfrm>
           <a:prstGeom prst="rect">
             <a:avLst/>
@@ -18033,6 +15266,251 @@
           </a:bodyPr>
           <a:lstStyle/>
           <a:p>
+            <a:pPr algn="l">
+              <a:defRPr sz="1100" b="0" i="0">
+                <a:solidFill>
+                  <a:srgbClr val="1A1A1A"/>
+                </a:solidFill>
+                <a:latin typeface="Calibri"/>
+              </a:defRPr>
+            </a:pPr>
+          </a:p>
+          <a:p>
+            <a:pPr algn="l">
+              <a:spcBef>
+                <a:spcPts val="600"/>
+              </a:spcBef>
+              <a:defRPr sz="1100" b="1">
+                <a:solidFill>
+                  <a:srgbClr val="1F4E79"/>
+                </a:solidFill>
+                <a:latin typeface="Calibri"/>
+              </a:defRPr>
+            </a:pPr>
+            <a:r>
+              <a:t>Max Heart Rate:</a:t>
+            </a:r>
+          </a:p>
+          <a:p>
+            <a:pPr algn="l">
+              <a:spcBef>
+                <a:spcPts val="200"/>
+              </a:spcBef>
+              <a:defRPr sz="1000" b="0">
+                <a:solidFill>
+                  <a:srgbClr val="1A1A1A"/>
+                </a:solidFill>
+                <a:latin typeface="Calibri"/>
+              </a:defRPr>
+            </a:pPr>
+            <a:r>
+              <a:t>Lower max HR → reduced cardiac reserve → higher risk</a:t>
+            </a:r>
+          </a:p>
+          <a:p>
+            <a:pPr algn="l">
+              <a:spcBef>
+                <a:spcPts val="400"/>
+              </a:spcBef>
+              <a:defRPr sz="600" b="0">
+                <a:solidFill>
+                  <a:srgbClr val="1A1A1A"/>
+                </a:solidFill>
+                <a:latin typeface="Calibri"/>
+              </a:defRPr>
+            </a:pPr>
+          </a:p>
+          <a:p>
+            <a:pPr algn="l">
+              <a:spcBef>
+                <a:spcPts val="400"/>
+              </a:spcBef>
+              <a:defRPr sz="1100" b="1">
+                <a:solidFill>
+                  <a:srgbClr val="1F4E79"/>
+                </a:solidFill>
+                <a:latin typeface="Calibri"/>
+              </a:defRPr>
+            </a:pPr>
+            <a:r>
+              <a:t>Chest Pain Type:</a:t>
+            </a:r>
+          </a:p>
+          <a:p>
+            <a:pPr algn="l">
+              <a:spcBef>
+                <a:spcPts val="200"/>
+              </a:spcBef>
+              <a:defRPr sz="1000" b="0">
+                <a:solidFill>
+                  <a:srgbClr val="1A1A1A"/>
+                </a:solidFill>
+                <a:latin typeface="Calibri"/>
+              </a:defRPr>
+            </a:pPr>
+            <a:r>
+              <a:t>Asymptomatic (cp=3) is paradoxically the highest risk category</a:t>
+            </a:r>
+          </a:p>
+          <a:p>
+            <a:pPr algn="l">
+              <a:spcBef>
+                <a:spcPts val="400"/>
+              </a:spcBef>
+              <a:defRPr sz="600" b="0">
+                <a:solidFill>
+                  <a:srgbClr val="1A1A1A"/>
+                </a:solidFill>
+                <a:latin typeface="Calibri"/>
+              </a:defRPr>
+            </a:pPr>
+          </a:p>
+          <a:p>
+            <a:pPr algn="l">
+              <a:spcBef>
+                <a:spcPts val="400"/>
+              </a:spcBef>
+              <a:defRPr sz="1100" b="1">
+                <a:solidFill>
+                  <a:srgbClr val="1F4E79"/>
+                </a:solidFill>
+                <a:latin typeface="Calibri"/>
+              </a:defRPr>
+            </a:pPr>
+            <a:r>
+              <a:t>ST Depression:</a:t>
+            </a:r>
+          </a:p>
+          <a:p>
+            <a:pPr algn="l">
+              <a:spcBef>
+                <a:spcPts val="200"/>
+              </a:spcBef>
+              <a:defRPr sz="1000" b="0">
+                <a:solidFill>
+                  <a:srgbClr val="1A1A1A"/>
+                </a:solidFill>
+                <a:latin typeface="Calibri"/>
+              </a:defRPr>
+            </a:pPr>
+            <a:r>
+              <a:t>Exercise-induced myocardial ischaemia — direct indicator</a:t>
+            </a:r>
+          </a:p>
+          <a:p>
+            <a:pPr algn="l">
+              <a:spcBef>
+                <a:spcPts val="400"/>
+              </a:spcBef>
+              <a:defRPr sz="600" b="0">
+                <a:solidFill>
+                  <a:srgbClr val="1A1A1A"/>
+                </a:solidFill>
+                <a:latin typeface="Calibri"/>
+              </a:defRPr>
+            </a:pPr>
+          </a:p>
+          <a:p>
+            <a:pPr algn="l">
+              <a:spcBef>
+                <a:spcPts val="400"/>
+              </a:spcBef>
+              <a:defRPr sz="1100" b="1">
+                <a:solidFill>
+                  <a:srgbClr val="1F4E79"/>
+                </a:solidFill>
+                <a:latin typeface="Calibri"/>
+              </a:defRPr>
+            </a:pPr>
+            <a:r>
+              <a:t>Major Vessels (ca):</a:t>
+            </a:r>
+          </a:p>
+          <a:p>
+            <a:pPr algn="l">
+              <a:spcBef>
+                <a:spcPts val="200"/>
+              </a:spcBef>
+              <a:defRPr sz="1000" b="0">
+                <a:solidFill>
+                  <a:srgbClr val="1A1A1A"/>
+                </a:solidFill>
+                <a:latin typeface="Calibri"/>
+              </a:defRPr>
+            </a:pPr>
+            <a:r>
+              <a:t>More blocked vessels = worse coronary patency</a:t>
+            </a:r>
+          </a:p>
+          <a:p>
+            <a:pPr algn="l">
+              <a:spcBef>
+                <a:spcPts val="400"/>
+              </a:spcBef>
+              <a:defRPr sz="600" b="0">
+                <a:solidFill>
+                  <a:srgbClr val="1A1A1A"/>
+                </a:solidFill>
+                <a:latin typeface="Calibri"/>
+              </a:defRPr>
+            </a:pPr>
+          </a:p>
+          <a:p>
+            <a:pPr algn="l">
+              <a:spcBef>
+                <a:spcPts val="400"/>
+              </a:spcBef>
+              <a:defRPr sz="1100" b="1">
+                <a:solidFill>
+                  <a:srgbClr val="1F4E79"/>
+                </a:solidFill>
+                <a:latin typeface="Calibri"/>
+              </a:defRPr>
+            </a:pPr>
+            <a:r>
+              <a:t>Thalassemia (thal):</a:t>
+            </a:r>
+          </a:p>
+          <a:p>
+            <a:pPr algn="l">
+              <a:spcBef>
+                <a:spcPts val="200"/>
+              </a:spcBef>
+              <a:defRPr sz="1000" b="0">
+                <a:solidFill>
+                  <a:srgbClr val="1A1A1A"/>
+                </a:solidFill>
+                <a:latin typeface="Calibri"/>
+              </a:defRPr>
+            </a:pPr>
+            <a:r>
+              <a:t>Blood disorder affecting oxygen transport — perfusion defect marker</a:t>
+            </a:r>
+          </a:p>
+        </p:txBody>
+      </p:sp>
+      <p:sp>
+        <p:nvSpPr>
+          <p:cNvPr id="9" name="TextBox 8"/>
+          <p:cNvSpPr txBox="1"/>
+          <p:nvPr/>
+        </p:nvSpPr>
+        <p:spPr>
+          <a:xfrm>
+            <a:off x="731520" y="6309360"/>
+            <a:ext cx="10698480" cy="274320"/>
+          </a:xfrm>
+          <a:prstGeom prst="rect">
+            <a:avLst/>
+          </a:prstGeom>
+          <a:noFill/>
+        </p:spPr>
+        <p:txBody>
+          <a:bodyPr wrap="square">
+            <a:spAutoFit/>
+          </a:bodyPr>
+          <a:lstStyle/>
+          <a:p>
             <a:pPr algn="r">
               <a:defRPr sz="900" b="0" i="0">
                 <a:solidFill>
@@ -18049,7 +15527,7 @@
       </p:sp>
       <p:sp>
         <p:nvSpPr>
-          <p:cNvPr id="9" name="Rectangle 8"/>
+          <p:cNvPr id="10" name="Rectangle 9"/>
           <p:cNvSpPr/>
           <p:nvPr/>
         </p:nvSpPr>

</xml_diff>

<commit_message>
Defense-ready PPT: 80% baseline, GridSearchCV, high-contrast CM, Docker callout, Security highlight
</commit_message>
<xml_diff>
--- a/CardioPredict_Presentation.pptx
+++ b/CardioPredict_Presentation.pptx
@@ -5417,8 +5417,8 @@
         </p:nvSpPr>
         <p:spPr>
           <a:xfrm>
-            <a:off x="731520" y="3931920"/>
-            <a:ext cx="10698480" cy="1645920"/>
+            <a:off x="731520" y="3749039"/>
+            <a:ext cx="5029200" cy="1737360"/>
           </a:xfrm>
           <a:prstGeom prst="rect">
             <a:avLst/>
@@ -5463,8 +5463,8 @@
         </p:nvSpPr>
         <p:spPr>
           <a:xfrm>
-            <a:off x="914400" y="4023360"/>
-            <a:ext cx="10332720" cy="274320"/>
+            <a:off x="914400" y="3794760"/>
+            <a:ext cx="4663440" cy="274320"/>
           </a:xfrm>
           <a:prstGeom prst="rect">
             <a:avLst/>
@@ -5499,8 +5499,8 @@
         </p:nvSpPr>
         <p:spPr>
           <a:xfrm>
-            <a:off x="914400" y="4389120"/>
-            <a:ext cx="10332720" cy="1097280"/>
+            <a:off x="914400" y="4114800"/>
+            <a:ext cx="4663440" cy="1188720"/>
           </a:xfrm>
           <a:prstGeom prst="rect">
             <a:avLst/>
@@ -5535,7 +5535,7 @@
               </a:defRPr>
             </a:pPr>
             <a:r>
-              <a:t>User fills 13 fields → Browser validates (HTML5) → POST /predict → Flask validates server-side</a:t>
+              <a:t>Browser → POST /predict → Flask validates</a:t>
             </a:r>
           </a:p>
           <a:p>
@@ -5551,7 +5551,7 @@
               </a:defRPr>
             </a:pPr>
             <a:r>
-              <a:t>→ NumPy array built → StandardScaler transforms → Random Forest predicts → SQLite saves result</a:t>
+              <a:t>→ StandardScaler + Random Forest inference</a:t>
             </a:r>
           </a:p>
           <a:p>
@@ -5567,21 +5567,67 @@
               </a:defRPr>
             </a:pPr>
             <a:r>
-              <a:t>→ Result page rendered with colour-coded risk indicator (green / amber / red)</a:t>
-            </a:r>
-          </a:p>
-        </p:txBody>
-      </p:sp>
-      <p:sp>
-        <p:nvSpPr>
-          <p:cNvPr id="24" name="TextBox 23"/>
+              <a:t>→ SQLite saves → colour-coded result rendered</a:t>
+            </a:r>
+          </a:p>
+        </p:txBody>
+      </p:sp>
+      <p:sp>
+        <p:nvSpPr>
+          <p:cNvPr id="24" name="Rectangle 23"/>
+          <p:cNvSpPr/>
+          <p:nvPr/>
+        </p:nvSpPr>
+        <p:spPr>
+          <a:xfrm>
+            <a:off x="6217920" y="3749039"/>
+            <a:ext cx="5212080" cy="1737360"/>
+          </a:xfrm>
+          <a:prstGeom prst="rect">
+            <a:avLst/>
+          </a:prstGeom>
+          <a:solidFill>
+            <a:srgbClr val="E8F0FE"/>
+          </a:solidFill>
+          <a:ln w="6350">
+            <a:solidFill>
+              <a:srgbClr val="DDDDDD"/>
+            </a:solidFill>
+          </a:ln>
+          <a:effectLst/>
+        </p:spPr>
+        <p:style>
+          <a:lnRef idx="1">
+            <a:schemeClr val="accent1"/>
+          </a:lnRef>
+          <a:fillRef idx="3">
+            <a:schemeClr val="accent1"/>
+          </a:fillRef>
+          <a:effectRef idx="2">
+            <a:schemeClr val="accent1"/>
+          </a:effectRef>
+          <a:fontRef idx="minor">
+            <a:schemeClr val="lt1"/>
+          </a:fontRef>
+        </p:style>
+        <p:txBody>
+          <a:bodyPr rtlCol="0" anchor="ctr"/>
+          <a:lstStyle/>
+          <a:p>
+            <a:pPr algn="ctr"/>
+          </a:p>
+        </p:txBody>
+      </p:sp>
+      <p:sp>
+        <p:nvSpPr>
+          <p:cNvPr id="25" name="TextBox 24"/>
           <p:cNvSpPr txBox="1"/>
           <p:nvPr/>
         </p:nvSpPr>
         <p:spPr>
           <a:xfrm>
-            <a:off x="731520" y="6309360"/>
-            <a:ext cx="10698480" cy="274320"/>
+            <a:off x="6400800" y="3794760"/>
+            <a:ext cx="4846320" cy="274320"/>
           </a:xfrm>
           <a:prstGeom prst="rect">
             <a:avLst/>
@@ -5594,6 +5640,139 @@
           </a:bodyPr>
           <a:lstStyle/>
           <a:p>
+            <a:pPr algn="l">
+              <a:defRPr sz="1300" b="1" i="0">
+                <a:solidFill>
+                  <a:srgbClr val="1F4E79"/>
+                </a:solidFill>
+                <a:latin typeface="Calibri"/>
+              </a:defRPr>
+            </a:pPr>
+            <a:r>
+              <a:t>Production Deployment</a:t>
+            </a:r>
+          </a:p>
+        </p:txBody>
+      </p:sp>
+      <p:sp>
+        <p:nvSpPr>
+          <p:cNvPr id="26" name="TextBox 25"/>
+          <p:cNvSpPr txBox="1"/>
+          <p:nvPr/>
+        </p:nvSpPr>
+        <p:spPr>
+          <a:xfrm>
+            <a:off x="6400800" y="4114800"/>
+            <a:ext cx="4846320" cy="1188720"/>
+          </a:xfrm>
+          <a:prstGeom prst="rect">
+            <a:avLst/>
+          </a:prstGeom>
+          <a:noFill/>
+        </p:spPr>
+        <p:txBody>
+          <a:bodyPr wrap="square">
+            <a:spAutoFit/>
+          </a:bodyPr>
+          <a:lstStyle/>
+          <a:p>
+            <a:pPr algn="l">
+              <a:defRPr sz="1200" b="0" i="0">
+                <a:solidFill>
+                  <a:srgbClr val="1A1A1A"/>
+                </a:solidFill>
+                <a:latin typeface="Calibri"/>
+              </a:defRPr>
+            </a:pPr>
+          </a:p>
+          <a:p>
+            <a:pPr algn="l">
+              <a:spcBef>
+                <a:spcPts val="400"/>
+              </a:spcBef>
+              <a:defRPr sz="1200" b="0">
+                <a:solidFill>
+                  <a:srgbClr val="1A1A1A"/>
+                </a:solidFill>
+                <a:latin typeface="Calibri"/>
+              </a:defRPr>
+            </a:pPr>
+            <a:r>
+              <a:t>🐳  Docker container — single-command deploy</a:t>
+            </a:r>
+          </a:p>
+          <a:p>
+            <a:pPr algn="l">
+              <a:spcBef>
+                <a:spcPts val="400"/>
+              </a:spcBef>
+              <a:defRPr sz="1200" b="0">
+                <a:solidFill>
+                  <a:srgbClr val="1A1A1A"/>
+                </a:solidFill>
+                <a:latin typeface="Calibri"/>
+              </a:defRPr>
+            </a:pPr>
+            <a:r>
+              <a:t>⚡  Gunicorn WSGI — 4 worker processes</a:t>
+            </a:r>
+          </a:p>
+          <a:p>
+            <a:pPr algn="l">
+              <a:spcBef>
+                <a:spcPts val="400"/>
+              </a:spcBef>
+              <a:defRPr sz="1200" b="0">
+                <a:solidFill>
+                  <a:srgbClr val="1A1A1A"/>
+                </a:solidFill>
+                <a:latin typeface="Calibri"/>
+              </a:defRPr>
+            </a:pPr>
+            <a:r>
+              <a:t>📦  All dependencies frozen in requirements.txt</a:t>
+            </a:r>
+          </a:p>
+          <a:p>
+            <a:pPr algn="l">
+              <a:spcBef>
+                <a:spcPts val="400"/>
+              </a:spcBef>
+              <a:defRPr sz="1200" b="0">
+                <a:solidFill>
+                  <a:srgbClr val="1A1A1A"/>
+                </a:solidFill>
+                <a:latin typeface="Calibri"/>
+              </a:defRPr>
+            </a:pPr>
+            <a:r>
+              <a:t>🔒  Environment variables for config management</a:t>
+            </a:r>
+          </a:p>
+        </p:txBody>
+      </p:sp>
+      <p:sp>
+        <p:nvSpPr>
+          <p:cNvPr id="27" name="TextBox 26"/>
+          <p:cNvSpPr txBox="1"/>
+          <p:nvPr/>
+        </p:nvSpPr>
+        <p:spPr>
+          <a:xfrm>
+            <a:off x="731520" y="6309360"/>
+            <a:ext cx="10698480" cy="274320"/>
+          </a:xfrm>
+          <a:prstGeom prst="rect">
+            <a:avLst/>
+          </a:prstGeom>
+          <a:noFill/>
+        </p:spPr>
+        <p:txBody>
+          <a:bodyPr wrap="square">
+            <a:spAutoFit/>
+          </a:bodyPr>
+          <a:lstStyle/>
+          <a:p>
             <a:pPr algn="r">
               <a:defRPr sz="900" b="0" i="0">
                 <a:solidFill>
@@ -5610,7 +5789,7 @@
       </p:sp>
       <p:sp>
         <p:nvSpPr>
-          <p:cNvPr id="25" name="Rectangle 24"/>
+          <p:cNvPr id="28" name="Rectangle 27"/>
           <p:cNvSpPr/>
           <p:nvPr/>
         </p:nvSpPr>
@@ -7054,7 +7233,7 @@
                         </a:defRPr>
                       </a:pPr>
                       <a:r>
-                        <a:t>Security</a:t>
+                        <a:t>Security ★</a:t>
                       </a:r>
                     </a:p>
                   </a:txBody>
@@ -7128,7 +7307,7 @@
                         </a:defRPr>
                       </a:pPr>
                       <a:r>
-                        <a:t>Accessibility</a:t>
+                        <a:t>Accessibility ★</a:t>
                       </a:r>
                     </a:p>
                   </a:txBody>
@@ -7199,7 +7378,89 @@
         </p:nvSpPr>
         <p:spPr>
           <a:xfrm>
-            <a:off x="731520" y="5212080"/>
+            <a:off x="731520" y="5029200"/>
+            <a:ext cx="10698480" cy="457200"/>
+          </a:xfrm>
+          <a:prstGeom prst="rect">
+            <a:avLst/>
+          </a:prstGeom>
+          <a:solidFill>
+            <a:srgbClr val="FDF2E0"/>
+          </a:solidFill>
+          <a:ln w="6350">
+            <a:solidFill>
+              <a:srgbClr val="DDDDDD"/>
+            </a:solidFill>
+          </a:ln>
+          <a:effectLst/>
+        </p:spPr>
+        <p:style>
+          <a:lnRef idx="1">
+            <a:schemeClr val="accent1"/>
+          </a:lnRef>
+          <a:fillRef idx="3">
+            <a:schemeClr val="accent1"/>
+          </a:fillRef>
+          <a:effectRef idx="2">
+            <a:schemeClr val="accent1"/>
+          </a:effectRef>
+          <a:fontRef idx="minor">
+            <a:schemeClr val="lt1"/>
+          </a:fontRef>
+        </p:style>
+        <p:txBody>
+          <a:bodyPr rtlCol="0" anchor="ctr"/>
+          <a:lstStyle/>
+          <a:p>
+            <a:pPr algn="ctr"/>
+          </a:p>
+        </p:txBody>
+      </p:sp>
+      <p:sp>
+        <p:nvSpPr>
+          <p:cNvPr id="8" name="TextBox 7"/>
+          <p:cNvSpPr txBox="1"/>
+          <p:nvPr/>
+        </p:nvSpPr>
+        <p:spPr>
+          <a:xfrm>
+            <a:off x="914400" y="5074920"/>
+            <a:ext cx="10332720" cy="365760"/>
+          </a:xfrm>
+          <a:prstGeom prst="rect">
+            <a:avLst/>
+          </a:prstGeom>
+          <a:noFill/>
+        </p:spPr>
+        <p:txBody>
+          <a:bodyPr wrap="square">
+            <a:spAutoFit/>
+          </a:bodyPr>
+          <a:lstStyle/>
+          <a:p>
+            <a:pPr algn="l">
+              <a:defRPr sz="1100" b="0" i="0">
+                <a:solidFill>
+                  <a:srgbClr val="BF6E00"/>
+                </a:solidFill>
+                <a:latin typeface="Calibri"/>
+              </a:defRPr>
+            </a:pPr>
+            <a:r>
+              <a:t>★  Security &amp; Accessibility tests highlight production-grade polish — SQL injection prevention, ARIA tags, Dark Mode, responsive design.</a:t>
+            </a:r>
+          </a:p>
+        </p:txBody>
+      </p:sp>
+      <p:sp>
+        <p:nvSpPr>
+          <p:cNvPr id="9" name="Rectangle 8"/>
+          <p:cNvSpPr/>
+          <p:nvPr/>
+        </p:nvSpPr>
+        <p:spPr>
+          <a:xfrm>
+            <a:off x="731520" y="5577840"/>
             <a:ext cx="10698480" cy="457200"/>
           </a:xfrm>
           <a:prstGeom prst="rect">
@@ -7239,13 +7500,13 @@
       </p:sp>
       <p:sp>
         <p:nvSpPr>
-          <p:cNvPr id="8" name="TextBox 7"/>
+          <p:cNvPr id="10" name="TextBox 9"/>
           <p:cNvSpPr txBox="1"/>
           <p:nvPr/>
         </p:nvSpPr>
         <p:spPr>
           <a:xfrm>
-            <a:off x="731520" y="5257800"/>
+            <a:off x="731520" y="5623560"/>
             <a:ext cx="10698480" cy="365760"/>
           </a:xfrm>
           <a:prstGeom prst="rect">
@@ -7275,7 +7536,7 @@
       </p:sp>
       <p:sp>
         <p:nvSpPr>
-          <p:cNvPr id="9" name="TextBox 8"/>
+          <p:cNvPr id="11" name="TextBox 10"/>
           <p:cNvSpPr txBox="1"/>
           <p:nvPr/>
         </p:nvSpPr>
@@ -7311,7 +7572,7 @@
       </p:sp>
       <p:sp>
         <p:nvSpPr>
-          <p:cNvPr id="10" name="Rectangle 9"/>
+          <p:cNvPr id="12" name="Rectangle 11"/>
           <p:cNvSpPr/>
           <p:nvPr/>
         </p:nvSpPr>
@@ -8242,7 +8503,7 @@
               </a:defRPr>
             </a:pPr>
             <a:r>
-              <a:t>github.com/sandeeep-kr/HeartDiseaseProject</a:t>
+              <a:t>https://github.com/sandeeep-kr/HeartDiseaseProject</a:t>
             </a:r>
           </a:p>
         </p:txBody>
@@ -14033,7 +14294,7 @@
               </a:defRPr>
             </a:pPr>
             <a:r>
-              <a:t>Evaluation Strategy</a:t>
+              <a:t>Evaluation &amp; Tuning</a:t>
             </a:r>
           </a:p>
           <a:p>
@@ -14113,7 +14374,23 @@
               </a:defRPr>
             </a:pPr>
             <a:r>
-              <a:t>• Comparison across 7 algorithms</a:t>
+              <a:t>• Hyperparameter tuning via GridSearchCV:</a:t>
+            </a:r>
+          </a:p>
+          <a:p>
+            <a:pPr algn="l">
+              <a:spcBef>
+                <a:spcPts val="200"/>
+              </a:spcBef>
+              <a:defRPr sz="1300" b="0">
+                <a:solidFill>
+                  <a:srgbClr val="5F5F5F"/>
+                </a:solidFill>
+                <a:latin typeface="Calibri"/>
+              </a:defRPr>
+            </a:pPr>
+            <a:r>
+              <a:t>  n_estimators=100 selected through systematic search</a:t>
             </a:r>
           </a:p>
         </p:txBody>
@@ -14452,7 +14729,7 @@
               </a:defRPr>
             </a:pPr>
             <a:r>
-              <a:t>Random Forest wins with 85.04% — ensemble of 100 trees reduces overfitting while handling mixed feature types.</a:t>
+              <a:t>Red line = 80% baseline. Random Forest (85.04%) — 100 trees via GridSearchCV; ensemble reduces overfitting across mixed features.</a:t>
             </a:r>
           </a:p>
         </p:txBody>

</xml_diff>

<commit_message>
Fix Live Demo slide screenshot alignment - centered 2x2 grid
</commit_message>
<xml_diff>
--- a/CardioPredict_Presentation.pptx
+++ b/CardioPredict_Presentation.pptx
@@ -5978,8 +5978,8 @@
         </p:nvSpPr>
         <p:spPr>
           <a:xfrm>
-            <a:off x="457200" y="978408"/>
-            <a:ext cx="5303520" cy="182880"/>
+            <a:off x="566928" y="1161288"/>
+            <a:ext cx="5303520" cy="164592"/>
           </a:xfrm>
           <a:prstGeom prst="rect">
             <a:avLst/>
@@ -6014,14 +6014,14 @@
         </p:nvSpPr>
         <p:spPr>
           <a:xfrm>
-            <a:off x="429768" y="1115568"/>
-            <a:ext cx="5358384" cy="2157984"/>
+            <a:off x="548640" y="1307592"/>
+            <a:ext cx="5340096" cy="2231136"/>
           </a:xfrm>
           <a:prstGeom prst="rect">
             <a:avLst/>
           </a:prstGeom>
           <a:solidFill>
-            <a:srgbClr val="CCCCCC"/>
+            <a:srgbClr val="DDDDDD"/>
           </a:solidFill>
           <a:ln w="6350">
             <a:solidFill>
@@ -6068,8 +6068,8 @@
         </p:blipFill>
         <p:spPr>
           <a:xfrm>
-            <a:off x="457200" y="1143000"/>
-            <a:ext cx="5303520" cy="2103120"/>
+            <a:off x="566928" y="1325880"/>
+            <a:ext cx="5303520" cy="2194560"/>
           </a:xfrm>
           <a:prstGeom prst="rect">
             <a:avLst/>
@@ -6084,8 +6084,8 @@
         </p:nvSpPr>
         <p:spPr>
           <a:xfrm>
-            <a:off x="6126480" y="978408"/>
-            <a:ext cx="5303520" cy="182880"/>
+            <a:off x="6327648" y="1161288"/>
+            <a:ext cx="5303520" cy="164592"/>
           </a:xfrm>
           <a:prstGeom prst="rect">
             <a:avLst/>
@@ -6120,14 +6120,14 @@
         </p:nvSpPr>
         <p:spPr>
           <a:xfrm>
-            <a:off x="6099048" y="1115568"/>
-            <a:ext cx="5358384" cy="2157984"/>
+            <a:off x="6309360" y="1307592"/>
+            <a:ext cx="5340096" cy="2231136"/>
           </a:xfrm>
           <a:prstGeom prst="rect">
             <a:avLst/>
           </a:prstGeom>
           <a:solidFill>
-            <a:srgbClr val="CCCCCC"/>
+            <a:srgbClr val="DDDDDD"/>
           </a:solidFill>
           <a:ln w="6350">
             <a:solidFill>
@@ -6174,8 +6174,8 @@
         </p:blipFill>
         <p:spPr>
           <a:xfrm>
-            <a:off x="6126480" y="1143000"/>
-            <a:ext cx="5303520" cy="2103120"/>
+            <a:off x="6327648" y="1325880"/>
+            <a:ext cx="5303520" cy="2194560"/>
           </a:xfrm>
           <a:prstGeom prst="rect">
             <a:avLst/>
@@ -6190,8 +6190,8 @@
         </p:nvSpPr>
         <p:spPr>
           <a:xfrm>
-            <a:off x="457200" y="3447288"/>
-            <a:ext cx="5303520" cy="182880"/>
+            <a:off x="566928" y="3840479"/>
+            <a:ext cx="5303520" cy="164592"/>
           </a:xfrm>
           <a:prstGeom prst="rect">
             <a:avLst/>
@@ -6226,14 +6226,14 @@
         </p:nvSpPr>
         <p:spPr>
           <a:xfrm>
-            <a:off x="429768" y="3584448"/>
-            <a:ext cx="5358384" cy="2157984"/>
+            <a:off x="548640" y="3986783"/>
+            <a:ext cx="5340096" cy="2231136"/>
           </a:xfrm>
           <a:prstGeom prst="rect">
             <a:avLst/>
           </a:prstGeom>
           <a:solidFill>
-            <a:srgbClr val="CCCCCC"/>
+            <a:srgbClr val="DDDDDD"/>
           </a:solidFill>
           <a:ln w="6350">
             <a:solidFill>
@@ -6280,8 +6280,8 @@
         </p:blipFill>
         <p:spPr>
           <a:xfrm>
-            <a:off x="457200" y="3611880"/>
-            <a:ext cx="5303520" cy="2103120"/>
+            <a:off x="566928" y="4005071"/>
+            <a:ext cx="5303520" cy="2194560"/>
           </a:xfrm>
           <a:prstGeom prst="rect">
             <a:avLst/>
@@ -6296,8 +6296,8 @@
         </p:nvSpPr>
         <p:spPr>
           <a:xfrm>
-            <a:off x="6126480" y="3447288"/>
-            <a:ext cx="5303520" cy="182880"/>
+            <a:off x="6327648" y="3840479"/>
+            <a:ext cx="5303520" cy="164592"/>
           </a:xfrm>
           <a:prstGeom prst="rect">
             <a:avLst/>
@@ -6332,14 +6332,14 @@
         </p:nvSpPr>
         <p:spPr>
           <a:xfrm>
-            <a:off x="6099048" y="3584448"/>
-            <a:ext cx="5358384" cy="2157984"/>
+            <a:off x="6309360" y="3986783"/>
+            <a:ext cx="5340096" cy="2231136"/>
           </a:xfrm>
           <a:prstGeom prst="rect">
             <a:avLst/>
           </a:prstGeom>
           <a:solidFill>
-            <a:srgbClr val="CCCCCC"/>
+            <a:srgbClr val="DDDDDD"/>
           </a:solidFill>
           <a:ln w="6350">
             <a:solidFill>
@@ -6386,8 +6386,8 @@
         </p:blipFill>
         <p:spPr>
           <a:xfrm>
-            <a:off x="6126480" y="3611880"/>
-            <a:ext cx="5303520" cy="2103120"/>
+            <a:off x="6327648" y="4005071"/>
+            <a:ext cx="5303520" cy="2194560"/>
           </a:xfrm>
           <a:prstGeom prst="rect">
             <a:avLst/>

</xml_diff>

<commit_message>
Center-align screenshot labels on Live Demo slide
</commit_message>
<xml_diff>
--- a/CardioPredict_Presentation.pptx
+++ b/CardioPredict_Presentation.pptx
@@ -5992,7 +5992,7 @@
           </a:bodyPr>
           <a:lstStyle/>
           <a:p>
-            <a:pPr algn="l">
+            <a:pPr algn="ctr">
               <a:defRPr sz="900" b="1" i="0">
                 <a:solidFill>
                   <a:srgbClr val="1F4E79"/>
@@ -6098,7 +6098,7 @@
           </a:bodyPr>
           <a:lstStyle/>
           <a:p>
-            <a:pPr algn="l">
+            <a:pPr algn="ctr">
               <a:defRPr sz="900" b="1" i="0">
                 <a:solidFill>
                   <a:srgbClr val="1F4E79"/>
@@ -6204,7 +6204,7 @@
           </a:bodyPr>
           <a:lstStyle/>
           <a:p>
-            <a:pPr algn="l">
+            <a:pPr algn="ctr">
               <a:defRPr sz="900" b="1" i="0">
                 <a:solidFill>
                   <a:srgbClr val="1F4E79"/>
@@ -6310,7 +6310,7 @@
           </a:bodyPr>
           <a:lstStyle/>
           <a:p>
-            <a:pPr algn="l">
+            <a:pPr algn="ctr">
               <a:defRPr sz="900" b="1" i="0">
                 <a:solidFill>
                   <a:srgbClr val="1F4E79"/>

</xml_diff>

<commit_message>
Fix screenshot labels: z-order fixed, labels drawn on top, visible above images
</commit_message>
<xml_diff>
--- a/CardioPredict_Presentation.pptx
+++ b/CardioPredict_Presentation.pptx
@@ -5972,50 +5972,14 @@
       </p:sp>
       <p:sp>
         <p:nvSpPr>
-          <p:cNvPr id="5" name="TextBox 4"/>
-          <p:cNvSpPr txBox="1"/>
-          <p:nvPr/>
-        </p:nvSpPr>
-        <p:spPr>
-          <a:xfrm>
-            <a:off x="566928" y="1161288"/>
-            <a:ext cx="5303520" cy="164592"/>
-          </a:xfrm>
-          <a:prstGeom prst="rect">
-            <a:avLst/>
-          </a:prstGeom>
-          <a:noFill/>
-        </p:spPr>
-        <p:txBody>
-          <a:bodyPr wrap="square">
-            <a:noAutofit/>
-          </a:bodyPr>
-          <a:lstStyle/>
-          <a:p>
-            <a:pPr algn="ctr">
-              <a:defRPr sz="900" b="1" i="0">
-                <a:solidFill>
-                  <a:srgbClr val="1F4E79"/>
-                </a:solidFill>
-                <a:latin typeface="Calibri"/>
-              </a:defRPr>
-            </a:pPr>
-            <a:r>
-              <a:t>Home Page</a:t>
-            </a:r>
-          </a:p>
-        </p:txBody>
-      </p:sp>
-      <p:sp>
-        <p:nvSpPr>
-          <p:cNvPr id="6" name="Rectangle 5"/>
+          <p:cNvPr id="5" name="Rectangle 4"/>
           <p:cNvSpPr/>
           <p:nvPr/>
         </p:nvSpPr>
         <p:spPr>
           <a:xfrm>
             <a:off x="548640" y="1307592"/>
-            <a:ext cx="5340096" cy="2231136"/>
+            <a:ext cx="5340096" cy="2048256"/>
           </a:xfrm>
           <a:prstGeom prst="rect">
             <a:avLst/>
@@ -6054,7 +6018,7 @@
       </p:sp>
       <p:pic>
         <p:nvPicPr>
-          <p:cNvPr id="7" name="Picture 6" descr="screenshot_home.png"/>
+          <p:cNvPr id="6" name="Picture 5" descr="screenshot_home.png"/>
           <p:cNvPicPr>
             <a:picLocks noChangeAspect="1"/>
           </p:cNvPicPr>
@@ -6069,7 +6033,7 @@
         <p:spPr>
           <a:xfrm>
             <a:off x="566928" y="1325880"/>
-            <a:ext cx="5303520" cy="2194560"/>
+            <a:ext cx="5303520" cy="2011680"/>
           </a:xfrm>
           <a:prstGeom prst="rect">
             <a:avLst/>
@@ -6078,50 +6042,14 @@
       </p:pic>
       <p:sp>
         <p:nvSpPr>
-          <p:cNvPr id="8" name="TextBox 7"/>
-          <p:cNvSpPr txBox="1"/>
-          <p:nvPr/>
-        </p:nvSpPr>
-        <p:spPr>
-          <a:xfrm>
-            <a:off x="6327648" y="1161288"/>
-            <a:ext cx="5303520" cy="164592"/>
-          </a:xfrm>
-          <a:prstGeom prst="rect">
-            <a:avLst/>
-          </a:prstGeom>
-          <a:noFill/>
-        </p:spPr>
-        <p:txBody>
-          <a:bodyPr wrap="square">
-            <a:noAutofit/>
-          </a:bodyPr>
-          <a:lstStyle/>
-          <a:p>
-            <a:pPr algn="ctr">
-              <a:defRPr sz="900" b="1" i="0">
-                <a:solidFill>
-                  <a:srgbClr val="1F4E79"/>
-                </a:solidFill>
-                <a:latin typeface="Calibri"/>
-              </a:defRPr>
-            </a:pPr>
-            <a:r>
-              <a:t>Prediction Result</a:t>
-            </a:r>
-          </a:p>
-        </p:txBody>
-      </p:sp>
-      <p:sp>
-        <p:nvSpPr>
-          <p:cNvPr id="9" name="Rectangle 8"/>
+          <p:cNvPr id="7" name="Rectangle 6"/>
           <p:cNvSpPr/>
           <p:nvPr/>
         </p:nvSpPr>
         <p:spPr>
           <a:xfrm>
             <a:off x="6309360" y="1307592"/>
-            <a:ext cx="5340096" cy="2231136"/>
+            <a:ext cx="5340096" cy="2048256"/>
           </a:xfrm>
           <a:prstGeom prst="rect">
             <a:avLst/>
@@ -6160,7 +6088,7 @@
       </p:sp>
       <p:pic>
         <p:nvPicPr>
-          <p:cNvPr id="10" name="Picture 9" descr="screenshot_result.png"/>
+          <p:cNvPr id="8" name="Picture 7" descr="screenshot_result.png"/>
           <p:cNvPicPr>
             <a:picLocks noChangeAspect="1"/>
           </p:cNvPicPr>
@@ -6175,7 +6103,7 @@
         <p:spPr>
           <a:xfrm>
             <a:off x="6327648" y="1325880"/>
-            <a:ext cx="5303520" cy="2194560"/>
+            <a:ext cx="5303520" cy="2011680"/>
           </a:xfrm>
           <a:prstGeom prst="rect">
             <a:avLst/>
@@ -6184,50 +6112,14 @@
       </p:pic>
       <p:sp>
         <p:nvSpPr>
-          <p:cNvPr id="11" name="TextBox 10"/>
-          <p:cNvSpPr txBox="1"/>
-          <p:nvPr/>
-        </p:nvSpPr>
-        <p:spPr>
-          <a:xfrm>
-            <a:off x="566928" y="3840479"/>
-            <a:ext cx="5303520" cy="164592"/>
-          </a:xfrm>
-          <a:prstGeom prst="rect">
-            <a:avLst/>
-          </a:prstGeom>
-          <a:noFill/>
-        </p:spPr>
-        <p:txBody>
-          <a:bodyPr wrap="square">
-            <a:noAutofit/>
-          </a:bodyPr>
-          <a:lstStyle/>
-          <a:p>
-            <a:pPr algn="ctr">
-              <a:defRPr sz="900" b="1" i="0">
-                <a:solidFill>
-                  <a:srgbClr val="1F4E79"/>
-                </a:solidFill>
-                <a:latin typeface="Calibri"/>
-              </a:defRPr>
-            </a:pPr>
-            <a:r>
-              <a:t>Prediction History</a:t>
-            </a:r>
-          </a:p>
-        </p:txBody>
-      </p:sp>
-      <p:sp>
-        <p:nvSpPr>
-          <p:cNvPr id="12" name="Rectangle 11"/>
+          <p:cNvPr id="9" name="Rectangle 8"/>
           <p:cNvSpPr/>
           <p:nvPr/>
         </p:nvSpPr>
         <p:spPr>
           <a:xfrm>
-            <a:off x="548640" y="3986783"/>
-            <a:ext cx="5340096" cy="2231136"/>
+            <a:off x="548640" y="4050792"/>
+            <a:ext cx="5340096" cy="2048256"/>
           </a:xfrm>
           <a:prstGeom prst="rect">
             <a:avLst/>
@@ -6266,7 +6158,7 @@
       </p:sp>
       <p:pic>
         <p:nvPicPr>
-          <p:cNvPr id="13" name="Picture 12" descr="screenshot_history.png"/>
+          <p:cNvPr id="10" name="Picture 9" descr="screenshot_history.png"/>
           <p:cNvPicPr>
             <a:picLocks noChangeAspect="1"/>
           </p:cNvPicPr>
@@ -6280,8 +6172,8 @@
         </p:blipFill>
         <p:spPr>
           <a:xfrm>
-            <a:off x="566928" y="4005071"/>
-            <a:ext cx="5303520" cy="2194560"/>
+            <a:off x="566928" y="4069080"/>
+            <a:ext cx="5303520" cy="2011680"/>
           </a:xfrm>
           <a:prstGeom prst="rect">
             <a:avLst/>
@@ -6290,50 +6182,14 @@
       </p:pic>
       <p:sp>
         <p:nvSpPr>
-          <p:cNvPr id="14" name="TextBox 13"/>
-          <p:cNvSpPr txBox="1"/>
-          <p:nvPr/>
-        </p:nvSpPr>
-        <p:spPr>
-          <a:xfrm>
-            <a:off x="6327648" y="3840479"/>
-            <a:ext cx="5303520" cy="164592"/>
-          </a:xfrm>
-          <a:prstGeom prst="rect">
-            <a:avLst/>
-          </a:prstGeom>
-          <a:noFill/>
-        </p:spPr>
-        <p:txBody>
-          <a:bodyPr wrap="square">
-            <a:noAutofit/>
-          </a:bodyPr>
-          <a:lstStyle/>
-          <a:p>
-            <a:pPr algn="ctr">
-              <a:defRPr sz="900" b="1" i="0">
-                <a:solidFill>
-                  <a:srgbClr val="1F4E79"/>
-                </a:solidFill>
-                <a:latin typeface="Calibri"/>
-              </a:defRPr>
-            </a:pPr>
-            <a:r>
-              <a:t>Dark Mode</a:t>
-            </a:r>
-          </a:p>
-        </p:txBody>
-      </p:sp>
-      <p:sp>
-        <p:nvSpPr>
-          <p:cNvPr id="15" name="Rectangle 14"/>
+          <p:cNvPr id="11" name="Rectangle 10"/>
           <p:cNvSpPr/>
           <p:nvPr/>
         </p:nvSpPr>
         <p:spPr>
           <a:xfrm>
-            <a:off x="6309360" y="3986783"/>
-            <a:ext cx="5340096" cy="2231136"/>
+            <a:off x="6309360" y="4050792"/>
+            <a:ext cx="5340096" cy="2048256"/>
           </a:xfrm>
           <a:prstGeom prst="rect">
             <a:avLst/>
@@ -6372,7 +6228,7 @@
       </p:sp>
       <p:pic>
         <p:nvPicPr>
-          <p:cNvPr id="16" name="Picture 15" descr="screenshot_dark.png"/>
+          <p:cNvPr id="12" name="Picture 11" descr="screenshot_dark.png"/>
           <p:cNvPicPr>
             <a:picLocks noChangeAspect="1"/>
           </p:cNvPicPr>
@@ -6386,14 +6242,158 @@
         </p:blipFill>
         <p:spPr>
           <a:xfrm>
-            <a:off x="6327648" y="4005071"/>
-            <a:ext cx="5303520" cy="2194560"/>
+            <a:off x="6327648" y="4069080"/>
+            <a:ext cx="5303520" cy="2011680"/>
           </a:xfrm>
           <a:prstGeom prst="rect">
             <a:avLst/>
           </a:prstGeom>
         </p:spPr>
       </p:pic>
+      <p:sp>
+        <p:nvSpPr>
+          <p:cNvPr id="13" name="TextBox 12"/>
+          <p:cNvSpPr txBox="1"/>
+          <p:nvPr/>
+        </p:nvSpPr>
+        <p:spPr>
+          <a:xfrm>
+            <a:off x="566928" y="1051560"/>
+            <a:ext cx="5303520" cy="228600"/>
+          </a:xfrm>
+          <a:prstGeom prst="rect">
+            <a:avLst/>
+          </a:prstGeom>
+          <a:noFill/>
+        </p:spPr>
+        <p:txBody>
+          <a:bodyPr wrap="square">
+            <a:noAutofit/>
+          </a:bodyPr>
+          <a:lstStyle/>
+          <a:p>
+            <a:pPr algn="l">
+              <a:defRPr sz="1000" b="1" i="0">
+                <a:solidFill>
+                  <a:srgbClr val="1F4E79"/>
+                </a:solidFill>
+                <a:latin typeface="Calibri"/>
+              </a:defRPr>
+            </a:pPr>
+            <a:r>
+              <a:t>Home Page</a:t>
+            </a:r>
+          </a:p>
+        </p:txBody>
+      </p:sp>
+      <p:sp>
+        <p:nvSpPr>
+          <p:cNvPr id="14" name="TextBox 13"/>
+          <p:cNvSpPr txBox="1"/>
+          <p:nvPr/>
+        </p:nvSpPr>
+        <p:spPr>
+          <a:xfrm>
+            <a:off x="6327648" y="1051560"/>
+            <a:ext cx="5303520" cy="228600"/>
+          </a:xfrm>
+          <a:prstGeom prst="rect">
+            <a:avLst/>
+          </a:prstGeom>
+          <a:noFill/>
+        </p:spPr>
+        <p:txBody>
+          <a:bodyPr wrap="square">
+            <a:noAutofit/>
+          </a:bodyPr>
+          <a:lstStyle/>
+          <a:p>
+            <a:pPr algn="l">
+              <a:defRPr sz="1000" b="1" i="0">
+                <a:solidFill>
+                  <a:srgbClr val="1F4E79"/>
+                </a:solidFill>
+                <a:latin typeface="Calibri"/>
+              </a:defRPr>
+            </a:pPr>
+            <a:r>
+              <a:t>Prediction Result</a:t>
+            </a:r>
+          </a:p>
+        </p:txBody>
+      </p:sp>
+      <p:sp>
+        <p:nvSpPr>
+          <p:cNvPr id="15" name="TextBox 14"/>
+          <p:cNvSpPr txBox="1"/>
+          <p:nvPr/>
+        </p:nvSpPr>
+        <p:spPr>
+          <a:xfrm>
+            <a:off x="566928" y="3794760"/>
+            <a:ext cx="5303520" cy="228600"/>
+          </a:xfrm>
+          <a:prstGeom prst="rect">
+            <a:avLst/>
+          </a:prstGeom>
+          <a:noFill/>
+        </p:spPr>
+        <p:txBody>
+          <a:bodyPr wrap="square">
+            <a:noAutofit/>
+          </a:bodyPr>
+          <a:lstStyle/>
+          <a:p>
+            <a:pPr algn="l">
+              <a:defRPr sz="1000" b="1" i="0">
+                <a:solidFill>
+                  <a:srgbClr val="1F4E79"/>
+                </a:solidFill>
+                <a:latin typeface="Calibri"/>
+              </a:defRPr>
+            </a:pPr>
+            <a:r>
+              <a:t>Prediction History</a:t>
+            </a:r>
+          </a:p>
+        </p:txBody>
+      </p:sp>
+      <p:sp>
+        <p:nvSpPr>
+          <p:cNvPr id="16" name="TextBox 15"/>
+          <p:cNvSpPr txBox="1"/>
+          <p:nvPr/>
+        </p:nvSpPr>
+        <p:spPr>
+          <a:xfrm>
+            <a:off x="6327648" y="3794760"/>
+            <a:ext cx="5303520" cy="228600"/>
+          </a:xfrm>
+          <a:prstGeom prst="rect">
+            <a:avLst/>
+          </a:prstGeom>
+          <a:noFill/>
+        </p:spPr>
+        <p:txBody>
+          <a:bodyPr wrap="square">
+            <a:noAutofit/>
+          </a:bodyPr>
+          <a:lstStyle/>
+          <a:p>
+            <a:pPr algn="l">
+              <a:defRPr sz="1000" b="1" i="0">
+                <a:solidFill>
+                  <a:srgbClr val="1F4E79"/>
+                </a:solidFill>
+                <a:latin typeface="Calibri"/>
+              </a:defRPr>
+            </a:pPr>
+            <a:r>
+              <a:t>Dark Mode</a:t>
+            </a:r>
+          </a:p>
+        </p:txBody>
+      </p:sp>
       <p:sp>
         <p:nvSpPr>
           <p:cNvPr id="17" name="TextBox 16"/>

</xml_diff>

<commit_message>
Fix: labels left-aligned above screenshots, visible on top
</commit_message>
<xml_diff>
--- a/CardioPredict_Presentation.pptx
+++ b/CardioPredict_Presentation.pptx
@@ -5970,55 +5970,9 @@
           </a:p>
         </p:txBody>
       </p:sp>
-      <p:sp>
-        <p:nvSpPr>
-          <p:cNvPr id="5" name="Rectangle 4"/>
-          <p:cNvSpPr/>
-          <p:nvPr/>
-        </p:nvSpPr>
-        <p:spPr>
-          <a:xfrm>
-            <a:off x="548640" y="1307592"/>
-            <a:ext cx="5340096" cy="2048256"/>
-          </a:xfrm>
-          <a:prstGeom prst="rect">
-            <a:avLst/>
-          </a:prstGeom>
-          <a:solidFill>
-            <a:srgbClr val="DDDDDD"/>
-          </a:solidFill>
-          <a:ln w="6350">
-            <a:solidFill>
-              <a:srgbClr val="DDDDDD"/>
-            </a:solidFill>
-          </a:ln>
-          <a:effectLst/>
-        </p:spPr>
-        <p:style>
-          <a:lnRef idx="1">
-            <a:schemeClr val="accent1"/>
-          </a:lnRef>
-          <a:fillRef idx="3">
-            <a:schemeClr val="accent1"/>
-          </a:fillRef>
-          <a:effectRef idx="2">
-            <a:schemeClr val="accent1"/>
-          </a:effectRef>
-          <a:fontRef idx="minor">
-            <a:schemeClr val="lt1"/>
-          </a:fontRef>
-        </p:style>
-        <p:txBody>
-          <a:bodyPr rtlCol="0" anchor="ctr"/>
-          <a:lstStyle/>
-          <a:p>
-            <a:pPr algn="ctr"/>
-          </a:p>
-        </p:txBody>
-      </p:sp>
       <p:pic>
         <p:nvPicPr>
-          <p:cNvPr id="6" name="Picture 5" descr="screenshot_home.png"/>
+          <p:cNvPr id="5" name="Picture 4" descr="screenshot_home.png"/>
           <p:cNvPicPr>
             <a:picLocks noChangeAspect="1"/>
           </p:cNvPicPr>
@@ -6032,63 +5986,17 @@
         </p:blipFill>
         <p:spPr>
           <a:xfrm>
-            <a:off x="566928" y="1325880"/>
-            <a:ext cx="5303520" cy="2011680"/>
+            <a:off x="457200" y="1280160"/>
+            <a:ext cx="5394960" cy="2103120"/>
           </a:xfrm>
           <a:prstGeom prst="rect">
             <a:avLst/>
           </a:prstGeom>
         </p:spPr>
       </p:pic>
-      <p:sp>
-        <p:nvSpPr>
-          <p:cNvPr id="7" name="Rectangle 6"/>
-          <p:cNvSpPr/>
-          <p:nvPr/>
-        </p:nvSpPr>
-        <p:spPr>
-          <a:xfrm>
-            <a:off x="6309360" y="1307592"/>
-            <a:ext cx="5340096" cy="2048256"/>
-          </a:xfrm>
-          <a:prstGeom prst="rect">
-            <a:avLst/>
-          </a:prstGeom>
-          <a:solidFill>
-            <a:srgbClr val="DDDDDD"/>
-          </a:solidFill>
-          <a:ln w="6350">
-            <a:solidFill>
-              <a:srgbClr val="DDDDDD"/>
-            </a:solidFill>
-          </a:ln>
-          <a:effectLst/>
-        </p:spPr>
-        <p:style>
-          <a:lnRef idx="1">
-            <a:schemeClr val="accent1"/>
-          </a:lnRef>
-          <a:fillRef idx="3">
-            <a:schemeClr val="accent1"/>
-          </a:fillRef>
-          <a:effectRef idx="2">
-            <a:schemeClr val="accent1"/>
-          </a:effectRef>
-          <a:fontRef idx="minor">
-            <a:schemeClr val="lt1"/>
-          </a:fontRef>
-        </p:style>
-        <p:txBody>
-          <a:bodyPr rtlCol="0" anchor="ctr"/>
-          <a:lstStyle/>
-          <a:p>
-            <a:pPr algn="ctr"/>
-          </a:p>
-        </p:txBody>
-      </p:sp>
       <p:pic>
         <p:nvPicPr>
-          <p:cNvPr id="8" name="Picture 7" descr="screenshot_result.png"/>
+          <p:cNvPr id="6" name="Picture 5" descr="screenshot_result.png"/>
           <p:cNvPicPr>
             <a:picLocks noChangeAspect="1"/>
           </p:cNvPicPr>
@@ -6102,63 +6010,17 @@
         </p:blipFill>
         <p:spPr>
           <a:xfrm>
-            <a:off x="6327648" y="1325880"/>
-            <a:ext cx="5303520" cy="2011680"/>
+            <a:off x="6035040" y="1280160"/>
+            <a:ext cx="5394960" cy="2103120"/>
           </a:xfrm>
           <a:prstGeom prst="rect">
             <a:avLst/>
           </a:prstGeom>
         </p:spPr>
       </p:pic>
-      <p:sp>
-        <p:nvSpPr>
-          <p:cNvPr id="9" name="Rectangle 8"/>
-          <p:cNvSpPr/>
-          <p:nvPr/>
-        </p:nvSpPr>
-        <p:spPr>
-          <a:xfrm>
-            <a:off x="548640" y="4050792"/>
-            <a:ext cx="5340096" cy="2048256"/>
-          </a:xfrm>
-          <a:prstGeom prst="rect">
-            <a:avLst/>
-          </a:prstGeom>
-          <a:solidFill>
-            <a:srgbClr val="DDDDDD"/>
-          </a:solidFill>
-          <a:ln w="6350">
-            <a:solidFill>
-              <a:srgbClr val="DDDDDD"/>
-            </a:solidFill>
-          </a:ln>
-          <a:effectLst/>
-        </p:spPr>
-        <p:style>
-          <a:lnRef idx="1">
-            <a:schemeClr val="accent1"/>
-          </a:lnRef>
-          <a:fillRef idx="3">
-            <a:schemeClr val="accent1"/>
-          </a:fillRef>
-          <a:effectRef idx="2">
-            <a:schemeClr val="accent1"/>
-          </a:effectRef>
-          <a:fontRef idx="minor">
-            <a:schemeClr val="lt1"/>
-          </a:fontRef>
-        </p:style>
-        <p:txBody>
-          <a:bodyPr rtlCol="0" anchor="ctr"/>
-          <a:lstStyle/>
-          <a:p>
-            <a:pPr algn="ctr"/>
-          </a:p>
-        </p:txBody>
-      </p:sp>
       <p:pic>
         <p:nvPicPr>
-          <p:cNvPr id="10" name="Picture 9" descr="screenshot_history.png"/>
+          <p:cNvPr id="7" name="Picture 6" descr="screenshot_history.png"/>
           <p:cNvPicPr>
             <a:picLocks noChangeAspect="1"/>
           </p:cNvPicPr>
@@ -6172,63 +6034,17 @@
         </p:blipFill>
         <p:spPr>
           <a:xfrm>
-            <a:off x="566928" y="4069080"/>
-            <a:ext cx="5303520" cy="2011680"/>
+            <a:off x="457200" y="3657600"/>
+            <a:ext cx="5394960" cy="2103120"/>
           </a:xfrm>
           <a:prstGeom prst="rect">
             <a:avLst/>
           </a:prstGeom>
         </p:spPr>
       </p:pic>
-      <p:sp>
-        <p:nvSpPr>
-          <p:cNvPr id="11" name="Rectangle 10"/>
-          <p:cNvSpPr/>
-          <p:nvPr/>
-        </p:nvSpPr>
-        <p:spPr>
-          <a:xfrm>
-            <a:off x="6309360" y="4050792"/>
-            <a:ext cx="5340096" cy="2048256"/>
-          </a:xfrm>
-          <a:prstGeom prst="rect">
-            <a:avLst/>
-          </a:prstGeom>
-          <a:solidFill>
-            <a:srgbClr val="DDDDDD"/>
-          </a:solidFill>
-          <a:ln w="6350">
-            <a:solidFill>
-              <a:srgbClr val="DDDDDD"/>
-            </a:solidFill>
-          </a:ln>
-          <a:effectLst/>
-        </p:spPr>
-        <p:style>
-          <a:lnRef idx="1">
-            <a:schemeClr val="accent1"/>
-          </a:lnRef>
-          <a:fillRef idx="3">
-            <a:schemeClr val="accent1"/>
-          </a:fillRef>
-          <a:effectRef idx="2">
-            <a:schemeClr val="accent1"/>
-          </a:effectRef>
-          <a:fontRef idx="minor">
-            <a:schemeClr val="lt1"/>
-          </a:fontRef>
-        </p:style>
-        <p:txBody>
-          <a:bodyPr rtlCol="0" anchor="ctr"/>
-          <a:lstStyle/>
-          <a:p>
-            <a:pPr algn="ctr"/>
-          </a:p>
-        </p:txBody>
-      </p:sp>
       <p:pic>
         <p:nvPicPr>
-          <p:cNvPr id="12" name="Picture 11" descr="screenshot_dark.png"/>
+          <p:cNvPr id="8" name="Picture 7" descr="screenshot_dark.png"/>
           <p:cNvPicPr>
             <a:picLocks noChangeAspect="1"/>
           </p:cNvPicPr>
@@ -6242,8 +6058,8 @@
         </p:blipFill>
         <p:spPr>
           <a:xfrm>
-            <a:off x="6327648" y="4069080"/>
-            <a:ext cx="5303520" cy="2011680"/>
+            <a:off x="6035040" y="3657600"/>
+            <a:ext cx="5394960" cy="2103120"/>
           </a:xfrm>
           <a:prstGeom prst="rect">
             <a:avLst/>
@@ -6252,14 +6068,14 @@
       </p:pic>
       <p:sp>
         <p:nvSpPr>
-          <p:cNvPr id="13" name="TextBox 12"/>
+          <p:cNvPr id="9" name="TextBox 8"/>
           <p:cNvSpPr txBox="1"/>
           <p:nvPr/>
         </p:nvSpPr>
         <p:spPr>
           <a:xfrm>
-            <a:off x="566928" y="1051560"/>
-            <a:ext cx="5303520" cy="228600"/>
+            <a:off x="457200" y="1051560"/>
+            <a:ext cx="5394960" cy="228600"/>
           </a:xfrm>
           <a:prstGeom prst="rect">
             <a:avLst/>
@@ -6288,14 +6104,14 @@
       </p:sp>
       <p:sp>
         <p:nvSpPr>
-          <p:cNvPr id="14" name="TextBox 13"/>
+          <p:cNvPr id="10" name="TextBox 9"/>
           <p:cNvSpPr txBox="1"/>
           <p:nvPr/>
         </p:nvSpPr>
         <p:spPr>
           <a:xfrm>
-            <a:off x="6327648" y="1051560"/>
-            <a:ext cx="5303520" cy="228600"/>
+            <a:off x="6035040" y="1051560"/>
+            <a:ext cx="5394960" cy="228600"/>
           </a:xfrm>
           <a:prstGeom prst="rect">
             <a:avLst/>
@@ -6324,14 +6140,14 @@
       </p:sp>
       <p:sp>
         <p:nvSpPr>
-          <p:cNvPr id="15" name="TextBox 14"/>
+          <p:cNvPr id="11" name="TextBox 10"/>
           <p:cNvSpPr txBox="1"/>
           <p:nvPr/>
         </p:nvSpPr>
         <p:spPr>
           <a:xfrm>
-            <a:off x="566928" y="3794760"/>
-            <a:ext cx="5303520" cy="228600"/>
+            <a:off x="457200" y="3429000"/>
+            <a:ext cx="5394960" cy="228600"/>
           </a:xfrm>
           <a:prstGeom prst="rect">
             <a:avLst/>
@@ -6360,14 +6176,14 @@
       </p:sp>
       <p:sp>
         <p:nvSpPr>
-          <p:cNvPr id="16" name="TextBox 15"/>
+          <p:cNvPr id="12" name="TextBox 11"/>
           <p:cNvSpPr txBox="1"/>
           <p:nvPr/>
         </p:nvSpPr>
         <p:spPr>
           <a:xfrm>
-            <a:off x="6327648" y="3794760"/>
-            <a:ext cx="5303520" cy="228600"/>
+            <a:off x="6035040" y="3429000"/>
+            <a:ext cx="5394960" cy="228600"/>
           </a:xfrm>
           <a:prstGeom prst="rect">
             <a:avLst/>
@@ -6396,7 +6212,7 @@
       </p:sp>
       <p:sp>
         <p:nvSpPr>
-          <p:cNvPr id="17" name="TextBox 16"/>
+          <p:cNvPr id="13" name="TextBox 12"/>
           <p:cNvSpPr txBox="1"/>
           <p:nvPr/>
         </p:nvSpPr>
@@ -6432,7 +6248,7 @@
       </p:sp>
       <p:sp>
         <p:nvSpPr>
-          <p:cNvPr id="18" name="Rectangle 17"/>
+          <p:cNvPr id="14" name="Rectangle 13"/>
           <p:cNvSpPr/>
           <p:nvPr/>
         </p:nvSpPr>

</xml_diff>